<commit_message>
feat: add footnote citations across all 43 slides, remove slide 44, add dual presenters (Quarta / Quinta), and align Nexus metrics with 2025/2026 report
</commit_message>
<xml_diff>
--- a/Seminario_5_Ecossistemas_Inovacao_Master.pptx
+++ b/Seminario_5_Ecossistemas_Inovacao_Master.pptx
@@ -48,7 +48,6 @@
     <p:sldId id="296" r:id="rId48"/>
     <p:sldId id="297" r:id="rId49"/>
     <p:sldId id="298" r:id="rId50"/>
-    <p:sldId id="299" r:id="rId51"/>
   </p:sldIdLst>
   <p:sldSz cx="12191695" cy="6858000" type="screen4x3"/>
   <p:notesSz cx="6858000" cy="9144000"/>
@@ -7267,6 +7266,49 @@
           </a:p>
         </p:txBody>
       </p:sp>
+      <p:sp>
+        <p:nvSpPr>
+          <p:cNvPr id="6" name="TextBox 5"/>
+          <p:cNvSpPr txBox="1"/>
+          <p:nvPr/>
+        </p:nvSpPr>
+        <p:spPr>
+          <a:xfrm>
+            <a:off x="731520" y="6309360"/>
+            <a:ext cx="10728655" cy="411480"/>
+          </a:xfrm>
+          <a:prstGeom prst="rect">
+            <a:avLst/>
+          </a:prstGeom>
+          <a:noFill/>
+        </p:spPr>
+        <p:txBody>
+          <a:bodyPr wrap="square">
+            <a:spAutoFit/>
+          </a:bodyPr>
+          <a:lstStyle/>
+          <a:p>
+            <a:r>
+              <a:rPr sz="850" b="1">
+                <a:solidFill>
+                  <a:srgbClr val="3FD0E6"/>
+                </a:solidFill>
+                <a:latin typeface="JetBrains Mono"/>
+              </a:rPr>
+              <a:t>🎤 Josué Jofre (4ª) / Fernando Barreto (5ª)   |   </a:t>
+            </a:r>
+            <a:r>
+              <a:rPr sz="850">
+                <a:solidFill>
+                  <a:srgbClr val="94A3B8"/>
+                </a:solidFill>
+                <a:latin typeface="JetBrains Mono"/>
+              </a:rPr>
+              <a:t>📚 Fonte / Ref:  Seminário 5: Ecossistemas de Inovação • GETI 2026 / PPG-PIT UNIFESP Campus Parque Tecnológico SJC.</a:t>
+            </a:r>
+          </a:p>
+        </p:txBody>
+      </p:sp>
     </p:spTree>
   </p:cSld>
   <p:clrMapOvr>
@@ -7526,6 +7568,49 @@
           </a:p>
         </p:txBody>
       </p:sp>
+      <p:sp>
+        <p:nvSpPr>
+          <p:cNvPr id="6" name="TextBox 5"/>
+          <p:cNvSpPr txBox="1"/>
+          <p:nvPr/>
+        </p:nvSpPr>
+        <p:spPr>
+          <a:xfrm>
+            <a:off x="731520" y="6309360"/>
+            <a:ext cx="10728655" cy="411480"/>
+          </a:xfrm>
+          <a:prstGeom prst="rect">
+            <a:avLst/>
+          </a:prstGeom>
+          <a:noFill/>
+        </p:spPr>
+        <p:txBody>
+          <a:bodyPr wrap="square">
+            <a:spAutoFit/>
+          </a:bodyPr>
+          <a:lstStyle/>
+          <a:p>
+            <a:r>
+              <a:rPr sz="850" b="1">
+                <a:solidFill>
+                  <a:srgbClr val="3FD0E6"/>
+                </a:solidFill>
+                <a:latin typeface="JetBrains Mono"/>
+              </a:rPr>
+              <a:t>🎤 Veridiany Braga (4ª) / Fábio Lippi (5ª)   |   </a:t>
+            </a:r>
+            <a:r>
+              <a:rPr sz="850">
+                <a:solidFill>
+                  <a:srgbClr val="94A3B8"/>
+                </a:solidFill>
+                <a:latin typeface="JetBrains Mono"/>
+              </a:rPr>
+              <a:t>📚 Fonte / Ref:  Adner, R. (2006; 2012). Match Your Innovation Strategy to Your Innovation Ecosystem / The Wide Lens. Portfolio/Penguin.</a:t>
+            </a:r>
+          </a:p>
+        </p:txBody>
+      </p:sp>
     </p:spTree>
   </p:cSld>
   <p:clrMapOvr>
@@ -7785,6 +7870,49 @@
           </a:p>
         </p:txBody>
       </p:sp>
+      <p:sp>
+        <p:nvSpPr>
+          <p:cNvPr id="6" name="TextBox 5"/>
+          <p:cNvSpPr txBox="1"/>
+          <p:nvPr/>
+        </p:nvSpPr>
+        <p:spPr>
+          <a:xfrm>
+            <a:off x="731520" y="6309360"/>
+            <a:ext cx="10728655" cy="411480"/>
+          </a:xfrm>
+          <a:prstGeom prst="rect">
+            <a:avLst/>
+          </a:prstGeom>
+          <a:noFill/>
+        </p:spPr>
+        <p:txBody>
+          <a:bodyPr wrap="square">
+            <a:spAutoFit/>
+          </a:bodyPr>
+          <a:lstStyle/>
+          <a:p>
+            <a:r>
+              <a:rPr sz="850" b="1">
+                <a:solidFill>
+                  <a:srgbClr val="3FD0E6"/>
+                </a:solidFill>
+                <a:latin typeface="JetBrains Mono"/>
+              </a:rPr>
+              <a:t>🎤 Veridiany Braga (4ª) / Fábio Lippi (5ª)   |   </a:t>
+            </a:r>
+            <a:r>
+              <a:rPr sz="850">
+                <a:solidFill>
+                  <a:srgbClr val="94A3B8"/>
+                </a:solidFill>
+                <a:latin typeface="JetBrains Mono"/>
+              </a:rPr>
+              <a:t>📚 Fonte / Ref:  Avaliação Formativa Síncrona • Banco de Questões GETI 2026 baseado em Adner (2006) e Carayannis &amp; Campbell (2012).</a:t>
+            </a:r>
+          </a:p>
+        </p:txBody>
+      </p:sp>
     </p:spTree>
   </p:cSld>
   <p:clrMapOvr>
@@ -7905,6 +8033,49 @@
           </a:prstGeom>
         </p:spPr>
       </p:pic>
+      <p:sp>
+        <p:nvSpPr>
+          <p:cNvPr id="5" name="TextBox 4"/>
+          <p:cNvSpPr txBox="1"/>
+          <p:nvPr/>
+        </p:nvSpPr>
+        <p:spPr>
+          <a:xfrm>
+            <a:off x="731520" y="6309360"/>
+            <a:ext cx="10728655" cy="411480"/>
+          </a:xfrm>
+          <a:prstGeom prst="rect">
+            <a:avLst/>
+          </a:prstGeom>
+          <a:noFill/>
+        </p:spPr>
+        <p:txBody>
+          <a:bodyPr wrap="square">
+            <a:spAutoFit/>
+          </a:bodyPr>
+          <a:lstStyle/>
+          <a:p>
+            <a:r>
+              <a:rPr sz="850" b="1">
+                <a:solidFill>
+                  <a:srgbClr val="3FD0E6"/>
+                </a:solidFill>
+                <a:latin typeface="JetBrains Mono"/>
+              </a:rPr>
+              <a:t>🎤 Jéssica David (4ª) / Fernando Barreto (5ª)   |   </a:t>
+            </a:r>
+            <a:r>
+              <a:rPr sz="850">
+                <a:solidFill>
+                  <a:srgbClr val="94A3B8"/>
+                </a:solidFill>
+                <a:latin typeface="JetBrains Mono"/>
+              </a:rPr>
+              <a:t>📚 Fonte / Ref:  Machado, C. G., Faccin, K., &amp; Bitencourt, C. C. (2025). Orchestration competence in innovation ecosystems. Innovation &amp; Management Review.</a:t>
+            </a:r>
+          </a:p>
+        </p:txBody>
+      </p:sp>
     </p:spTree>
   </p:cSld>
   <p:clrMapOvr>
@@ -8025,6 +8196,49 @@
           </a:prstGeom>
         </p:spPr>
       </p:pic>
+      <p:sp>
+        <p:nvSpPr>
+          <p:cNvPr id="5" name="TextBox 4"/>
+          <p:cNvSpPr txBox="1"/>
+          <p:nvPr/>
+        </p:nvSpPr>
+        <p:spPr>
+          <a:xfrm>
+            <a:off x="731520" y="6309360"/>
+            <a:ext cx="10728655" cy="411480"/>
+          </a:xfrm>
+          <a:prstGeom prst="rect">
+            <a:avLst/>
+          </a:prstGeom>
+          <a:noFill/>
+        </p:spPr>
+        <p:txBody>
+          <a:bodyPr wrap="square">
+            <a:spAutoFit/>
+          </a:bodyPr>
+          <a:lstStyle/>
+          <a:p>
+            <a:r>
+              <a:rPr sz="850" b="1">
+                <a:solidFill>
+                  <a:srgbClr val="3FD0E6"/>
+                </a:solidFill>
+                <a:latin typeface="JetBrains Mono"/>
+              </a:rPr>
+              <a:t>🎤 Jéssica David (4ª) / Fernando Barreto (5ª)   |   </a:t>
+            </a:r>
+            <a:r>
+              <a:rPr sz="850">
+                <a:solidFill>
+                  <a:srgbClr val="94A3B8"/>
+                </a:solidFill>
+                <a:latin typeface="JetBrains Mono"/>
+              </a:rPr>
+              <a:t>📚 Fonte / Ref:  Dhanaraj, C. &amp; Parkhe, A. (2006). Orchestrating innovation networks. AMR; Machado, Faccin &amp; Bitencourt (2025).</a:t>
+            </a:r>
+          </a:p>
+        </p:txBody>
+      </p:sp>
     </p:spTree>
   </p:cSld>
   <p:clrMapOvr>
@@ -8240,6 +8454,49 @@
           </a:p>
         </p:txBody>
       </p:sp>
+      <p:sp>
+        <p:nvSpPr>
+          <p:cNvPr id="5" name="TextBox 4"/>
+          <p:cNvSpPr txBox="1"/>
+          <p:nvPr/>
+        </p:nvSpPr>
+        <p:spPr>
+          <a:xfrm>
+            <a:off x="731520" y="6309360"/>
+            <a:ext cx="10728655" cy="411480"/>
+          </a:xfrm>
+          <a:prstGeom prst="rect">
+            <a:avLst/>
+          </a:prstGeom>
+          <a:noFill/>
+        </p:spPr>
+        <p:txBody>
+          <a:bodyPr wrap="square">
+            <a:spAutoFit/>
+          </a:bodyPr>
+          <a:lstStyle/>
+          <a:p>
+            <a:r>
+              <a:rPr sz="850" b="1">
+                <a:solidFill>
+                  <a:srgbClr val="3FD0E6"/>
+                </a:solidFill>
+                <a:latin typeface="JetBrains Mono"/>
+              </a:rPr>
+              <a:t>🎤 Jéssica David (4ª) / Fernando Barreto (5ª)   |   </a:t>
+            </a:r>
+            <a:r>
+              <a:rPr sz="850">
+                <a:solidFill>
+                  <a:srgbClr val="94A3B8"/>
+                </a:solidFill>
+                <a:latin typeface="JetBrains Mono"/>
+              </a:rPr>
+              <a:t>📚 Fonte / Ref:  Hurmelinna-Laukkanen et al. (2011); Da Silva &amp; Bitencourt (2019); Mignoni et al. (2021); Machado et al. (2025).</a:t>
+            </a:r>
+          </a:p>
+        </p:txBody>
+      </p:sp>
     </p:spTree>
   </p:cSld>
   <p:clrMapOvr>
@@ -8360,6 +8617,49 @@
           </a:prstGeom>
         </p:spPr>
       </p:pic>
+      <p:sp>
+        <p:nvSpPr>
+          <p:cNvPr id="5" name="TextBox 4"/>
+          <p:cNvSpPr txBox="1"/>
+          <p:nvPr/>
+        </p:nvSpPr>
+        <p:spPr>
+          <a:xfrm>
+            <a:off x="731520" y="6309360"/>
+            <a:ext cx="10728655" cy="411480"/>
+          </a:xfrm>
+          <a:prstGeom prst="rect">
+            <a:avLst/>
+          </a:prstGeom>
+          <a:noFill/>
+        </p:spPr>
+        <p:txBody>
+          <a:bodyPr wrap="square">
+            <a:spAutoFit/>
+          </a:bodyPr>
+          <a:lstStyle/>
+          <a:p>
+            <a:r>
+              <a:rPr sz="850" b="1">
+                <a:solidFill>
+                  <a:srgbClr val="3FD0E6"/>
+                </a:solidFill>
+                <a:latin typeface="JetBrains Mono"/>
+              </a:rPr>
+              <a:t>🎤 Jéssica David (4ª) / Fernando Barreto (5ª)   |   </a:t>
+            </a:r>
+            <a:r>
+              <a:rPr sz="850">
+                <a:solidFill>
+                  <a:srgbClr val="94A3B8"/>
+                </a:solidFill>
+                <a:latin typeface="JetBrains Mono"/>
+              </a:rPr>
+              <a:t>📚 Fonte / Ref:  Machado, C. G., Faccin, K., &amp; Bitencourt, C. C. (2025). Tabela 1 e 2: Mecanismos de Direção, Mobilização e Estabilização.</a:t>
+            </a:r>
+          </a:p>
+        </p:txBody>
+      </p:sp>
     </p:spTree>
   </p:cSld>
   <p:clrMapOvr>
@@ -8480,6 +8780,49 @@
           </a:prstGeom>
         </p:spPr>
       </p:pic>
+      <p:sp>
+        <p:nvSpPr>
+          <p:cNvPr id="5" name="TextBox 4"/>
+          <p:cNvSpPr txBox="1"/>
+          <p:nvPr/>
+        </p:nvSpPr>
+        <p:spPr>
+          <a:xfrm>
+            <a:off x="731520" y="6309360"/>
+            <a:ext cx="10728655" cy="411480"/>
+          </a:xfrm>
+          <a:prstGeom prst="rect">
+            <a:avLst/>
+          </a:prstGeom>
+          <a:noFill/>
+        </p:spPr>
+        <p:txBody>
+          <a:bodyPr wrap="square">
+            <a:spAutoFit/>
+          </a:bodyPr>
+          <a:lstStyle/>
+          <a:p>
+            <a:r>
+              <a:rPr sz="850" b="1">
+                <a:solidFill>
+                  <a:srgbClr val="3FD0E6"/>
+                </a:solidFill>
+                <a:latin typeface="JetBrains Mono"/>
+              </a:rPr>
+              <a:t>🎤 Jéssica David (4ª) / Fernando Barreto (5ª)   |   </a:t>
+            </a:r>
+            <a:r>
+              <a:rPr sz="850">
+                <a:solidFill>
+                  <a:srgbClr val="94A3B8"/>
+                </a:solidFill>
+                <a:latin typeface="JetBrains Mono"/>
+              </a:rPr>
+              <a:t>📚 Fonte / Ref:  Machado, C. G., Faccin, K., &amp; Bitencourt, C. C. (2025). Mecanismos de Compartilhamento, Coordenação e Gestão da Comunicação.</a:t>
+            </a:r>
+          </a:p>
+        </p:txBody>
+      </p:sp>
     </p:spTree>
   </p:cSld>
   <p:clrMapOvr>
@@ -8600,6 +8943,49 @@
           </a:prstGeom>
         </p:spPr>
       </p:pic>
+      <p:sp>
+        <p:nvSpPr>
+          <p:cNvPr id="5" name="TextBox 4"/>
+          <p:cNvSpPr txBox="1"/>
+          <p:nvPr/>
+        </p:nvSpPr>
+        <p:spPr>
+          <a:xfrm>
+            <a:off x="731520" y="6309360"/>
+            <a:ext cx="10728655" cy="411480"/>
+          </a:xfrm>
+          <a:prstGeom prst="rect">
+            <a:avLst/>
+          </a:prstGeom>
+          <a:noFill/>
+        </p:spPr>
+        <p:txBody>
+          <a:bodyPr wrap="square">
+            <a:spAutoFit/>
+          </a:bodyPr>
+          <a:lstStyle/>
+          <a:p>
+            <a:r>
+              <a:rPr sz="850" b="1">
+                <a:solidFill>
+                  <a:srgbClr val="3FD0E6"/>
+                </a:solidFill>
+                <a:latin typeface="JetBrains Mono"/>
+              </a:rPr>
+              <a:t>🎤 Jéssica David (4ª) / Fernando Barreto (5ª)   |   </a:t>
+            </a:r>
+            <a:r>
+              <a:rPr sz="850">
+                <a:solidFill>
+                  <a:srgbClr val="94A3B8"/>
+                </a:solidFill>
+                <a:latin typeface="JetBrains Mono"/>
+              </a:rPr>
+              <a:t>📚 Fonte / Ref:  Dutra, J. S. (2004). Gestão por competências; Fleury &amp; Fleury (2001); Machado, Faccin &amp; Bitencourt (2025).</a:t>
+            </a:r>
+          </a:p>
+        </p:txBody>
+      </p:sp>
     </p:spTree>
   </p:cSld>
   <p:clrMapOvr>
@@ -8720,6 +9106,49 @@
           </a:prstGeom>
         </p:spPr>
       </p:pic>
+      <p:sp>
+        <p:nvSpPr>
+          <p:cNvPr id="5" name="TextBox 4"/>
+          <p:cNvSpPr txBox="1"/>
+          <p:nvPr/>
+        </p:nvSpPr>
+        <p:spPr>
+          <a:xfrm>
+            <a:off x="731520" y="6309360"/>
+            <a:ext cx="10728655" cy="411480"/>
+          </a:xfrm>
+          <a:prstGeom prst="rect">
+            <a:avLst/>
+          </a:prstGeom>
+          <a:noFill/>
+        </p:spPr>
+        <p:txBody>
+          <a:bodyPr wrap="square">
+            <a:spAutoFit/>
+          </a:bodyPr>
+          <a:lstStyle/>
+          <a:p>
+            <a:r>
+              <a:rPr sz="850" b="1">
+                <a:solidFill>
+                  <a:srgbClr val="3FD0E6"/>
+                </a:solidFill>
+                <a:latin typeface="JetBrains Mono"/>
+              </a:rPr>
+              <a:t>🎤 Jéssica David (4ª) / Fernando Barreto (5ª)   |   </a:t>
+            </a:r>
+            <a:r>
+              <a:rPr sz="850">
+                <a:solidFill>
+                  <a:srgbClr val="94A3B8"/>
+                </a:solidFill>
+                <a:latin typeface="JetBrains Mono"/>
+              </a:rPr>
+              <a:t>📚 Fonte / Ref:  Machado, C. G., Faccin, K., &amp; Bitencourt, C. C. (2025). Framework Integrado de Competências de Orquestração.</a:t>
+            </a:r>
+          </a:p>
+        </p:txBody>
+      </p:sp>
     </p:spTree>
   </p:cSld>
   <p:clrMapOvr>
@@ -8979,6 +9408,49 @@
           </a:p>
         </p:txBody>
       </p:sp>
+      <p:sp>
+        <p:nvSpPr>
+          <p:cNvPr id="6" name="TextBox 5"/>
+          <p:cNvSpPr txBox="1"/>
+          <p:nvPr/>
+        </p:nvSpPr>
+        <p:spPr>
+          <a:xfrm>
+            <a:off x="731520" y="6309360"/>
+            <a:ext cx="10728655" cy="411480"/>
+          </a:xfrm>
+          <a:prstGeom prst="rect">
+            <a:avLst/>
+          </a:prstGeom>
+          <a:noFill/>
+        </p:spPr>
+        <p:txBody>
+          <a:bodyPr wrap="square">
+            <a:spAutoFit/>
+          </a:bodyPr>
+          <a:lstStyle/>
+          <a:p>
+            <a:r>
+              <a:rPr sz="850" b="1">
+                <a:solidFill>
+                  <a:srgbClr val="3FD0E6"/>
+                </a:solidFill>
+                <a:latin typeface="JetBrains Mono"/>
+              </a:rPr>
+              <a:t>🎤 Jéssica David (4ª) / Fernando Barreto (5ª)   |   </a:t>
+            </a:r>
+            <a:r>
+              <a:rPr sz="850">
+                <a:solidFill>
+                  <a:srgbClr val="94A3B8"/>
+                </a:solidFill>
+                <a:latin typeface="JetBrains Mono"/>
+              </a:rPr>
+              <a:t>📚 Fonte / Ref:  Avaliação Formativa Síncrona • Banco de Questões GETI 2026 baseado em Machado, Faccin &amp; Bitencourt (2025).</a:t>
+            </a:r>
+          </a:p>
+        </p:txBody>
+      </p:sp>
     </p:spTree>
   </p:cSld>
   <p:clrMapOvr>
@@ -9238,6 +9710,49 @@
           </a:p>
         </p:txBody>
       </p:sp>
+      <p:sp>
+        <p:nvSpPr>
+          <p:cNvPr id="6" name="TextBox 5"/>
+          <p:cNvSpPr txBox="1"/>
+          <p:nvPr/>
+        </p:nvSpPr>
+        <p:spPr>
+          <a:xfrm>
+            <a:off x="731520" y="6309360"/>
+            <a:ext cx="10728655" cy="411480"/>
+          </a:xfrm>
+          <a:prstGeom prst="rect">
+            <a:avLst/>
+          </a:prstGeom>
+          <a:noFill/>
+        </p:spPr>
+        <p:txBody>
+          <a:bodyPr wrap="square">
+            <a:spAutoFit/>
+          </a:bodyPr>
+          <a:lstStyle/>
+          <a:p>
+            <a:r>
+              <a:rPr sz="850" b="1">
+                <a:solidFill>
+                  <a:srgbClr val="3FD0E6"/>
+                </a:solidFill>
+                <a:latin typeface="JetBrains Mono"/>
+              </a:rPr>
+              <a:t>🎤 Nathalia Neves (4ª) / Fernando Barreto (5ª)   |   </a:t>
+            </a:r>
+            <a:r>
+              <a:rPr sz="850">
+                <a:solidFill>
+                  <a:srgbClr val="94A3B8"/>
+                </a:solidFill>
+                <a:latin typeface="JetBrains Mono"/>
+              </a:rPr>
+              <a:t>📚 Fonte / Ref:  Estrutura Baseada em Moore (1993), Etzkowitz (2000), Machado et al. (2025), Furr &amp; Shipilov (2018), Majava &amp; Rinkinen (2026) e Shen et al. (2026).</a:t>
+            </a:r>
+          </a:p>
+        </p:txBody>
+      </p:sp>
     </p:spTree>
   </p:cSld>
   <p:clrMapOvr>
@@ -9497,6 +10012,49 @@
           </a:p>
         </p:txBody>
       </p:sp>
+      <p:sp>
+        <p:nvSpPr>
+          <p:cNvPr id="6" name="TextBox 5"/>
+          <p:cNvSpPr txBox="1"/>
+          <p:nvPr/>
+        </p:nvSpPr>
+        <p:spPr>
+          <a:xfrm>
+            <a:off x="731520" y="6309360"/>
+            <a:ext cx="10728655" cy="411480"/>
+          </a:xfrm>
+          <a:prstGeom prst="rect">
+            <a:avLst/>
+          </a:prstGeom>
+          <a:noFill/>
+        </p:spPr>
+        <p:txBody>
+          <a:bodyPr wrap="square">
+            <a:spAutoFit/>
+          </a:bodyPr>
+          <a:lstStyle/>
+          <a:p>
+            <a:r>
+              <a:rPr sz="850" b="1">
+                <a:solidFill>
+                  <a:srgbClr val="3FD0E6"/>
+                </a:solidFill>
+                <a:latin typeface="JetBrains Mono"/>
+              </a:rPr>
+              <a:t>🎤 Josué Jofre (4ª) / Marciele Toledo (5ª)   |   </a:t>
+            </a:r>
+            <a:r>
+              <a:rPr sz="850">
+                <a:solidFill>
+                  <a:srgbClr val="94A3B8"/>
+                </a:solidFill>
+                <a:latin typeface="JetBrains Mono"/>
+              </a:rPr>
+              <a:t>📚 Fonte / Ref:  Furr, N. &amp; Shipilov, A. (2018). Building the Right Ecosystem for Innovation. MIT Sloan Management Review, 59(4), 59-64.</a:t>
+            </a:r>
+          </a:p>
+        </p:txBody>
+      </p:sp>
     </p:spTree>
   </p:cSld>
   <p:clrMapOvr>
@@ -9756,6 +10314,49 @@
           </a:p>
         </p:txBody>
       </p:sp>
+      <p:sp>
+        <p:nvSpPr>
+          <p:cNvPr id="6" name="TextBox 5"/>
+          <p:cNvSpPr txBox="1"/>
+          <p:nvPr/>
+        </p:nvSpPr>
+        <p:spPr>
+          <a:xfrm>
+            <a:off x="731520" y="6309360"/>
+            <a:ext cx="10728655" cy="411480"/>
+          </a:xfrm>
+          <a:prstGeom prst="rect">
+            <a:avLst/>
+          </a:prstGeom>
+          <a:noFill/>
+        </p:spPr>
+        <p:txBody>
+          <a:bodyPr wrap="square">
+            <a:spAutoFit/>
+          </a:bodyPr>
+          <a:lstStyle/>
+          <a:p>
+            <a:r>
+              <a:rPr sz="850" b="1">
+                <a:solidFill>
+                  <a:srgbClr val="3FD0E6"/>
+                </a:solidFill>
+                <a:latin typeface="JetBrains Mono"/>
+              </a:rPr>
+              <a:t>🎤 Josué Jofre (4ª) / Marciele Toledo (5ª)   |   </a:t>
+            </a:r>
+            <a:r>
+              <a:rPr sz="850">
+                <a:solidFill>
+                  <a:srgbClr val="94A3B8"/>
+                </a:solidFill>
+                <a:latin typeface="JetBrains Mono"/>
+              </a:rPr>
+              <a:t>📚 Fonte / Ref:  APTSJC (2025). Relatório Anual de Atividades 2025; Nexus Hub de Inovação do Parque Tecnológico de São José dos Campos.</a:t>
+            </a:r>
+          </a:p>
+        </p:txBody>
+      </p:sp>
     </p:spTree>
   </p:cSld>
   <p:clrMapOvr>
@@ -10015,6 +10616,49 @@
           </a:p>
         </p:txBody>
       </p:sp>
+      <p:sp>
+        <p:nvSpPr>
+          <p:cNvPr id="6" name="TextBox 5"/>
+          <p:cNvSpPr txBox="1"/>
+          <p:nvPr/>
+        </p:nvSpPr>
+        <p:spPr>
+          <a:xfrm>
+            <a:off x="731520" y="6309360"/>
+            <a:ext cx="10728655" cy="411480"/>
+          </a:xfrm>
+          <a:prstGeom prst="rect">
+            <a:avLst/>
+          </a:prstGeom>
+          <a:noFill/>
+        </p:spPr>
+        <p:txBody>
+          <a:bodyPr wrap="square">
+            <a:spAutoFit/>
+          </a:bodyPr>
+          <a:lstStyle/>
+          <a:p>
+            <a:r>
+              <a:rPr sz="850" b="1">
+                <a:solidFill>
+                  <a:srgbClr val="3FD0E6"/>
+                </a:solidFill>
+                <a:latin typeface="JetBrains Mono"/>
+              </a:rPr>
+              <a:t>🎤 Josué Jofre (4ª) / Marciele Toledo (5ª)   |   </a:t>
+            </a:r>
+            <a:r>
+              <a:rPr sz="850">
+                <a:solidFill>
+                  <a:srgbClr val="94A3B8"/>
+                </a:solidFill>
+                <a:latin typeface="JetBrains Mono"/>
+              </a:rPr>
+              <a:t>📚 Fonte / Ref:  Heifetz, R., Grashow, A., &amp; Linsky, M. (2009). The Practice of Adaptive Leadership. Harvard Business Press; Furr &amp; Shipilov (2018).</a:t>
+            </a:r>
+          </a:p>
+        </p:txBody>
+      </p:sp>
     </p:spTree>
   </p:cSld>
   <p:clrMapOvr>
@@ -10274,6 +10918,49 @@
           </a:p>
         </p:txBody>
       </p:sp>
+      <p:sp>
+        <p:nvSpPr>
+          <p:cNvPr id="6" name="TextBox 5"/>
+          <p:cNvSpPr txBox="1"/>
+          <p:nvPr/>
+        </p:nvSpPr>
+        <p:spPr>
+          <a:xfrm>
+            <a:off x="731520" y="6309360"/>
+            <a:ext cx="10728655" cy="411480"/>
+          </a:xfrm>
+          <a:prstGeom prst="rect">
+            <a:avLst/>
+          </a:prstGeom>
+          <a:noFill/>
+        </p:spPr>
+        <p:txBody>
+          <a:bodyPr wrap="square">
+            <a:spAutoFit/>
+          </a:bodyPr>
+          <a:lstStyle/>
+          <a:p>
+            <a:r>
+              <a:rPr sz="850" b="1">
+                <a:solidFill>
+                  <a:srgbClr val="3FD0E6"/>
+                </a:solidFill>
+                <a:latin typeface="JetBrains Mono"/>
+              </a:rPr>
+              <a:t>🎤 Josué Jofre (4ª) / Marciele Toledo (5ª)   |   </a:t>
+            </a:r>
+            <a:r>
+              <a:rPr sz="850">
+                <a:solidFill>
+                  <a:srgbClr val="94A3B8"/>
+                </a:solidFill>
+                <a:latin typeface="JetBrains Mono"/>
+              </a:rPr>
+              <a:t>📚 Fonte / Ref:  Avaliação Formativa Síncrona • Banco de Questões GETI 2026 baseado em Furr &amp; Shipilov (2018).</a:t>
+            </a:r>
+          </a:p>
+        </p:txBody>
+      </p:sp>
     </p:spTree>
   </p:cSld>
   <p:clrMapOvr>
@@ -10462,6 +11149,49 @@
           </a:prstGeom>
         </p:spPr>
       </p:pic>
+      <p:sp>
+        <p:nvSpPr>
+          <p:cNvPr id="7" name="TextBox 6"/>
+          <p:cNvSpPr txBox="1"/>
+          <p:nvPr/>
+        </p:nvSpPr>
+        <p:spPr>
+          <a:xfrm>
+            <a:off x="731520" y="6309360"/>
+            <a:ext cx="10728655" cy="411480"/>
+          </a:xfrm>
+          <a:prstGeom prst="rect">
+            <a:avLst/>
+          </a:prstGeom>
+          <a:noFill/>
+        </p:spPr>
+        <p:txBody>
+          <a:bodyPr wrap="square">
+            <a:spAutoFit/>
+          </a:bodyPr>
+          <a:lstStyle/>
+          <a:p>
+            <a:r>
+              <a:rPr sz="850" b="1">
+                <a:solidFill>
+                  <a:srgbClr val="3FD0E6"/>
+                </a:solidFill>
+                <a:latin typeface="JetBrains Mono"/>
+              </a:rPr>
+              <a:t>🎤 Lilian Veiga (4ª) / Fábio Lippi (5ª)   |   </a:t>
+            </a:r>
+            <a:r>
+              <a:rPr sz="850">
+                <a:solidFill>
+                  <a:srgbClr val="94A3B8"/>
+                </a:solidFill>
+                <a:latin typeface="JetBrains Mono"/>
+              </a:rPr>
+              <a:t>📚 Fonte / Ref:  WIPO (2025). Global Innovation Index 2025: S&amp;T Clusters Ranking (San Diego, 14th); Majava &amp; Rinkinen (2026).</a:t>
+            </a:r>
+          </a:p>
+        </p:txBody>
+      </p:sp>
     </p:spTree>
   </p:cSld>
   <p:clrMapOvr>
@@ -10753,6 +11483,49 @@
           </a:p>
         </p:txBody>
       </p:sp>
+      <p:sp>
+        <p:nvSpPr>
+          <p:cNvPr id="6" name="TextBox 5"/>
+          <p:cNvSpPr txBox="1"/>
+          <p:nvPr/>
+        </p:nvSpPr>
+        <p:spPr>
+          <a:xfrm>
+            <a:off x="731520" y="6309360"/>
+            <a:ext cx="10728655" cy="411480"/>
+          </a:xfrm>
+          <a:prstGeom prst="rect">
+            <a:avLst/>
+          </a:prstGeom>
+          <a:noFill/>
+        </p:spPr>
+        <p:txBody>
+          <a:bodyPr wrap="square">
+            <a:spAutoFit/>
+          </a:bodyPr>
+          <a:lstStyle/>
+          <a:p>
+            <a:r>
+              <a:rPr sz="850" b="1">
+                <a:solidFill>
+                  <a:srgbClr val="3FD0E6"/>
+                </a:solidFill>
+                <a:latin typeface="JetBrains Mono"/>
+              </a:rPr>
+              <a:t>🎤 Lilian Veiga (4ª) / Fábio Lippi (5ª)   |   </a:t>
+            </a:r>
+            <a:r>
+              <a:rPr sz="850">
+                <a:solidFill>
+                  <a:srgbClr val="94A3B8"/>
+                </a:solidFill>
+                <a:latin typeface="JetBrains Mono"/>
+              </a:rPr>
+              <a:t>📚 Fonte / Ref:  Majava, J. &amp; Rinkinen, S. (2024/2026). Twenty years, twenty studies: what can we learn from San Diego’s innovation ecosystem? Technology Analysis &amp; Strategic Management, 38(1), 49-64.</a:t>
+            </a:r>
+          </a:p>
+        </p:txBody>
+      </p:sp>
     </p:spTree>
   </p:cSld>
   <p:clrMapOvr>
@@ -10917,6 +11690,49 @@
           </a:prstGeom>
         </p:spPr>
       </p:pic>
+      <p:sp>
+        <p:nvSpPr>
+          <p:cNvPr id="6" name="TextBox 5"/>
+          <p:cNvSpPr txBox="1"/>
+          <p:nvPr/>
+        </p:nvSpPr>
+        <p:spPr>
+          <a:xfrm>
+            <a:off x="731520" y="6309360"/>
+            <a:ext cx="10728655" cy="411480"/>
+          </a:xfrm>
+          <a:prstGeom prst="rect">
+            <a:avLst/>
+          </a:prstGeom>
+          <a:noFill/>
+        </p:spPr>
+        <p:txBody>
+          <a:bodyPr wrap="square">
+            <a:spAutoFit/>
+          </a:bodyPr>
+          <a:lstStyle/>
+          <a:p>
+            <a:r>
+              <a:rPr sz="850" b="1">
+                <a:solidFill>
+                  <a:srgbClr val="3FD0E6"/>
+                </a:solidFill>
+                <a:latin typeface="JetBrains Mono"/>
+              </a:rPr>
+              <a:t>🎤 Lilian Veiga (4ª) / Fábio Lippi (5ª)   |   </a:t>
+            </a:r>
+            <a:r>
+              <a:rPr sz="850">
+                <a:solidFill>
+                  <a:srgbClr val="94A3B8"/>
+                </a:solidFill>
+                <a:latin typeface="JetBrains Mono"/>
+              </a:rPr>
+              <a:t>📚 Fonte / Ref:  Majava, J. &amp; Rinkinen, S. (2024/2026); Walshok, M. L. &amp; Shragge, A. (2014). Invention and Reinvention: The Evolution of San Diego's Innovation Economy.</a:t>
+            </a:r>
+          </a:p>
+        </p:txBody>
+      </p:sp>
     </p:spTree>
   </p:cSld>
   <p:clrMapOvr>
@@ -11046,6 +11862,49 @@
           </a:prstGeom>
         </p:spPr>
       </p:pic>
+      <p:sp>
+        <p:nvSpPr>
+          <p:cNvPr id="5" name="TextBox 4"/>
+          <p:cNvSpPr txBox="1"/>
+          <p:nvPr/>
+        </p:nvSpPr>
+        <p:spPr>
+          <a:xfrm>
+            <a:off x="731520" y="6309360"/>
+            <a:ext cx="10728655" cy="411480"/>
+          </a:xfrm>
+          <a:prstGeom prst="rect">
+            <a:avLst/>
+          </a:prstGeom>
+          <a:noFill/>
+        </p:spPr>
+        <p:txBody>
+          <a:bodyPr wrap="square">
+            <a:spAutoFit/>
+          </a:bodyPr>
+          <a:lstStyle/>
+          <a:p>
+            <a:r>
+              <a:rPr sz="850" b="1">
+                <a:solidFill>
+                  <a:srgbClr val="3FD0E6"/>
+                </a:solidFill>
+                <a:latin typeface="JetBrains Mono"/>
+              </a:rPr>
+              <a:t>🎤 Lilian Veiga (4ª) / Fábio Lippi (5ª)   |   </a:t>
+            </a:r>
+            <a:r>
+              <a:rPr sz="850">
+                <a:solidFill>
+                  <a:srgbClr val="94A3B8"/>
+                </a:solidFill>
+                <a:latin typeface="JetBrains Mono"/>
+              </a:rPr>
+              <a:t>📚 Fonte / Ref:  Majava, J. &amp; Rinkinen, S. (2024/2026). PEST Analysis of the San Diego Innovation Ecosystem.</a:t>
+            </a:r>
+          </a:p>
+        </p:txBody>
+      </p:sp>
     </p:spTree>
   </p:cSld>
   <p:clrMapOvr>
@@ -11302,6 +12161,49 @@
           </a:p>
         </p:txBody>
       </p:sp>
+      <p:sp>
+        <p:nvSpPr>
+          <p:cNvPr id="7" name="TextBox 6"/>
+          <p:cNvSpPr txBox="1"/>
+          <p:nvPr/>
+        </p:nvSpPr>
+        <p:spPr>
+          <a:xfrm>
+            <a:off x="731520" y="6309360"/>
+            <a:ext cx="10728655" cy="411480"/>
+          </a:xfrm>
+          <a:prstGeom prst="rect">
+            <a:avLst/>
+          </a:prstGeom>
+          <a:noFill/>
+        </p:spPr>
+        <p:txBody>
+          <a:bodyPr wrap="square">
+            <a:spAutoFit/>
+          </a:bodyPr>
+          <a:lstStyle/>
+          <a:p>
+            <a:r>
+              <a:rPr sz="850" b="1">
+                <a:solidFill>
+                  <a:srgbClr val="3FD0E6"/>
+                </a:solidFill>
+                <a:latin typeface="JetBrains Mono"/>
+              </a:rPr>
+              <a:t>🎤 Lilian Veiga (4ª) / Fábio Lippi (5ª)   |   </a:t>
+            </a:r>
+            <a:r>
+              <a:rPr sz="850">
+                <a:solidFill>
+                  <a:srgbClr val="94A3B8"/>
+                </a:solidFill>
+                <a:latin typeface="JetBrains Mono"/>
+              </a:rPr>
+              <a:t>📚 Fonte / Ref:  Rubem, T. C. (2018). Políticas de inovação, parques tecnológicos e a importância do território. Anais Unicamp; Silva, O. (1998). A Decolagem de um Sonho.</a:t>
+            </a:r>
+          </a:p>
+        </p:txBody>
+      </p:sp>
     </p:spTree>
   </p:cSld>
   <p:clrMapOvr>
@@ -11466,6 +12368,49 @@
           </a:prstGeom>
         </p:spPr>
       </p:pic>
+      <p:sp>
+        <p:nvSpPr>
+          <p:cNvPr id="6" name="TextBox 5"/>
+          <p:cNvSpPr txBox="1"/>
+          <p:nvPr/>
+        </p:nvSpPr>
+        <p:spPr>
+          <a:xfrm>
+            <a:off x="731520" y="6309360"/>
+            <a:ext cx="10728655" cy="411480"/>
+          </a:xfrm>
+          <a:prstGeom prst="rect">
+            <a:avLst/>
+          </a:prstGeom>
+          <a:noFill/>
+        </p:spPr>
+        <p:txBody>
+          <a:bodyPr wrap="square">
+            <a:spAutoFit/>
+          </a:bodyPr>
+          <a:lstStyle/>
+          <a:p>
+            <a:r>
+              <a:rPr sz="850" b="1">
+                <a:solidFill>
+                  <a:srgbClr val="3FD0E6"/>
+                </a:solidFill>
+                <a:latin typeface="JetBrains Mono"/>
+              </a:rPr>
+              <a:t>🎤 Lilian Veiga (4ª) / Fábio Lippi (5ª)   |   </a:t>
+            </a:r>
+            <a:r>
+              <a:rPr sz="850">
+                <a:solidFill>
+                  <a:srgbClr val="94A3B8"/>
+                </a:solidFill>
+                <a:latin typeface="JetBrains Mono"/>
+              </a:rPr>
+              <a:t>📚 Fonte / Ref:  Rubem, T. C. (2018); Spolidoro, R. (1997). Tipologia de polos tecnológicos; APTSJC (2025).</a:t>
+            </a:r>
+          </a:p>
+        </p:txBody>
+      </p:sp>
     </p:spTree>
   </p:cSld>
   <p:clrMapOvr>
@@ -11725,6 +12670,49 @@
           </a:p>
         </p:txBody>
       </p:sp>
+      <p:sp>
+        <p:nvSpPr>
+          <p:cNvPr id="6" name="TextBox 5"/>
+          <p:cNvSpPr txBox="1"/>
+          <p:nvPr/>
+        </p:nvSpPr>
+        <p:spPr>
+          <a:xfrm>
+            <a:off x="731520" y="6309360"/>
+            <a:ext cx="10728655" cy="411480"/>
+          </a:xfrm>
+          <a:prstGeom prst="rect">
+            <a:avLst/>
+          </a:prstGeom>
+          <a:noFill/>
+        </p:spPr>
+        <p:txBody>
+          <a:bodyPr wrap="square">
+            <a:spAutoFit/>
+          </a:bodyPr>
+          <a:lstStyle/>
+          <a:p>
+            <a:r>
+              <a:rPr sz="850" b="1">
+                <a:solidFill>
+                  <a:srgbClr val="3FD0E6"/>
+                </a:solidFill>
+                <a:latin typeface="JetBrains Mono"/>
+              </a:rPr>
+              <a:t>🎤 Josué Jofre (4ª) / Marciele Toledo (5ª)   |   </a:t>
+            </a:r>
+            <a:r>
+              <a:rPr sz="850">
+                <a:solidFill>
+                  <a:srgbClr val="94A3B8"/>
+                </a:solidFill>
+                <a:latin typeface="JetBrains Mono"/>
+              </a:rPr>
+              <a:t>📚 Fonte / Ref:  APTSJC (2025). Relatório Anual de Atividades; Prefeitura Municipal de São José dos Campos (Lei nº 7.058/2006).</a:t>
+            </a:r>
+          </a:p>
+        </p:txBody>
+      </p:sp>
     </p:spTree>
   </p:cSld>
   <p:clrMapOvr>
@@ -12000,6 +12988,49 @@
           </a:p>
         </p:txBody>
       </p:sp>
+      <p:sp>
+        <p:nvSpPr>
+          <p:cNvPr id="7" name="TextBox 6"/>
+          <p:cNvSpPr txBox="1"/>
+          <p:nvPr/>
+        </p:nvSpPr>
+        <p:spPr>
+          <a:xfrm>
+            <a:off x="731520" y="6309360"/>
+            <a:ext cx="10728655" cy="411480"/>
+          </a:xfrm>
+          <a:prstGeom prst="rect">
+            <a:avLst/>
+          </a:prstGeom>
+          <a:noFill/>
+        </p:spPr>
+        <p:txBody>
+          <a:bodyPr wrap="square">
+            <a:spAutoFit/>
+          </a:bodyPr>
+          <a:lstStyle/>
+          <a:p>
+            <a:r>
+              <a:rPr sz="850" b="1">
+                <a:solidFill>
+                  <a:srgbClr val="3FD0E6"/>
+                </a:solidFill>
+                <a:latin typeface="JetBrains Mono"/>
+              </a:rPr>
+              <a:t>🎤 Lilian Veiga (4ª) / Fábio Lippi (5ª)   |   </a:t>
+            </a:r>
+            <a:r>
+              <a:rPr sz="850">
+                <a:solidFill>
+                  <a:srgbClr val="94A3B8"/>
+                </a:solidFill>
+                <a:latin typeface="JetBrains Mono"/>
+              </a:rPr>
+              <a:t>📚 Fonte / Ref:  APTSJC (2025). Relatório Anual de Atividades; Rubem, T. C. (2018) sobre spill-overs territoriais no PIT SJC.</a:t>
+            </a:r>
+          </a:p>
+        </p:txBody>
+      </p:sp>
     </p:spTree>
   </p:cSld>
   <p:clrMapOvr>
@@ -12271,6 +13302,49 @@
                 </a:solidFill>
               </a:rPr>
               <a:t>Comunidade com 23 entidades estratégicas e 87 mentores seniores no Nexus Circle.</a:t>
+            </a:r>
+          </a:p>
+        </p:txBody>
+      </p:sp>
+      <p:sp>
+        <p:nvSpPr>
+          <p:cNvPr id="7" name="TextBox 6"/>
+          <p:cNvSpPr txBox="1"/>
+          <p:nvPr/>
+        </p:nvSpPr>
+        <p:spPr>
+          <a:xfrm>
+            <a:off x="731520" y="6309360"/>
+            <a:ext cx="10728655" cy="411480"/>
+          </a:xfrm>
+          <a:prstGeom prst="rect">
+            <a:avLst/>
+          </a:prstGeom>
+          <a:noFill/>
+        </p:spPr>
+        <p:txBody>
+          <a:bodyPr wrap="square">
+            <a:spAutoFit/>
+          </a:bodyPr>
+          <a:lstStyle/>
+          <a:p>
+            <a:r>
+              <a:rPr sz="850" b="1">
+                <a:solidFill>
+                  <a:srgbClr val="3FD0E6"/>
+                </a:solidFill>
+                <a:latin typeface="JetBrains Mono"/>
+              </a:rPr>
+              <a:t>🎤 Lilian Veiga (4ª) / Fábio Lippi (5ª)   |   </a:t>
+            </a:r>
+            <a:r>
+              <a:rPr sz="850">
+                <a:solidFill>
+                  <a:srgbClr val="94A3B8"/>
+                </a:solidFill>
+                <a:latin typeface="JetBrains Mono"/>
+              </a:rPr>
+              <a:t>📚 Fonte / Ref:  Cheriegate, J. (2026). Parque Tecnológico fortalece São José como polo nacional de inovação. Gazeta de SP; APTSJC (2025).</a:t>
             </a:r>
           </a:p>
         </p:txBody>
@@ -12904,6 +13978,49 @@
           </a:graphicData>
         </a:graphic>
       </p:graphicFrame>
+      <p:sp>
+        <p:nvSpPr>
+          <p:cNvPr id="5" name="TextBox 4"/>
+          <p:cNvSpPr txBox="1"/>
+          <p:nvPr/>
+        </p:nvSpPr>
+        <p:spPr>
+          <a:xfrm>
+            <a:off x="731520" y="6309360"/>
+            <a:ext cx="10728655" cy="411480"/>
+          </a:xfrm>
+          <a:prstGeom prst="rect">
+            <a:avLst/>
+          </a:prstGeom>
+          <a:noFill/>
+        </p:spPr>
+        <p:txBody>
+          <a:bodyPr wrap="square">
+            <a:spAutoFit/>
+          </a:bodyPr>
+          <a:lstStyle/>
+          <a:p>
+            <a:r>
+              <a:rPr sz="850" b="1">
+                <a:solidFill>
+                  <a:srgbClr val="3FD0E6"/>
+                </a:solidFill>
+                <a:latin typeface="JetBrains Mono"/>
+              </a:rPr>
+              <a:t>🎤 Lilian Veiga (4ª) / Fábio Lippi (5ª)   |   </a:t>
+            </a:r>
+            <a:r>
+              <a:rPr sz="850">
+                <a:solidFill>
+                  <a:srgbClr val="94A3B8"/>
+                </a:solidFill>
+                <a:latin typeface="JetBrains Mono"/>
+              </a:rPr>
+              <a:t>📚 Fonte / Ref:  Majava &amp; Rinkinen (2026); Rubem (2018); APTSJC (2025); Matriz Comparativa Oficial Seminário 5 GETI 2026.</a:t>
+            </a:r>
+          </a:p>
+        </p:txBody>
+      </p:sp>
     </p:spTree>
   </p:cSld>
   <p:clrMapOvr>
@@ -13163,6 +14280,49 @@
           </a:p>
         </p:txBody>
       </p:sp>
+      <p:sp>
+        <p:nvSpPr>
+          <p:cNvPr id="6" name="TextBox 5"/>
+          <p:cNvSpPr txBox="1"/>
+          <p:nvPr/>
+        </p:nvSpPr>
+        <p:spPr>
+          <a:xfrm>
+            <a:off x="731520" y="6309360"/>
+            <a:ext cx="10728655" cy="411480"/>
+          </a:xfrm>
+          <a:prstGeom prst="rect">
+            <a:avLst/>
+          </a:prstGeom>
+          <a:noFill/>
+        </p:spPr>
+        <p:txBody>
+          <a:bodyPr wrap="square">
+            <a:spAutoFit/>
+          </a:bodyPr>
+          <a:lstStyle/>
+          <a:p>
+            <a:r>
+              <a:rPr sz="850" b="1">
+                <a:solidFill>
+                  <a:srgbClr val="3FD0E6"/>
+                </a:solidFill>
+                <a:latin typeface="JetBrains Mono"/>
+              </a:rPr>
+              <a:t>🎤 Lilian Veiga (4ª) / Fábio Lippi (5ª)   |   </a:t>
+            </a:r>
+            <a:r>
+              <a:rPr sz="850">
+                <a:solidFill>
+                  <a:srgbClr val="94A3B8"/>
+                </a:solidFill>
+                <a:latin typeface="JetBrains Mono"/>
+              </a:rPr>
+              <a:t>📚 Fonte / Ref:  Avaliação Formativa Síncrona • Banco de Questões GETI 2026 elaborado por Lilian Veiga Vinhas baseado em Majava &amp; Rinkinen (2026).</a:t>
+            </a:r>
+          </a:p>
+        </p:txBody>
+      </p:sp>
     </p:spTree>
   </p:cSld>
   <p:clrMapOvr>
@@ -13422,6 +14582,49 @@
           </a:p>
         </p:txBody>
       </p:sp>
+      <p:sp>
+        <p:nvSpPr>
+          <p:cNvPr id="6" name="TextBox 5"/>
+          <p:cNvSpPr txBox="1"/>
+          <p:nvPr/>
+        </p:nvSpPr>
+        <p:spPr>
+          <a:xfrm>
+            <a:off x="731520" y="6309360"/>
+            <a:ext cx="10728655" cy="411480"/>
+          </a:xfrm>
+          <a:prstGeom prst="rect">
+            <a:avLst/>
+          </a:prstGeom>
+          <a:noFill/>
+        </p:spPr>
+        <p:txBody>
+          <a:bodyPr wrap="square">
+            <a:spAutoFit/>
+          </a:bodyPr>
+          <a:lstStyle/>
+          <a:p>
+            <a:r>
+              <a:rPr sz="850" b="1">
+                <a:solidFill>
+                  <a:srgbClr val="3FD0E6"/>
+                </a:solidFill>
+                <a:latin typeface="JetBrains Mono"/>
+              </a:rPr>
+              <a:t>🎤 Josué Jofre (4ª) / Marciele Toledo (5ª)   |   </a:t>
+            </a:r>
+            <a:r>
+              <a:rPr sz="850">
+                <a:solidFill>
+                  <a:srgbClr val="94A3B8"/>
+                </a:solidFill>
+                <a:latin typeface="JetBrains Mono"/>
+              </a:rPr>
+              <a:t>📚 Fonte / Ref:  Projeto Pedagógico PPG-PIT (2026) • Programa de Pós-Graduação em Inovação Tecnológica, UNIFESP Campus Parque Tecnológico SJC.</a:t>
+            </a:r>
+          </a:p>
+        </p:txBody>
+      </p:sp>
     </p:spTree>
   </p:cSld>
   <p:clrMapOvr>
@@ -13681,6 +14884,49 @@
           </a:p>
         </p:txBody>
       </p:sp>
+      <p:sp>
+        <p:nvSpPr>
+          <p:cNvPr id="6" name="TextBox 5"/>
+          <p:cNvSpPr txBox="1"/>
+          <p:nvPr/>
+        </p:nvSpPr>
+        <p:spPr>
+          <a:xfrm>
+            <a:off x="731520" y="6309360"/>
+            <a:ext cx="10728655" cy="411480"/>
+          </a:xfrm>
+          <a:prstGeom prst="rect">
+            <a:avLst/>
+          </a:prstGeom>
+          <a:noFill/>
+        </p:spPr>
+        <p:txBody>
+          <a:bodyPr wrap="square">
+            <a:spAutoFit/>
+          </a:bodyPr>
+          <a:lstStyle/>
+          <a:p>
+            <a:r>
+              <a:rPr sz="850" b="1">
+                <a:solidFill>
+                  <a:srgbClr val="3FD0E6"/>
+                </a:solidFill>
+                <a:latin typeface="JetBrains Mono"/>
+              </a:rPr>
+              <a:t>🎤 Renato Paschoal (4ª e 5ª)   |   </a:t>
+            </a:r>
+            <a:r>
+              <a:rPr sz="850">
+                <a:solidFill>
+                  <a:srgbClr val="94A3B8"/>
+                </a:solidFill>
+                <a:latin typeface="JetBrains Mono"/>
+              </a:rPr>
+              <a:t>📚 Fonte / Ref:  Paschoal, R. (2026). Atividade de Campo: Entrevista Técnica com a Coordenadoria de Inovação do Parque Tecnológico de São José dos Campos.</a:t>
+            </a:r>
+          </a:p>
+        </p:txBody>
+      </p:sp>
     </p:spTree>
   </p:cSld>
   <p:clrMapOvr>
@@ -13940,6 +15186,49 @@
           </a:p>
         </p:txBody>
       </p:sp>
+      <p:sp>
+        <p:nvSpPr>
+          <p:cNvPr id="6" name="TextBox 5"/>
+          <p:cNvSpPr txBox="1"/>
+          <p:nvPr/>
+        </p:nvSpPr>
+        <p:spPr>
+          <a:xfrm>
+            <a:off x="731520" y="6309360"/>
+            <a:ext cx="10728655" cy="411480"/>
+          </a:xfrm>
+          <a:prstGeom prst="rect">
+            <a:avLst/>
+          </a:prstGeom>
+          <a:noFill/>
+        </p:spPr>
+        <p:txBody>
+          <a:bodyPr wrap="square">
+            <a:spAutoFit/>
+          </a:bodyPr>
+          <a:lstStyle/>
+          <a:p>
+            <a:r>
+              <a:rPr sz="850" b="1">
+                <a:solidFill>
+                  <a:srgbClr val="3FD0E6"/>
+                </a:solidFill>
+                <a:latin typeface="JetBrains Mono"/>
+              </a:rPr>
+              <a:t>🎤 Renato Paschoal (4ª e 5ª)   |   </a:t>
+            </a:r>
+            <a:r>
+              <a:rPr sz="850">
+                <a:solidFill>
+                  <a:srgbClr val="94A3B8"/>
+                </a:solidFill>
+                <a:latin typeface="JetBrains Mono"/>
+              </a:rPr>
+              <a:t>📚 Fonte / Ref:  Paschoal, R. (2026). Síntese Empírica dos 4 Eixos de Governança no PIT SJC.</a:t>
+            </a:r>
+          </a:p>
+        </p:txBody>
+      </p:sp>
     </p:spTree>
   </p:cSld>
   <p:clrMapOvr>
@@ -14199,6 +15488,49 @@
           </a:p>
         </p:txBody>
       </p:sp>
+      <p:sp>
+        <p:nvSpPr>
+          <p:cNvPr id="6" name="TextBox 5"/>
+          <p:cNvSpPr txBox="1"/>
+          <p:nvPr/>
+        </p:nvSpPr>
+        <p:spPr>
+          <a:xfrm>
+            <a:off x="731520" y="6309360"/>
+            <a:ext cx="10728655" cy="411480"/>
+          </a:xfrm>
+          <a:prstGeom prst="rect">
+            <a:avLst/>
+          </a:prstGeom>
+          <a:noFill/>
+        </p:spPr>
+        <p:txBody>
+          <a:bodyPr wrap="square">
+            <a:spAutoFit/>
+          </a:bodyPr>
+          <a:lstStyle/>
+          <a:p>
+            <a:r>
+              <a:rPr sz="850" b="1">
+                <a:solidFill>
+                  <a:srgbClr val="3FD0E6"/>
+                </a:solidFill>
+                <a:latin typeface="JetBrains Mono"/>
+              </a:rPr>
+              <a:t>🎤 Renato Paschoal (4ª e 5ª)   |   </a:t>
+            </a:r>
+            <a:r>
+              <a:rPr sz="850">
+                <a:solidFill>
+                  <a:srgbClr val="94A3B8"/>
+                </a:solidFill>
+                <a:latin typeface="JetBrains Mono"/>
+              </a:rPr>
+              <a:t>📚 Fonte / Ref:  Shen, W., et al. (2025/2026). Mapping innovation ecosystem research; Alvesson, M. &amp; Spicer, A. (2012). A Stupidity-Based Theory of Organizations. JMS.</a:t>
+            </a:r>
+          </a:p>
+        </p:txBody>
+      </p:sp>
     </p:spTree>
   </p:cSld>
   <p:clrMapOvr>
@@ -14458,6 +15790,49 @@
           </a:p>
         </p:txBody>
       </p:sp>
+      <p:sp>
+        <p:nvSpPr>
+          <p:cNvPr id="6" name="TextBox 5"/>
+          <p:cNvSpPr txBox="1"/>
+          <p:nvPr/>
+        </p:nvSpPr>
+        <p:spPr>
+          <a:xfrm>
+            <a:off x="731520" y="6309360"/>
+            <a:ext cx="10728655" cy="411480"/>
+          </a:xfrm>
+          <a:prstGeom prst="rect">
+            <a:avLst/>
+          </a:prstGeom>
+          <a:noFill/>
+        </p:spPr>
+        <p:txBody>
+          <a:bodyPr wrap="square">
+            <a:spAutoFit/>
+          </a:bodyPr>
+          <a:lstStyle/>
+          <a:p>
+            <a:r>
+              <a:rPr sz="850" b="1">
+                <a:solidFill>
+                  <a:srgbClr val="3FD0E6"/>
+                </a:solidFill>
+                <a:latin typeface="JetBrains Mono"/>
+              </a:rPr>
+              <a:t>🎤 Renato Paschoal (4ª e 5ª)   |   </a:t>
+            </a:r>
+            <a:r>
+              <a:rPr sz="850">
+                <a:solidFill>
+                  <a:srgbClr val="94A3B8"/>
+                </a:solidFill>
+                <a:latin typeface="JetBrains Mono"/>
+              </a:rPr>
+              <a:t>📚 Fonte / Ref:  Thomas, L. &amp; Ritala, P. (2022). Ecosystem legitimacy emergence; Shen et al. (2025/2026).</a:t>
+            </a:r>
+          </a:p>
+        </p:txBody>
+      </p:sp>
     </p:spTree>
   </p:cSld>
   <p:clrMapOvr>
@@ -14717,6 +16092,49 @@
           </a:p>
         </p:txBody>
       </p:sp>
+      <p:sp>
+        <p:nvSpPr>
+          <p:cNvPr id="6" name="TextBox 5"/>
+          <p:cNvSpPr txBox="1"/>
+          <p:nvPr/>
+        </p:nvSpPr>
+        <p:spPr>
+          <a:xfrm>
+            <a:off x="731520" y="6309360"/>
+            <a:ext cx="10728655" cy="411480"/>
+          </a:xfrm>
+          <a:prstGeom prst="rect">
+            <a:avLst/>
+          </a:prstGeom>
+          <a:noFill/>
+        </p:spPr>
+        <p:txBody>
+          <a:bodyPr wrap="square">
+            <a:spAutoFit/>
+          </a:bodyPr>
+          <a:lstStyle/>
+          <a:p>
+            <a:r>
+              <a:rPr sz="850" b="1">
+                <a:solidFill>
+                  <a:srgbClr val="3FD0E6"/>
+                </a:solidFill>
+                <a:latin typeface="JetBrains Mono"/>
+              </a:rPr>
+              <a:t>🎤 Renato Paschoal (4ª e 5ª)   |   </a:t>
+            </a:r>
+            <a:r>
+              <a:rPr sz="850">
+                <a:solidFill>
+                  <a:srgbClr val="94A3B8"/>
+                </a:solidFill>
+                <a:latin typeface="JetBrains Mono"/>
+              </a:rPr>
+              <a:t>📚 Fonte / Ref:  Avaliação Formativa Síncrona • Banco de Questões GETI 2026 baseado em Shen et al. (2025/2026).</a:t>
+            </a:r>
+          </a:p>
+        </p:txBody>
+      </p:sp>
     </p:spTree>
   </p:cSld>
   <p:clrMapOvr>
@@ -14976,6 +16394,49 @@
           </a:p>
         </p:txBody>
       </p:sp>
+      <p:sp>
+        <p:nvSpPr>
+          <p:cNvPr id="6" name="TextBox 5"/>
+          <p:cNvSpPr txBox="1"/>
+          <p:nvPr/>
+        </p:nvSpPr>
+        <p:spPr>
+          <a:xfrm>
+            <a:off x="731520" y="6309360"/>
+            <a:ext cx="10728655" cy="411480"/>
+          </a:xfrm>
+          <a:prstGeom prst="rect">
+            <a:avLst/>
+          </a:prstGeom>
+          <a:noFill/>
+        </p:spPr>
+        <p:txBody>
+          <a:bodyPr wrap="square">
+            <a:spAutoFit/>
+          </a:bodyPr>
+          <a:lstStyle/>
+          <a:p>
+            <a:r>
+              <a:rPr sz="850" b="1">
+                <a:solidFill>
+                  <a:srgbClr val="3FD0E6"/>
+                </a:solidFill>
+                <a:latin typeface="JetBrains Mono"/>
+              </a:rPr>
+              <a:t>🎤 Nathalia Neves (4ª) / Fernando Barreto (5ª)   |   </a:t>
+            </a:r>
+            <a:r>
+              <a:rPr sz="850">
+                <a:solidFill>
+                  <a:srgbClr val="94A3B8"/>
+                </a:solidFill>
+                <a:latin typeface="JetBrains Mono"/>
+              </a:rPr>
+              <a:t>📚 Fonte / Ref:  Tansley, A. G. (1935). The use and abuse of vegetational concepts and terms. Ecology; Moore, J. F. (1993). Predators and Prey. HBR.</a:t>
+            </a:r>
+          </a:p>
+        </p:txBody>
+      </p:sp>
     </p:spTree>
   </p:cSld>
   <p:clrMapOvr>
@@ -15235,6 +16696,49 @@
           </a:p>
         </p:txBody>
       </p:sp>
+      <p:sp>
+        <p:nvSpPr>
+          <p:cNvPr id="6" name="TextBox 5"/>
+          <p:cNvSpPr txBox="1"/>
+          <p:nvPr/>
+        </p:nvSpPr>
+        <p:spPr>
+          <a:xfrm>
+            <a:off x="731520" y="6309360"/>
+            <a:ext cx="10728655" cy="411480"/>
+          </a:xfrm>
+          <a:prstGeom prst="rect">
+            <a:avLst/>
+          </a:prstGeom>
+          <a:noFill/>
+        </p:spPr>
+        <p:txBody>
+          <a:bodyPr wrap="square">
+            <a:spAutoFit/>
+          </a:bodyPr>
+          <a:lstStyle/>
+          <a:p>
+            <a:r>
+              <a:rPr sz="850" b="1">
+                <a:solidFill>
+                  <a:srgbClr val="3FD0E6"/>
+                </a:solidFill>
+                <a:latin typeface="JetBrains Mono"/>
+              </a:rPr>
+              <a:t>🎤 Jéssica David (4ª) / Fernando Barreto (5ª)   |   </a:t>
+            </a:r>
+            <a:r>
+              <a:rPr sz="850">
+                <a:solidFill>
+                  <a:srgbClr val="94A3B8"/>
+                </a:solidFill>
+                <a:latin typeface="JetBrains Mono"/>
+              </a:rPr>
+              <a:t>📚 Fonte / Ref:  Avaliação Cienciométrica e Diagnóstico Formativo de Desempenho • Equipe GETI 2026 / PPG-PIT UNIFESP.</a:t>
+            </a:r>
+          </a:p>
+        </p:txBody>
+      </p:sp>
     </p:spTree>
   </p:cSld>
   <p:clrMapOvr>
@@ -15494,6 +16998,49 @@
           </a:p>
         </p:txBody>
       </p:sp>
+      <p:sp>
+        <p:nvSpPr>
+          <p:cNvPr id="6" name="TextBox 5"/>
+          <p:cNvSpPr txBox="1"/>
+          <p:nvPr/>
+        </p:nvSpPr>
+        <p:spPr>
+          <a:xfrm>
+            <a:off x="731520" y="6309360"/>
+            <a:ext cx="10728655" cy="411480"/>
+          </a:xfrm>
+          <a:prstGeom prst="rect">
+            <a:avLst/>
+          </a:prstGeom>
+          <a:noFill/>
+        </p:spPr>
+        <p:txBody>
+          <a:bodyPr wrap="square">
+            <a:spAutoFit/>
+          </a:bodyPr>
+          <a:lstStyle/>
+          <a:p>
+            <a:r>
+              <a:rPr sz="850" b="1">
+                <a:solidFill>
+                  <a:srgbClr val="3FD0E6"/>
+                </a:solidFill>
+                <a:latin typeface="JetBrains Mono"/>
+              </a:rPr>
+              <a:t>🎤 Jéssica David (4ª) / Fernando Barreto (5ª)   |   </a:t>
+            </a:r>
+            <a:r>
+              <a:rPr sz="850">
+                <a:solidFill>
+                  <a:srgbClr val="94A3B8"/>
+                </a:solidFill>
+                <a:latin typeface="JetBrains Mono"/>
+              </a:rPr>
+              <a:t>📚 Fonte / Ref:  Consolidação dos Dados do Kahoot RPG e Mapeamento de Lacunas Conceituais • PPG-PIT UNIFESP.</a:t>
+            </a:r>
+          </a:p>
+        </p:txBody>
+      </p:sp>
     </p:spTree>
   </p:cSld>
   <p:clrMapOvr>
@@ -15753,6 +17300,49 @@
           </a:p>
         </p:txBody>
       </p:sp>
+      <p:sp>
+        <p:nvSpPr>
+          <p:cNvPr id="6" name="TextBox 5"/>
+          <p:cNvSpPr txBox="1"/>
+          <p:nvPr/>
+        </p:nvSpPr>
+        <p:spPr>
+          <a:xfrm>
+            <a:off x="731520" y="6309360"/>
+            <a:ext cx="10728655" cy="411480"/>
+          </a:xfrm>
+          <a:prstGeom prst="rect">
+            <a:avLst/>
+          </a:prstGeom>
+          <a:noFill/>
+        </p:spPr>
+        <p:txBody>
+          <a:bodyPr wrap="square">
+            <a:spAutoFit/>
+          </a:bodyPr>
+          <a:lstStyle/>
+          <a:p>
+            <a:r>
+              <a:rPr sz="850" b="1">
+                <a:solidFill>
+                  <a:srgbClr val="3FD0E6"/>
+                </a:solidFill>
+                <a:latin typeface="JetBrains Mono"/>
+              </a:rPr>
+              <a:t>🎤 Josué Jofre (4ª) / Renato Paschoal (4ª) / Fernando Barreto (5ª)   |   </a:t>
+            </a:r>
+            <a:r>
+              <a:rPr sz="850">
+                <a:solidFill>
+                  <a:srgbClr val="94A3B8"/>
+                </a:solidFill>
+                <a:latin typeface="JetBrains Mono"/>
+              </a:rPr>
+              <a:t>📚 Fonte / Ref:  Síntese Integradora: Moore (1993), Adner (2006), Furr &amp; Shipilov (2018), Majava &amp; Rinkinen (2026), Machado et al. (2025).</a:t>
+            </a:r>
+          </a:p>
+        </p:txBody>
+      </p:sp>
     </p:spTree>
   </p:cSld>
   <p:clrMapOvr>
@@ -16012,42 +17602,16 @@
           </a:p>
         </p:txBody>
       </p:sp>
-    </p:spTree>
-  </p:cSld>
-  <p:clrMapOvr>
-    <a:masterClrMapping/>
-  </p:clrMapOvr>
-</p:sld>
-</file>
-
-<file path=ppt/slides/slide44.xml><?xml version="1.0" encoding="utf-8"?>
-<p:sld xmlns:a="http://schemas.openxmlformats.org/drawingml/2006/main" xmlns:p="http://schemas.openxmlformats.org/presentationml/2006/main" xmlns:r="http://schemas.openxmlformats.org/officeDocument/2006/relationships">
-  <p:cSld>
-    <p:bg>
-      <p:bgPr>
-        <a:solidFill>
-          <a:srgbClr val="050A14"/>
-        </a:solidFill>
-        <a:effectLst/>
-      </p:bgPr>
-    </p:bg>
-    <p:spTree>
-      <p:nvGrpSpPr>
-        <p:cNvPr id="1" name=""/>
-        <p:cNvGrpSpPr/>
-        <p:nvPr/>
-      </p:nvGrpSpPr>
-      <p:grpSpPr/>
-      <p:sp>
-        <p:nvSpPr>
-          <p:cNvPr id="2" name="TextBox 1"/>
+      <p:sp>
+        <p:nvSpPr>
+          <p:cNvPr id="6" name="TextBox 5"/>
           <p:cNvSpPr txBox="1"/>
           <p:nvPr/>
         </p:nvSpPr>
         <p:spPr>
           <a:xfrm>
-            <a:off x="731520" y="365760"/>
-            <a:ext cx="10698480" cy="365760"/>
+            <a:off x="731520" y="6309360"/>
+            <a:ext cx="10728655" cy="411480"/>
           </a:xfrm>
           <a:prstGeom prst="rect">
             <a:avLst/>
@@ -16060,178 +17624,23 @@
           </a:bodyPr>
           <a:lstStyle/>
           <a:p>
-            <a:pPr>
-              <a:defRPr sz="1100" b="1">
+            <a:r>
+              <a:rPr sz="850" b="1">
                 <a:solidFill>
                   <a:srgbClr val="3FD0E6"/>
                 </a:solidFill>
                 <a:latin typeface="JetBrains Mono"/>
-              </a:defRPr>
-            </a:pPr>
-            <a:r>
-              <a:t>📚 REFERÊNCIAS BIBLIOGRÁFICAS OFICIAIS</a:t>
-            </a:r>
-          </a:p>
-        </p:txBody>
-      </p:sp>
-      <p:sp>
-        <p:nvSpPr>
-          <p:cNvPr id="3" name="TextBox 2"/>
-          <p:cNvSpPr txBox="1"/>
-          <p:nvPr/>
-        </p:nvSpPr>
-        <p:spPr>
-          <a:xfrm>
-            <a:off x="731520" y="685800"/>
-            <a:ext cx="10698480" cy="731520"/>
-          </a:xfrm>
-          <a:prstGeom prst="rect">
-            <a:avLst/>
-          </a:prstGeom>
-          <a:noFill/>
-        </p:spPr>
-        <p:txBody>
-          <a:bodyPr wrap="square">
-            <a:spAutoFit/>
-          </a:bodyPr>
-          <a:lstStyle/>
-          <a:p>
-            <a:r>
-              <a:rPr sz="2200" b="1">
-                <a:solidFill>
-                  <a:srgbClr val="E6EEF5"/>
-                </a:solidFill>
-                <a:latin typeface="Outfit"/>
               </a:rPr>
-              <a:t>Literatura Seminal e Artigos de </a:t>
-            </a:r>
-            <a:r>
-              <a:rPr sz="2200" b="1">
-                <a:solidFill>
-                  <a:srgbClr val="3FD0E6"/>
-                </a:solidFill>
-                <a:latin typeface="Outfit"/>
+              <a:t>🎤 Grupo Inteiro (4ª e 5ª)   |   </a:t>
+            </a:r>
+            <a:r>
+              <a:rPr sz="850">
+                <a:solidFill>
+                  <a:srgbClr val="94A3B8"/>
+                </a:solidFill>
+                <a:latin typeface="JetBrains Mono"/>
               </a:rPr>
-              <a:t>Vanguarda (2025/2026)</a:t>
-            </a:r>
-          </a:p>
-        </p:txBody>
-      </p:sp>
-      <p:sp>
-        <p:nvSpPr>
-          <p:cNvPr id="4" name="TextBox 3"/>
-          <p:cNvSpPr txBox="1"/>
-          <p:nvPr/>
-        </p:nvSpPr>
-        <p:spPr>
-          <a:xfrm>
-            <a:off x="731520" y="1463040"/>
-            <a:ext cx="10698480" cy="4114800"/>
-          </a:xfrm>
-          <a:prstGeom prst="rect">
-            <a:avLst/>
-          </a:prstGeom>
-          <a:noFill/>
-        </p:spPr>
-        <p:txBody>
-          <a:bodyPr wrap="square">
-            <a:spAutoFit/>
-          </a:bodyPr>
-          <a:lstStyle/>
-          <a:p>
-            <a:pPr>
-              <a:defRPr sz="1300">
-                <a:solidFill>
-                  <a:srgbClr val="FFFFFF"/>
-                </a:solidFill>
-              </a:defRPr>
-            </a:pPr>
-            <a:r>
-              <a:t>• 📚 REFERÊNCIAS BIBLIOGRÁFICAS OFICIAIS</a:t>
-            </a:r>
-          </a:p>
-          <a:p>
-            <a:pPr>
-              <a:defRPr sz="1300">
-                <a:solidFill>
-                  <a:srgbClr val="94A3B8"/>
-                </a:solidFill>
-              </a:defRPr>
-            </a:pPr>
-            <a:r>
-              <a:t>• Literatura Seminal e Artigos de</a:t>
-            </a:r>
-          </a:p>
-          <a:p>
-            <a:pPr>
-              <a:defRPr sz="1300">
-                <a:solidFill>
-                  <a:srgbClr val="FFFFFF"/>
-                </a:solidFill>
-              </a:defRPr>
-            </a:pPr>
-            <a:r>
-              <a:t>• Vanguarda (2025/2026)</a:t>
-            </a:r>
-          </a:p>
-          <a:p>
-            <a:pPr>
-              <a:defRPr sz="1300">
-                <a:solidFill>
-                  <a:srgbClr val="94A3B8"/>
-                </a:solidFill>
-              </a:defRPr>
-            </a:pPr>
-            <a:r>
-              <a:t>• ▸</a:t>
-            </a:r>
-          </a:p>
-          <a:p>
-            <a:pPr>
-              <a:defRPr sz="1300">
-                <a:solidFill>
-                  <a:srgbClr val="FFFFFF"/>
-                </a:solidFill>
-              </a:defRPr>
-            </a:pPr>
-            <a:r>
-              <a:t>• Shen et al. (2025/2026):</a:t>
-            </a:r>
-          </a:p>
-          <a:p>
-            <a:pPr>
-              <a:defRPr sz="1300">
-                <a:solidFill>
-                  <a:srgbClr val="94A3B8"/>
-                </a:solidFill>
-              </a:defRPr>
-            </a:pPr>
-            <a:r>
-              <a:t>• Innovation ecosystems: a bibliometric analysis, systematic literature review, and research agenda.</a:t>
-            </a:r>
-          </a:p>
-          <a:p>
-            <a:pPr>
-              <a:defRPr sz="1300">
-                <a:solidFill>
-                  <a:srgbClr val="FFFFFF"/>
-                </a:solidFill>
-              </a:defRPr>
-            </a:pPr>
-            <a:r>
-              <a:t>• Technology Analysis &amp;amp; Strategic Management</a:t>
-            </a:r>
-          </a:p>
-          <a:p>
-            <a:pPr>
-              <a:defRPr sz="1300">
-                <a:solidFill>
-                  <a:srgbClr val="94A3B8"/>
-                </a:solidFill>
-              </a:defRPr>
-            </a:pPr>
-            <a:r>
-              <a:t>• .</a:t>
+              <a:t>📚 Fonte / Ref:  Mesa de Discussão Acadêmica e Avaliação da Banca Examinadora • Profª Drª Iraci de Souza João &amp; Prof. Dr. Antônio Yukio Ueta.</a:t>
             </a:r>
           </a:p>
         </p:txBody>
@@ -16495,6 +17904,49 @@
           </a:p>
         </p:txBody>
       </p:sp>
+      <p:sp>
+        <p:nvSpPr>
+          <p:cNvPr id="6" name="TextBox 5"/>
+          <p:cNvSpPr txBox="1"/>
+          <p:nvPr/>
+        </p:nvSpPr>
+        <p:spPr>
+          <a:xfrm>
+            <a:off x="731520" y="6309360"/>
+            <a:ext cx="10728655" cy="411480"/>
+          </a:xfrm>
+          <a:prstGeom prst="rect">
+            <a:avLst/>
+          </a:prstGeom>
+          <a:noFill/>
+        </p:spPr>
+        <p:txBody>
+          <a:bodyPr wrap="square">
+            <a:spAutoFit/>
+          </a:bodyPr>
+          <a:lstStyle/>
+          <a:p>
+            <a:r>
+              <a:rPr sz="850" b="1">
+                <a:solidFill>
+                  <a:srgbClr val="3FD0E6"/>
+                </a:solidFill>
+                <a:latin typeface="JetBrains Mono"/>
+              </a:rPr>
+              <a:t>🎤 Nathalia Neves (4ª) / Fernando Barreto (5ª)   |   </a:t>
+            </a:r>
+            <a:r>
+              <a:rPr sz="850">
+                <a:solidFill>
+                  <a:srgbClr val="94A3B8"/>
+                </a:solidFill>
+                <a:latin typeface="JetBrains Mono"/>
+              </a:rPr>
+              <a:t>📚 Fonte / Ref:  Shen, W., et al. (2025/2026). Mapping innovation ecosystem research published from 2006 to 2023: A scientometric review. Technology in Society, 78, 102641.</a:t>
+            </a:r>
+          </a:p>
+        </p:txBody>
+      </p:sp>
     </p:spTree>
   </p:cSld>
   <p:clrMapOvr>
@@ -16754,6 +18206,49 @@
           </a:p>
         </p:txBody>
       </p:sp>
+      <p:sp>
+        <p:nvSpPr>
+          <p:cNvPr id="6" name="TextBox 5"/>
+          <p:cNvSpPr txBox="1"/>
+          <p:nvPr/>
+        </p:nvSpPr>
+        <p:spPr>
+          <a:xfrm>
+            <a:off x="731520" y="6309360"/>
+            <a:ext cx="10728655" cy="411480"/>
+          </a:xfrm>
+          <a:prstGeom prst="rect">
+            <a:avLst/>
+          </a:prstGeom>
+          <a:noFill/>
+        </p:spPr>
+        <p:txBody>
+          <a:bodyPr wrap="square">
+            <a:spAutoFit/>
+          </a:bodyPr>
+          <a:lstStyle/>
+          <a:p>
+            <a:r>
+              <a:rPr sz="850" b="1">
+                <a:solidFill>
+                  <a:srgbClr val="3FD0E6"/>
+                </a:solidFill>
+                <a:latin typeface="JetBrains Mono"/>
+              </a:rPr>
+              <a:t>🎤 Nathalia Neves (4ª) / Fernando Barreto (5ª)   |   </a:t>
+            </a:r>
+            <a:r>
+              <a:rPr sz="850">
+                <a:solidFill>
+                  <a:srgbClr val="94A3B8"/>
+                </a:solidFill>
+                <a:latin typeface="JetBrains Mono"/>
+              </a:rPr>
+              <a:t>📚 Fonte / Ref:  Porter, M. (1998); Freeman, C. (1987); Lundvall, B.-Å. (1992); Moore, J. F. (1993); Adner, R. (2006).</a:t>
+            </a:r>
+          </a:p>
+        </p:txBody>
+      </p:sp>
     </p:spTree>
   </p:cSld>
   <p:clrMapOvr>
@@ -17013,6 +18508,49 @@
           </a:p>
         </p:txBody>
       </p:sp>
+      <p:sp>
+        <p:nvSpPr>
+          <p:cNvPr id="6" name="TextBox 5"/>
+          <p:cNvSpPr txBox="1"/>
+          <p:nvPr/>
+        </p:nvSpPr>
+        <p:spPr>
+          <a:xfrm>
+            <a:off x="731520" y="6309360"/>
+            <a:ext cx="10728655" cy="411480"/>
+          </a:xfrm>
+          <a:prstGeom prst="rect">
+            <a:avLst/>
+          </a:prstGeom>
+          <a:noFill/>
+        </p:spPr>
+        <p:txBody>
+          <a:bodyPr wrap="square">
+            <a:spAutoFit/>
+          </a:bodyPr>
+          <a:lstStyle/>
+          <a:p>
+            <a:r>
+              <a:rPr sz="850" b="1">
+                <a:solidFill>
+                  <a:srgbClr val="3FD0E6"/>
+                </a:solidFill>
+                <a:latin typeface="JetBrains Mono"/>
+              </a:rPr>
+              <a:t>🎤 Nathalia Neves (4ª) / Fernando Barreto (5ª)   |   </a:t>
+            </a:r>
+            <a:r>
+              <a:rPr sz="850">
+                <a:solidFill>
+                  <a:srgbClr val="94A3B8"/>
+                </a:solidFill>
+                <a:latin typeface="JetBrains Mono"/>
+              </a:rPr>
+              <a:t>📚 Fonte / Ref:  Avaliação Formativa Síncrona • Banco de Questões GETI 2026 baseado em Moore (1993) e Shen et al. (2026).</a:t>
+            </a:r>
+          </a:p>
+        </p:txBody>
+      </p:sp>
     </p:spTree>
   </p:cSld>
   <p:clrMapOvr>
@@ -17272,6 +18810,49 @@
           </a:p>
         </p:txBody>
       </p:sp>
+      <p:sp>
+        <p:nvSpPr>
+          <p:cNvPr id="6" name="TextBox 5"/>
+          <p:cNvSpPr txBox="1"/>
+          <p:nvPr/>
+        </p:nvSpPr>
+        <p:spPr>
+          <a:xfrm>
+            <a:off x="731520" y="6309360"/>
+            <a:ext cx="10728655" cy="411480"/>
+          </a:xfrm>
+          <a:prstGeom prst="rect">
+            <a:avLst/>
+          </a:prstGeom>
+          <a:noFill/>
+        </p:spPr>
+        <p:txBody>
+          <a:bodyPr wrap="square">
+            <a:spAutoFit/>
+          </a:bodyPr>
+          <a:lstStyle/>
+          <a:p>
+            <a:r>
+              <a:rPr sz="850" b="1">
+                <a:solidFill>
+                  <a:srgbClr val="3FD0E6"/>
+                </a:solidFill>
+                <a:latin typeface="JetBrains Mono"/>
+              </a:rPr>
+              <a:t>🎤 Veridiany Braga (4ª) / Fábio Lippi (5ª)   |   </a:t>
+            </a:r>
+            <a:r>
+              <a:rPr sz="850">
+                <a:solidFill>
+                  <a:srgbClr val="94A3B8"/>
+                </a:solidFill>
+                <a:latin typeface="JetBrains Mono"/>
+              </a:rPr>
+              <a:t>📚 Fonte / Ref:  Machado, C. G., Faccin, K., &amp; Bitencourt, C. C. (2025); Granovetter, M. (1973). The Strength of Weak Ties. AJS.</a:t>
+            </a:r>
+          </a:p>
+        </p:txBody>
+      </p:sp>
     </p:spTree>
   </p:cSld>
   <p:clrMapOvr>
@@ -17527,6 +19108,49 @@
             </a:pPr>
             <a:r>
               <a:t>• Academia &amp;amp; ICTs</a:t>
+            </a:r>
+          </a:p>
+        </p:txBody>
+      </p:sp>
+      <p:sp>
+        <p:nvSpPr>
+          <p:cNvPr id="6" name="TextBox 5"/>
+          <p:cNvSpPr txBox="1"/>
+          <p:nvPr/>
+        </p:nvSpPr>
+        <p:spPr>
+          <a:xfrm>
+            <a:off x="731520" y="6309360"/>
+            <a:ext cx="10728655" cy="411480"/>
+          </a:xfrm>
+          <a:prstGeom prst="rect">
+            <a:avLst/>
+          </a:prstGeom>
+          <a:noFill/>
+        </p:spPr>
+        <p:txBody>
+          <a:bodyPr wrap="square">
+            <a:spAutoFit/>
+          </a:bodyPr>
+          <a:lstStyle/>
+          <a:p>
+            <a:r>
+              <a:rPr sz="850" b="1">
+                <a:solidFill>
+                  <a:srgbClr val="3FD0E6"/>
+                </a:solidFill>
+                <a:latin typeface="JetBrains Mono"/>
+              </a:rPr>
+              <a:t>🎤 Veridiany Braga (4ª) / Fábio Lippi (5ª)   |   </a:t>
+            </a:r>
+            <a:r>
+              <a:rPr sz="850">
+                <a:solidFill>
+                  <a:srgbClr val="94A3B8"/>
+                </a:solidFill>
+                <a:latin typeface="JetBrains Mono"/>
+              </a:rPr>
+              <a:t>📚 Fonte / Ref:  Etzkowitz, H. &amp; Leydesdorff, L. (2000). The dynamics of innovation; Carayannis, E. G. &amp; Campbell, D. F. (2009, 2012). Quintuple Innovation Helix.</a:t>
             </a:r>
           </a:p>
         </p:txBody>

</xml_diff>

<commit_message>
feat: align Lilian slides 24-32 strictly with her original PPTX visual hierarchy and hero infographics
</commit_message>
<xml_diff>
--- a/Seminario_5_Ecossistemas_Inovacao_Master.pptx
+++ b/Seminario_5_Ecossistemas_Inovacao_Master.pptx
@@ -11018,7 +11018,7 @@
               </a:defRPr>
             </a:pPr>
             <a:r>
-              <a:t>🌍 BLOCO 5 • BENCHMARKING INTERNACIONAL (1/9)</a:t>
+              <a:t>🌍 BLOCO 5 • O CASO DE SAN DIEGO (1/9)</a:t>
             </a:r>
           </a:p>
         </p:txBody>
@@ -11052,58 +11052,14 @@
                 </a:solidFill>
                 <a:latin typeface="Outfit"/>
               </a:rPr>
-              <a:t>San Diego no Radar Global: </a:t>
-            </a:r>
-            <a:r>
-              <a:rPr sz="2200" b="1">
-                <a:solidFill>
-                  <a:srgbClr val="3FD0E6"/>
-                </a:solidFill>
-                <a:latin typeface="Outfit"/>
-              </a:rPr>
-              <a:t>14º Maior Polo de Inovação do Mundo</a:t>
-            </a:r>
-          </a:p>
-        </p:txBody>
-      </p:sp>
-      <p:sp>
-        <p:nvSpPr>
-          <p:cNvPr id="4" name="TextBox 3"/>
-          <p:cNvSpPr txBox="1"/>
-          <p:nvPr/>
-        </p:nvSpPr>
-        <p:spPr>
-          <a:xfrm>
-            <a:off x="731520" y="1463040"/>
-            <a:ext cx="10698480" cy="594360"/>
-          </a:xfrm>
-          <a:prstGeom prst="rect">
-            <a:avLst/>
-          </a:prstGeom>
-          <a:noFill/>
-        </p:spPr>
-        <p:txBody>
-          <a:bodyPr wrap="square">
-            <a:spAutoFit/>
-          </a:bodyPr>
-          <a:lstStyle/>
-          <a:p>
-            <a:pPr>
-              <a:defRPr sz="1300" i="1">
-                <a:solidFill>
-                  <a:srgbClr val="FFFFFF"/>
-                </a:solidFill>
-              </a:defRPr>
-            </a:pPr>
-            <a:r>
-              <a:t>""San Diego é o 14º maior polo mundial de inovação (7º por intensidade populacional): 26.713 pedidos de patente PCT liderados pela Qualcomm e 19.862 artigos pela UCSD.""</a:t>
+              <a:t>O Caso de San Diego </a:t>
             </a:r>
           </a:p>
         </p:txBody>
       </p:sp>
       <p:pic>
         <p:nvPicPr>
-          <p:cNvPr id="5" name="Picture 4" descr="slide_1_img_2.png"/>
+          <p:cNvPr id="4" name="Picture 3" descr="slide_1_img_2.png"/>
           <p:cNvPicPr>
             <a:picLocks noChangeAspect="1"/>
           </p:cNvPicPr>
@@ -11117,8 +11073,32 @@
         </p:blipFill>
         <p:spPr>
           <a:xfrm>
-            <a:off x="731520" y="2148840"/>
-            <a:ext cx="5303520" cy="2819163"/>
+            <a:off x="731520" y="1463040"/>
+            <a:ext cx="6035040" cy="4389120"/>
+          </a:xfrm>
+          <a:prstGeom prst="rect">
+            <a:avLst/>
+          </a:prstGeom>
+        </p:spPr>
+      </p:pic>
+      <p:pic>
+        <p:nvPicPr>
+          <p:cNvPr id="5" name="Picture 4" descr="slide_1_img_3.png"/>
+          <p:cNvPicPr>
+            <a:picLocks noChangeAspect="1"/>
+          </p:cNvPicPr>
+          <p:nvPr/>
+        </p:nvPicPr>
+        <p:blipFill>
+          <a:blip r:embed="rId3"/>
+          <a:stretch>
+            <a:fillRect/>
+          </a:stretch>
+        </p:blipFill>
+        <p:spPr>
+          <a:xfrm>
+            <a:off x="822960" y="3474720"/>
+            <a:ext cx="2286000" cy="1729362"/>
           </a:xfrm>
           <a:prstGeom prst="rect">
             <a:avLst/>
@@ -11134,15 +11114,15 @@
           <p:nvPr/>
         </p:nvPicPr>
         <p:blipFill>
-          <a:blip r:embed="rId3"/>
+          <a:blip r:embed="rId4"/>
           <a:stretch>
             <a:fillRect/>
           </a:stretch>
         </p:blipFill>
         <p:spPr>
           <a:xfrm>
-            <a:off x="6217920" y="2148840"/>
-            <a:ext cx="5212080" cy="4104042"/>
+            <a:off x="6949440" y="1463040"/>
+            <a:ext cx="4480560" cy="4389120"/>
           </a:xfrm>
           <a:prstGeom prst="rect">
             <a:avLst/>
@@ -11187,7 +11167,7 @@
                 </a:solidFill>
                 <a:latin typeface="JetBrains Mono"/>
               </a:rPr>
-              <a:t>📚 Fonte / Ref:  WIPO (2025). Global Innovation Index 2025: S&amp;T Clusters Ranking (San Diego, 14th); Majava &amp; Rinkinen (2026).</a:t>
+              <a:t>📚 Fonte / Ref:  Global Innovation Index 2025 (WIPO); Jukka Majava &amp; Satu Rinkinen (2026). Twenty years, twenty studies: what can we learn from San Diego’s innovation ecosystem?</a:t>
             </a:r>
           </a:p>
         </p:txBody>
@@ -11249,7 +11229,7 @@
               </a:defRPr>
             </a:pPr>
             <a:r>
-              <a:t>🧬 BLOCO 5 • CONCEITO &amp; GÊNESE (2/9)</a:t>
+              <a:t>🧬 BLOCO 5 • CONCEITO &amp; FUNDAMENTOS (2/9)</a:t>
             </a:r>
           </a:p>
         </p:txBody>
@@ -11283,16 +11263,7 @@
                 </a:solidFill>
                 <a:latin typeface="Outfit"/>
               </a:rPr>
-              <a:t>O que é um Ecossistema? </a:t>
-            </a:r>
-            <a:r>
-              <a:rPr sz="2200" b="1">
-                <a:solidFill>
-                  <a:srgbClr val="3FD0E6"/>
-                </a:solidFill>
-                <a:latin typeface="Outfit"/>
-              </a:rPr>
-              <a:t>Os 6 Pontos-Chave de San Diego</a:t>
+              <a:t>O que é um ecossistema de inovação? </a:t>
             </a:r>
           </a:p>
         </p:txBody>
@@ -11305,8 +11276,8 @@
         </p:nvSpPr>
         <p:spPr>
           <a:xfrm>
-            <a:off x="731520" y="1463040"/>
-            <a:ext cx="10698480" cy="594360"/>
+            <a:off x="731520" y="1371600"/>
+            <a:ext cx="10698480" cy="1097280"/>
           </a:xfrm>
           <a:prstGeom prst="rect">
             <a:avLst/>
@@ -11327,15 +11298,19 @@
               </a:defRPr>
             </a:pPr>
             <a:r>
-              <a:t>""É conjunto dinâmico e em evolução de atores, instituições, atividades e relações complementares que impulsionam o desempenho inovador."</a:t>
-            </a:r>
-            <a:br/>
-            <a:r>
-              <a:t>          </a:t>
-            </a:r>
-            <a:br/>
-            <a:r>
-              <a:t>            — Jukka Majava &amp; Satu Rinkinen (2024/2026) • Twenty years, twenty studies: what can we learn from San Diego’s innovation ecosystem? (Tech. Analysis &amp; Strategic Management, 38:1)"</a:t>
+              <a:t>"É conjunto dinâmico e em evolução de atores, instituições, atividades e relações complementares que impulsionam o desempenho inovador."</a:t>
+            </a:r>
+          </a:p>
+          <a:p>
+            <a:pPr>
+              <a:defRPr sz="1000">
+                <a:solidFill>
+                  <a:srgbClr val="3FD0E6"/>
+                </a:solidFill>
+              </a:defRPr>
+            </a:pPr>
+            <a:r>
+              <a:t>— Jukka Majava &amp; Satu Rinkinen (2026), Technology Analysis &amp; Strategic Management, 38:1, 49-64.</a:t>
             </a:r>
           </a:p>
         </p:txBody>
@@ -11348,8 +11323,8 @@
         </p:nvSpPr>
         <p:spPr>
           <a:xfrm>
-            <a:off x="731520" y="2148840"/>
-            <a:ext cx="10698480" cy="4114800"/>
+            <a:off x="731520" y="2651760"/>
+            <a:ext cx="5212080" cy="3291840"/>
           </a:xfrm>
           <a:prstGeom prst="rect">
             <a:avLst/>
@@ -11363,123 +11338,42 @@
           <a:lstStyle/>
           <a:p>
             <a:pPr>
-              <a:defRPr sz="1400" b="1">
-                <a:solidFill>
-                  <a:srgbClr val="3FD0E6"/>
-                </a:solidFill>
-              </a:defRPr>
-            </a:pPr>
-            <a:r>
-              <a:t>Os 6 Pontos-Chave de San Diego (Majava &amp; Rinkinen, 2024/2026):</a:t>
-            </a:r>
-          </a:p>
-          <a:p>
-            <a:r>
-              <a:rPr b="1" sz="1200">
+              <a:defRPr sz="1200" b="1">
                 <a:solidFill>
                   <a:srgbClr val="FFFFFF"/>
                 </a:solidFill>
-              </a:rPr>
-              <a:t>• 1º Ponto: Universidade com Pesquisa de Ponta: </a:t>
-            </a:r>
-            <a:r>
-              <a:rPr sz="1100">
-                <a:solidFill>
-                  <a:srgbClr val="94A3B8"/>
-                </a:solidFill>
-              </a:rPr>
-              <a:t>Fundação da UCSD nos anos 60 com foco em biologia e ciências, atraindo VCs e multinacionais.</a:t>
-            </a:r>
-          </a:p>
-          <a:p>
-            <a:r>
-              <a:rPr b="1" sz="1200">
+              </a:defRPr>
+            </a:pPr>
+            <a:r>
+              <a:t>▸ 1º. Ponto: UNIVERSIDADE COM PESQUISA DE PONTA, ATRAÇÃO DE EMPRESAS</a:t>
+            </a:r>
+            <a:br/>
+          </a:p>
+          <a:p>
+            <a:pPr>
+              <a:defRPr sz="1200" b="1">
                 <a:solidFill>
                   <a:srgbClr val="FFFFFF"/>
                 </a:solidFill>
-              </a:rPr>
-              <a:t>• 2º Ponto: Antecedentes Históricos &amp; Vocação: </a:t>
-            </a:r>
-            <a:r>
-              <a:rPr sz="1100">
-                <a:solidFill>
-                  <a:srgbClr val="94A3B8"/>
-                </a:solidFill>
-              </a:rPr>
-              <a:t>Investimento prévio em hospitais e clínicas; isolamento geográfico que impediu indústrias pesadas.</a:t>
-            </a:r>
-          </a:p>
-          <a:p>
-            <a:r>
-              <a:rPr b="1" sz="1200">
+              </a:defRPr>
+            </a:pPr>
+            <a:r>
+              <a:t>▸ 2º. Ponto: ANTECEDENTES HISTÓRICOS, VOCAÇÃO DA CIDADE</a:t>
+            </a:r>
+            <a:br/>
+          </a:p>
+          <a:p>
+            <a:pPr>
+              <a:defRPr sz="1200" b="1">
                 <a:solidFill>
                   <a:srgbClr val="FFFFFF"/>
                 </a:solidFill>
-              </a:rPr>
-              <a:t>• 3º Ponto: Decisões Políticas para Favorecer: </a:t>
-            </a:r>
-            <a:r>
-              <a:rPr sz="1100">
-                <a:solidFill>
-                  <a:srgbClr val="94A3B8"/>
-                </a:solidFill>
-              </a:rPr>
-              <a:t>Zoneamento urbano nos anos 70 garantindo proximidade física entre UCSD, institutos e empresas.</a:t>
-            </a:r>
-          </a:p>
-          <a:p>
-            <a:r>
-              <a:rPr b="1" sz="1200">
-                <a:solidFill>
-                  <a:srgbClr val="FFFFFF"/>
-                </a:solidFill>
-              </a:rPr>
-              <a:t>• 4º Ponto: Contingências que Geram Ações: </a:t>
-            </a:r>
-            <a:r>
-              <a:rPr sz="1100">
-                <a:solidFill>
-                  <a:srgbClr val="94A3B8"/>
-                </a:solidFill>
-              </a:rPr>
-              <a:t>Crise na indústria militar pós-Guerra Fria elevou desemprego, forçando reconversão em biotec e telecom.</a:t>
-            </a:r>
-          </a:p>
-          <a:p>
-            <a:r>
-              <a:rPr b="1" sz="1200">
-                <a:solidFill>
-                  <a:srgbClr val="FFFFFF"/>
-                </a:solidFill>
-              </a:rPr>
-              <a:t>• 5º Ponto: Instituição Mediadora (Orquestrador): </a:t>
-            </a:r>
-            <a:r>
-              <a:rPr sz="1100">
-                <a:solidFill>
-                  <a:srgbClr val="94A3B8"/>
-                </a:solidFill>
-              </a:rPr>
-              <a:t>Criação da CONNECT (1985) na UCSD: aceleradora Springboard, mentoria e laços de confiança.</a:t>
-            </a:r>
-          </a:p>
-          <a:p>
-            <a:r>
-              <a:rPr b="1" sz="1200">
-                <a:solidFill>
-                  <a:srgbClr val="FFFFFF"/>
-                </a:solidFill>
-              </a:rPr>
-              <a:t>• 6º Ponto: Proximidade Geográfica dos Atores: </a:t>
-            </a:r>
-            <a:r>
-              <a:rPr sz="1100">
-                <a:solidFill>
-                  <a:srgbClr val="94A3B8"/>
-                </a:solidFill>
-              </a:rPr>
-              <a:t>Distâncias curtas que facilitaram encontros de corredor, compartilhamento de conhecimento tácito.</a:t>
-            </a:r>
+              </a:defRPr>
+            </a:pPr>
+            <a:r>
+              <a:t>▸ 3º. Ponto: DECISÕES POLÍTICAS PARA FAVORECER O ECOSSISTEMA</a:t>
+            </a:r>
+            <a:br/>
           </a:p>
         </p:txBody>
       </p:sp>
@@ -11491,8 +11385,8 @@
         </p:nvSpPr>
         <p:spPr>
           <a:xfrm>
-            <a:off x="731520" y="6309360"/>
-            <a:ext cx="10728655" cy="411480"/>
+            <a:off x="6217920" y="2651760"/>
+            <a:ext cx="5212080" cy="3291840"/>
           </a:xfrm>
           <a:prstGeom prst="rect">
             <a:avLst/>
@@ -11505,6 +11399,68 @@
           </a:bodyPr>
           <a:lstStyle/>
           <a:p>
+            <a:pPr>
+              <a:defRPr sz="1200" b="1">
+                <a:solidFill>
+                  <a:srgbClr val="FFFFFF"/>
+                </a:solidFill>
+              </a:defRPr>
+            </a:pPr>
+            <a:r>
+              <a:t>▸ 4º Ponto: CONTINGENCIAS QUE GERAM AÇÕES</a:t>
+            </a:r>
+            <a:br/>
+          </a:p>
+          <a:p>
+            <a:pPr>
+              <a:defRPr sz="1200" b="1">
+                <a:solidFill>
+                  <a:srgbClr val="FFFFFF"/>
+                </a:solidFill>
+              </a:defRPr>
+            </a:pPr>
+            <a:r>
+              <a:t>▸ 5º. Ponto: INSTITUIÇÃO MEDIADORA PARA PROPORCIONAR RELACIONAMENTOS ENTRE ATORES</a:t>
+            </a:r>
+            <a:br/>
+          </a:p>
+          <a:p>
+            <a:pPr>
+              <a:defRPr sz="1200" b="1">
+                <a:solidFill>
+                  <a:srgbClr val="FFFFFF"/>
+                </a:solidFill>
+              </a:defRPr>
+            </a:pPr>
+            <a:r>
+              <a:t>▸ 6º Ponto: PROXIMIDADE GEOGRÁFICA DOS ATORES</a:t>
+            </a:r>
+            <a:br/>
+          </a:p>
+        </p:txBody>
+      </p:sp>
+      <p:sp>
+        <p:nvSpPr>
+          <p:cNvPr id="7" name="TextBox 6"/>
+          <p:cNvSpPr txBox="1"/>
+          <p:nvPr/>
+        </p:nvSpPr>
+        <p:spPr>
+          <a:xfrm>
+            <a:off x="731520" y="6309360"/>
+            <a:ext cx="10728655" cy="411480"/>
+          </a:xfrm>
+          <a:prstGeom prst="rect">
+            <a:avLst/>
+          </a:prstGeom>
+          <a:noFill/>
+        </p:spPr>
+        <p:txBody>
+          <a:bodyPr wrap="square">
+            <a:spAutoFit/>
+          </a:bodyPr>
+          <a:lstStyle/>
+          <a:p>
             <a:r>
               <a:rPr sz="850" b="1">
                 <a:solidFill>
@@ -11521,7 +11477,7 @@
                 </a:solidFill>
                 <a:latin typeface="JetBrains Mono"/>
               </a:rPr>
-              <a:t>📚 Fonte / Ref:  Majava, J. &amp; Rinkinen, S. (2024/2026). Twenty years, twenty studies: what can we learn from San Diego’s innovation ecosystem? Technology Analysis &amp; Strategic Management, 38(1), 49-64.</a:t>
+              <a:t>📚 Fonte / Ref:  Majava, J. &amp;amp; Rinkinen, S. (2026). Twenty years, twenty studies: what can we learn from San Diego’s innovation ecosystem?, Technology Analysis &amp;amp; Strategic Management, 38:1, 49-64.</a:t>
             </a:r>
           </a:p>
         </p:txBody>
@@ -11617,7 +11573,7 @@
                 </a:solidFill>
                 <a:latin typeface="Outfit"/>
               </a:rPr>
-              <a:t>CONNECT: A Engenharia da Confiança </a:t>
+              <a:t>ECOSSISTEMAS DE INOVAÇÃO • </a:t>
             </a:r>
             <a:r>
               <a:rPr sz="2200" b="1">
@@ -11626,49 +11582,14 @@
                 </a:solidFill>
                 <a:latin typeface="Outfit"/>
               </a:rPr>
-              <a:t>A Ponte entre Ciência e Capital</a:t>
-            </a:r>
-          </a:p>
-        </p:txBody>
-      </p:sp>
-      <p:sp>
-        <p:nvSpPr>
-          <p:cNvPr id="4" name="TextBox 3"/>
-          <p:cNvSpPr txBox="1"/>
-          <p:nvPr/>
-        </p:nvSpPr>
-        <p:spPr>
-          <a:xfrm>
-            <a:off x="731520" y="1463040"/>
-            <a:ext cx="10698480" cy="594360"/>
-          </a:xfrm>
-          <a:prstGeom prst="rect">
-            <a:avLst/>
-          </a:prstGeom>
-          <a:noFill/>
-        </p:spPr>
-        <p:txBody>
-          <a:bodyPr wrap="square">
-            <a:spAutoFit/>
-          </a:bodyPr>
-          <a:lstStyle/>
-          <a:p>
-            <a:pPr>
-              <a:defRPr sz="1300" i="1">
-                <a:solidFill>
-                  <a:srgbClr val="FFFFFF"/>
-                </a:solidFill>
-              </a:defRPr>
-            </a:pPr>
-            <a:r>
-              <a:t>""Criada de baixo para cima (Bottom-Up) na UCSD em resposta à crise militar, a CONNECT reduziu a assimetria entre as 'ideias' dos cientistas e as 'regras' dos negócios.""</a:t>
+              <a:t>O Caso de San Diego</a:t>
             </a:r>
           </a:p>
         </p:txBody>
       </p:sp>
       <p:pic>
         <p:nvPicPr>
-          <p:cNvPr id="5" name="Picture 4" descr="slide_3_img_1.png"/>
+          <p:cNvPr id="4" name="Picture 3" descr="slide_3_img_1.png"/>
           <p:cNvPicPr>
             <a:picLocks noChangeAspect="1"/>
           </p:cNvPicPr>
@@ -11682,8 +11603,8 @@
         </p:blipFill>
         <p:spPr>
           <a:xfrm>
-            <a:off x="1371600" y="2148840"/>
-            <a:ext cx="9418320" cy="5256737"/>
+            <a:off x="1097280" y="1371600"/>
+            <a:ext cx="9966960" cy="4663440"/>
           </a:xfrm>
           <a:prstGeom prst="rect">
             <a:avLst/>
@@ -11692,7 +11613,7 @@
       </p:pic>
       <p:sp>
         <p:nvSpPr>
-          <p:cNvPr id="6" name="TextBox 5"/>
+          <p:cNvPr id="5" name="TextBox 4"/>
           <p:cNvSpPr txBox="1"/>
           <p:nvPr/>
         </p:nvSpPr>
@@ -11728,7 +11649,7 @@
                 </a:solidFill>
                 <a:latin typeface="JetBrains Mono"/>
               </a:rPr>
-              <a:t>📚 Fonte / Ref:  Majava, J. &amp; Rinkinen, S. (2024/2026); Walshok, M. L. &amp; Shragge, A. (2014). Invention and Reinvention: The Evolution of San Diego's Innovation Economy.</a:t>
+              <a:t>📚 Fonte / Ref:  Jukka Majava &amp;amp; Satu Rinkinen (2026); Walshok, M. L. &amp;amp; Shragge, A. (2014). Invention and Reinvention: The Evolution of San Diego's Innovation Economy.</a:t>
             </a:r>
           </a:p>
         </p:txBody>
@@ -11824,7 +11745,7 @@
                 </a:solidFill>
                 <a:latin typeface="Outfit"/>
               </a:rPr>
-              <a:t>Análise PEST: O Radar de Sucesso </a:t>
+              <a:t>ECOSSISTEMAS DE INOVAÇÃO • </a:t>
             </a:r>
             <a:r>
               <a:rPr sz="2200" b="1">
@@ -11833,7 +11754,7 @@
                 </a:solidFill>
                 <a:latin typeface="Outfit"/>
               </a:rPr>
-              <a:t>As Forças que Impulsionaram San Diego</a:t>
+              <a:t>O Caso de San Diego</a:t>
             </a:r>
           </a:p>
         </p:txBody>
@@ -11854,8 +11775,8 @@
         </p:blipFill>
         <p:spPr>
           <a:xfrm>
-            <a:off x="1371600" y="1463040"/>
-            <a:ext cx="9418320" cy="5256737"/>
+            <a:off x="1097280" y="1371600"/>
+            <a:ext cx="9966960" cy="4663440"/>
           </a:xfrm>
           <a:prstGeom prst="rect">
             <a:avLst/>
@@ -11900,7 +11821,7 @@
                 </a:solidFill>
                 <a:latin typeface="JetBrains Mono"/>
               </a:rPr>
-              <a:t>📚 Fonte / Ref:  Majava, J. &amp; Rinkinen, S. (2024/2026). PEST Analysis of the San Diego Innovation Ecosystem.</a:t>
+              <a:t>📚 Fonte / Ref:  Jukka Majava &amp;amp; Satu Rinkinen (2026). Twenty years, twenty studies: what can we learn from San Diego’s innovation ecosystem? (Tech. Analysis &amp;amp; Strat. Mgmt.).</a:t>
             </a:r>
           </a:p>
         </p:txBody>
@@ -11996,7 +11917,7 @@
                 </a:solidFill>
                 <a:latin typeface="Outfit"/>
               </a:rPr>
-              <a:t>São José dos Campos: A Gênese de uma Vocação </a:t>
+              <a:t>ECOSSISTEMAS DE INOVAÇÃO • </a:t>
             </a:r>
             <a:r>
               <a:rPr sz="2200" b="1">
@@ -12005,49 +11926,14 @@
                 </a:solidFill>
                 <a:latin typeface="Outfit"/>
               </a:rPr>
-              <a:t>Planejamento de Estado &amp; Instituições-Âncora</a:t>
-            </a:r>
-          </a:p>
-        </p:txBody>
-      </p:sp>
-      <p:sp>
-        <p:nvSpPr>
-          <p:cNvPr id="4" name="TextBox 3"/>
-          <p:cNvSpPr txBox="1"/>
-          <p:nvPr/>
-        </p:nvSpPr>
-        <p:spPr>
-          <a:xfrm>
-            <a:off x="731520" y="1463040"/>
-            <a:ext cx="10698480" cy="594360"/>
-          </a:xfrm>
-          <a:prstGeom prst="rect">
-            <a:avLst/>
-          </a:prstGeom>
-          <a:noFill/>
-        </p:spPr>
-        <p:txBody>
-          <a:bodyPr wrap="square">
-            <a:spAutoFit/>
-          </a:bodyPr>
-          <a:lstStyle/>
-          <a:p>
-            <a:pPr>
-              <a:defRPr sz="1300" i="1">
-                <a:solidFill>
-                  <a:srgbClr val="FFFFFF"/>
-                </a:solidFill>
-              </a:defRPr>
-            </a:pPr>
-            <a:r>
-              <a:t>""Na ausência de capital de risco privado no Brasil dos anos 50/60, o poder de compra estatal do Ministério da Aeronáutica atuou como indutor, viabilizando a Embraer e fornecedores locais.""</a:t>
+              <a:t>O Caso de São José dos Campos</a:t>
             </a:r>
           </a:p>
         </p:txBody>
       </p:sp>
       <p:pic>
         <p:nvPicPr>
-          <p:cNvPr id="5" name="Picture 4" descr="slide_5_img_1.png"/>
+          <p:cNvPr id="4" name="Picture 3" descr="slide_5_img_1.png"/>
           <p:cNvPicPr>
             <a:picLocks noChangeAspect="1"/>
           </p:cNvPicPr>
@@ -12061,8 +11947,8 @@
         </p:blipFill>
         <p:spPr>
           <a:xfrm>
-            <a:off x="731520" y="2148840"/>
-            <a:ext cx="5486400" cy="3062177"/>
+            <a:off x="1097280" y="1371600"/>
+            <a:ext cx="9966960" cy="4663440"/>
           </a:xfrm>
           <a:prstGeom prst="rect">
             <a:avLst/>
@@ -12071,14 +11957,14 @@
       </p:pic>
       <p:sp>
         <p:nvSpPr>
-          <p:cNvPr id="6" name="TextBox 5"/>
+          <p:cNvPr id="5" name="TextBox 4"/>
           <p:cNvSpPr txBox="1"/>
           <p:nvPr/>
         </p:nvSpPr>
         <p:spPr>
           <a:xfrm>
-            <a:off x="6400800" y="2148840"/>
-            <a:ext cx="5029200" cy="4114800"/>
+            <a:off x="731520" y="6309360"/>
+            <a:ext cx="10728655" cy="411480"/>
           </a:xfrm>
           <a:prstGeom prst="rect">
             <a:avLst/>
@@ -12091,98 +11977,6 @@
           </a:bodyPr>
           <a:lstStyle/>
           <a:p>
-            <a:pPr>
-              <a:defRPr sz="1400" b="1">
-                <a:solidFill>
-                  <a:srgbClr val="3FD0E6"/>
-                </a:solidFill>
-              </a:defRPr>
-            </a:pPr>
-            <a:r>
-              <a:t>Fatores Estruturantes de São José dos Campos:</a:t>
-            </a:r>
-          </a:p>
-          <a:p>
-            <a:r>
-              <a:rPr b="1" sz="1200">
-                <a:solidFill>
-                  <a:srgbClr val="10B981"/>
-                </a:solidFill>
-              </a:rPr>
-              <a:t>
-▸ Fatores Atrativos Originais (Anos 50): </a:t>
-            </a:r>
-            <a:r>
-              <a:rPr sz="1100">
-                <a:solidFill>
-                  <a:srgbClr val="94A3B8"/>
-                </a:solidFill>
-              </a:rPr>
-              <a:t>Localização no Eixo Rio-SP (Via Dutra), energia elétrica abundante, recursos hídricos e relevo plano.</a:t>
-            </a:r>
-          </a:p>
-          <a:p>
-            <a:r>
-              <a:rPr b="1" sz="1200">
-                <a:solidFill>
-                  <a:srgbClr val="10B981"/>
-                </a:solidFill>
-              </a:rPr>
-              <a:t>
-▸ Instituições-Âncora Estratégicas: </a:t>
-            </a:r>
-            <a:r>
-              <a:rPr sz="1100">
-                <a:solidFill>
-                  <a:srgbClr val="94A3B8"/>
-                </a:solidFill>
-              </a:rPr>
-              <a:t>CTA e ITA criados nos anos 50 baseados no MIT; INPE criado em 1961 formando elite em P&amp;D aeroespacial e defesa.</a:t>
-            </a:r>
-          </a:p>
-          <a:p>
-            <a:r>
-              <a:rPr b="1" sz="1200">
-                <a:solidFill>
-                  <a:srgbClr val="10B981"/>
-                </a:solidFill>
-              </a:rPr>
-              <a:t>
-▸ O Poder de Compra Estatal: </a:t>
-            </a:r>
-            <a:r>
-              <a:rPr sz="1100">
-                <a:solidFill>
-                  <a:srgbClr val="94A3B8"/>
-                </a:solidFill>
-              </a:rPr>
-              <a:t>Na ausência de Venture Capital, as encomendas do Ministério da Aeronáutica viabilizaram a Embraer, Avibras e fornecedores nacionais.</a:t>
-            </a:r>
-          </a:p>
-        </p:txBody>
-      </p:sp>
-      <p:sp>
-        <p:nvSpPr>
-          <p:cNvPr id="7" name="TextBox 6"/>
-          <p:cNvSpPr txBox="1"/>
-          <p:nvPr/>
-        </p:nvSpPr>
-        <p:spPr>
-          <a:xfrm>
-            <a:off x="731520" y="6309360"/>
-            <a:ext cx="10728655" cy="411480"/>
-          </a:xfrm>
-          <a:prstGeom prst="rect">
-            <a:avLst/>
-          </a:prstGeom>
-          <a:noFill/>
-        </p:spPr>
-        <p:txBody>
-          <a:bodyPr wrap="square">
-            <a:spAutoFit/>
-          </a:bodyPr>
-          <a:lstStyle/>
-          <a:p>
             <a:r>
               <a:rPr sz="850" b="1">
                 <a:solidFill>
@@ -12199,7 +11993,7 @@
                 </a:solidFill>
                 <a:latin typeface="JetBrains Mono"/>
               </a:rPr>
-              <a:t>📚 Fonte / Ref:  Rubem, T. C. (2018). Políticas de inovação, parques tecnológicos e a importância do território. Anais Unicamp; Silva, O. (1998). A Decolagem de um Sonho.</a:t>
+              <a:t>📚 Fonte / Ref:  Rubem, Thiago Chiquetto (2018). Políticas de inovação, parques tecnológicos e a importância do território: o caso do PIT SJC; Silva, Ozires (1998).</a:t>
             </a:r>
           </a:p>
         </p:txBody>
@@ -12295,7 +12089,7 @@
                 </a:solidFill>
                 <a:latin typeface="Outfit"/>
               </a:rPr>
-              <a:t>A Evolução Tipológica: De Orgânico à Orquestração </a:t>
+              <a:t>ECOSSISTEMAS DE INOVAÇÃO • </a:t>
             </a:r>
             <a:r>
               <a:rPr sz="2200" b="1">
@@ -12304,49 +12098,14 @@
                 </a:solidFill>
                 <a:latin typeface="Outfit"/>
               </a:rPr>
-              <a:t>Da Proximidade Física à Gestão Formal do PIT</a:t>
-            </a:r>
-          </a:p>
-        </p:txBody>
-      </p:sp>
-      <p:sp>
-        <p:nvSpPr>
-          <p:cNvPr id="4" name="TextBox 3"/>
-          <p:cNvSpPr txBox="1"/>
-          <p:nvPr/>
-        </p:nvSpPr>
-        <p:spPr>
-          <a:xfrm>
-            <a:off x="731520" y="1463040"/>
-            <a:ext cx="10698480" cy="594360"/>
-          </a:xfrm>
-          <a:prstGeom prst="rect">
-            <a:avLst/>
-          </a:prstGeom>
-          <a:noFill/>
-        </p:spPr>
-        <p:txBody>
-          <a:bodyPr wrap="square">
-            <a:spAutoFit/>
-          </a:bodyPr>
-          <a:lstStyle/>
-          <a:p>
-            <a:pPr>
-              <a:defRPr sz="1300" i="1">
-                <a:solidFill>
-                  <a:srgbClr val="FFFFFF"/>
-                </a:solidFill>
-              </a:defRPr>
-            </a:pPr>
-            <a:r>
-              <a:t>""Da dificuldade histórica de acesso da indústria aos laboratórios de P&amp;D para a gestão orquestrada de inovação de 25 milhões de m².""</a:t>
+              <a:t>O Caso de São José dos Campos</a:t>
             </a:r>
           </a:p>
         </p:txBody>
       </p:sp>
       <p:pic>
         <p:nvPicPr>
-          <p:cNvPr id="5" name="Picture 4" descr="slide_6_img_1.png"/>
+          <p:cNvPr id="4" name="Picture 3" descr="slide_6_img_1.png"/>
           <p:cNvPicPr>
             <a:picLocks noChangeAspect="1"/>
           </p:cNvPicPr>
@@ -12360,8 +12119,8 @@
         </p:blipFill>
         <p:spPr>
           <a:xfrm>
-            <a:off x="1371600" y="2148840"/>
-            <a:ext cx="9418320" cy="5256737"/>
+            <a:off x="1097280" y="1371600"/>
+            <a:ext cx="9966960" cy="4663440"/>
           </a:xfrm>
           <a:prstGeom prst="rect">
             <a:avLst/>
@@ -12370,7 +12129,7 @@
       </p:pic>
       <p:sp>
         <p:nvSpPr>
-          <p:cNvPr id="6" name="TextBox 5"/>
+          <p:cNvPr id="5" name="TextBox 4"/>
           <p:cNvSpPr txBox="1"/>
           <p:nvPr/>
         </p:nvSpPr>
@@ -12406,7 +12165,7 @@
                 </a:solidFill>
                 <a:latin typeface="JetBrains Mono"/>
               </a:rPr>
-              <a:t>📚 Fonte / Ref:  Rubem, T. C. (2018); Spolidoro, R. (1997). Tipologia de polos tecnológicos; APTSJC (2025).</a:t>
+              <a:t>📚 Fonte / Ref:  Rubem, Thiago Chiquetto (2018); Spolidoro, R. (1997). Tipologia de polos tecnológicos; Relatório de Atividades PIT (2025).</a:t>
             </a:r>
           </a:p>
         </p:txBody>
@@ -12804,58 +12563,14 @@
                 </a:solidFill>
                 <a:latin typeface="Outfit"/>
               </a:rPr>
-              <a:t>O PIT SJC: Governança e Território </a:t>
-            </a:r>
-            <a:r>
-              <a:rPr sz="2200" b="1">
-                <a:solidFill>
-                  <a:srgbClr val="3FD0E6"/>
-                </a:solidFill>
-                <a:latin typeface="Outfit"/>
-              </a:rPr>
-              <a:t>Relatório Anual 2025 &amp; Políticas de Inovação</a:t>
-            </a:r>
-          </a:p>
-        </p:txBody>
-      </p:sp>
-      <p:sp>
-        <p:nvSpPr>
-          <p:cNvPr id="4" name="TextBox 3"/>
-          <p:cNvSpPr txBox="1"/>
-          <p:nvPr/>
-        </p:nvSpPr>
-        <p:spPr>
-          <a:xfrm>
-            <a:off x="731520" y="1463040"/>
-            <a:ext cx="10698480" cy="594360"/>
-          </a:xfrm>
-          <a:prstGeom prst="rect">
-            <a:avLst/>
-          </a:prstGeom>
-          <a:noFill/>
-        </p:spPr>
-        <p:txBody>
-          <a:bodyPr wrap="square">
-            <a:spAutoFit/>
-          </a:bodyPr>
-          <a:lstStyle/>
-          <a:p>
-            <a:pPr>
-              <a:defRPr sz="1300" i="1">
-                <a:solidFill>
-                  <a:srgbClr val="FFFFFF"/>
-                </a:solidFill>
-              </a:defRPr>
-            </a:pPr>
-            <a:r>
-              <a:t>""Spill-overs territoriais: em áreas de grande aglomeração, a proximidade física catalisa o transbordamento espontâneo de conhecimento tácito e sinergia." — Thiago Chiquetto Rubem (2018)"</a:t>
+              <a:t>O PIT SJC </a:t>
             </a:r>
           </a:p>
         </p:txBody>
       </p:sp>
       <p:pic>
         <p:nvPicPr>
-          <p:cNvPr id="5" name="Picture 4" descr="slide_7_img_2.png"/>
+          <p:cNvPr id="4" name="Picture 3" descr="slide_7_img_2.png"/>
           <p:cNvPicPr>
             <a:picLocks noChangeAspect="1"/>
           </p:cNvPicPr>
@@ -12869,8 +12584,8 @@
         </p:blipFill>
         <p:spPr>
           <a:xfrm>
-            <a:off x="731520" y="2148840"/>
-            <a:ext cx="5029200" cy="4304654"/>
+            <a:off x="3291840" y="1463040"/>
+            <a:ext cx="5577840" cy="4480560"/>
           </a:xfrm>
           <a:prstGeom prst="rect">
             <a:avLst/>
@@ -12879,14 +12594,14 @@
       </p:pic>
       <p:sp>
         <p:nvSpPr>
-          <p:cNvPr id="6" name="TextBox 5"/>
+          <p:cNvPr id="5" name="TextBox 4"/>
           <p:cNvSpPr txBox="1"/>
           <p:nvPr/>
         </p:nvSpPr>
         <p:spPr>
           <a:xfrm>
-            <a:off x="6035040" y="2148840"/>
-            <a:ext cx="5394960" cy="4114800"/>
+            <a:off x="731520" y="6309360"/>
+            <a:ext cx="10728655" cy="411480"/>
           </a:xfrm>
           <a:prstGeom prst="rect">
             <a:avLst/>
@@ -12899,117 +12614,6 @@
           </a:bodyPr>
           <a:lstStyle/>
           <a:p>
-            <a:pPr>
-              <a:defRPr sz="1400" b="1">
-                <a:solidFill>
-                  <a:srgbClr val="3FD0E6"/>
-                </a:solidFill>
-              </a:defRPr>
-            </a:pPr>
-            <a:r>
-              <a:t>Governança e Modelo de Operação do PIT SJC:</a:t>
-            </a:r>
-          </a:p>
-          <a:p>
-            <a:r>
-              <a:rPr b="1" sz="1200">
-                <a:solidFill>
-                  <a:srgbClr val="10B981"/>
-                </a:solidFill>
-              </a:rPr>
-              <a:t>
-▸ Gestão por Organização Social: </a:t>
-            </a:r>
-            <a:r>
-              <a:rPr sz="1100">
-                <a:solidFill>
-                  <a:srgbClr val="94A3B8"/>
-                </a:solidFill>
-              </a:rPr>
-              <a:t>Criado em 2009 pela Prefeitura de SJC; gerido pela APTSJC (OS privada sem fins lucrativos credenciada no SPTec/SPAI).</a:t>
-            </a:r>
-          </a:p>
-          <a:p>
-            <a:r>
-              <a:rPr b="1" sz="1200">
-                <a:solidFill>
-                  <a:srgbClr val="10B981"/>
-                </a:solidFill>
-              </a:rPr>
-              <a:t>
-▸ Superação do Gargalo de P&amp;D: </a:t>
-            </a:r>
-            <a:r>
-              <a:rPr sz="1100">
-                <a:solidFill>
-                  <a:srgbClr val="94A3B8"/>
-                </a:solidFill>
-              </a:rPr>
-              <a:t>56 projetos prospectados, 22 executados em 2025; acesso ampliado a 57 laboratórios parceiros multiusuários.</a:t>
-            </a:r>
-          </a:p>
-          <a:p>
-            <a:r>
-              <a:rPr b="1" sz="1200">
-                <a:solidFill>
-                  <a:srgbClr val="10B981"/>
-                </a:solidFill>
-              </a:rPr>
-              <a:t>
-▸ Os 5 Eixos da Matriz Pentagonal: </a:t>
-            </a:r>
-            <a:r>
-              <a:rPr sz="1100">
-                <a:solidFill>
-                  <a:srgbClr val="94A3B8"/>
-                </a:solidFill>
-              </a:rPr>
-              <a:t>Defesa e Aeroespacial, TIC, Agronegócio, Saúde/Biotecnologia e Mobilidade Urbana articulando a Tríplice Hélice central.</a:t>
-            </a:r>
-          </a:p>
-          <a:p>
-            <a:r>
-              <a:rPr b="1" sz="1200">
-                <a:solidFill>
-                  <a:srgbClr val="10B981"/>
-                </a:solidFill>
-              </a:rPr>
-              <a:t>
-▸ Spill-overs Territoriais (Thiago Rubem, 2018): </a:t>
-            </a:r>
-            <a:r>
-              <a:rPr sz="1100">
-                <a:solidFill>
-                  <a:srgbClr val="94A3B8"/>
-                </a:solidFill>
-              </a:rPr>
-              <a:t>A aglomeração física catalisa transbordamento espontâneo de conhecimento tácito e sinergia.</a:t>
-            </a:r>
-          </a:p>
-        </p:txBody>
-      </p:sp>
-      <p:sp>
-        <p:nvSpPr>
-          <p:cNvPr id="7" name="TextBox 6"/>
-          <p:cNvSpPr txBox="1"/>
-          <p:nvPr/>
-        </p:nvSpPr>
-        <p:spPr>
-          <a:xfrm>
-            <a:off x="731520" y="6309360"/>
-            <a:ext cx="10728655" cy="411480"/>
-          </a:xfrm>
-          <a:prstGeom prst="rect">
-            <a:avLst/>
-          </a:prstGeom>
-          <a:noFill/>
-        </p:spPr>
-        <p:txBody>
-          <a:bodyPr wrap="square">
-            <a:spAutoFit/>
-          </a:bodyPr>
-          <a:lstStyle/>
-          <a:p>
             <a:r>
               <a:rPr sz="850" b="1">
                 <a:solidFill>
@@ -13026,7 +12630,7 @@
                 </a:solidFill>
                 <a:latin typeface="JetBrains Mono"/>
               </a:rPr>
-              <a:t>📚 Fonte / Ref:  APTSJC (2025). Relatório Anual de Atividades; Rubem, T. C. (2018) sobre spill-overs territoriais no PIT SJC.</a:t>
+              <a:t>📚 Fonte / Ref:  RELATÓRIO ANUAL DE ATIVIDADES PIT 2025; RUBEM, Thiago Chiquetto. Políticas de inovação, parques tecnológicos e a importância do território: o caso do PIT SJC (2018).</a:t>
             </a:r>
           </a:p>
         </p:txBody>
@@ -13122,58 +12726,14 @@
                 </a:solidFill>
                 <a:latin typeface="Outfit"/>
               </a:rPr>
-              <a:t>O PIT SJC em 2026: Consolidação &amp; Parcerias </a:t>
-            </a:r>
-            <a:r>
-              <a:rPr sz="2200" b="1">
-                <a:solidFill>
-                  <a:srgbClr val="3FD0E6"/>
-                </a:solidFill>
-                <a:latin typeface="Outfit"/>
-              </a:rPr>
-              <a:t>Construção de Redes de Confiança e Diversificação</a:t>
-            </a:r>
-          </a:p>
-        </p:txBody>
-      </p:sp>
-      <p:sp>
-        <p:nvSpPr>
-          <p:cNvPr id="4" name="TextBox 3"/>
-          <p:cNvSpPr txBox="1"/>
-          <p:nvPr/>
-        </p:nvSpPr>
-        <p:spPr>
-          <a:xfrm>
-            <a:off x="731520" y="1463040"/>
-            <a:ext cx="10698480" cy="594360"/>
-          </a:xfrm>
-          <a:prstGeom prst="rect">
-            <a:avLst/>
-          </a:prstGeom>
-          <a:noFill/>
-        </p:spPr>
-        <p:txBody>
-          <a:bodyPr wrap="square">
-            <a:spAutoFit/>
-          </a:bodyPr>
-          <a:lstStyle/>
-          <a:p>
-            <a:pPr>
-              <a:defRPr sz="1300" i="1">
-                <a:solidFill>
-                  <a:srgbClr val="FFFFFF"/>
-                </a:solidFill>
-              </a:defRPr>
-            </a:pPr>
-            <a:r>
-              <a:t>""Parque Tecnológico não é mero empreendimento imobiliário: é um ambiente catalisador de confiança, pontes relacionais e encontros humanos." — Jeferson Cheriegate (Gazeta de SP, 2026)"</a:t>
+              <a:t>O PIT SJC </a:t>
             </a:r>
           </a:p>
         </p:txBody>
       </p:sp>
       <p:pic>
         <p:nvPicPr>
-          <p:cNvPr id="5" name="Picture 4" descr="slide_8_img_3.png"/>
+          <p:cNvPr id="4" name="Picture 3" descr="slide_8_img_3.png"/>
           <p:cNvPicPr>
             <a:picLocks noChangeAspect="1"/>
           </p:cNvPicPr>
@@ -13187,8 +12747,8 @@
         </p:blipFill>
         <p:spPr>
           <a:xfrm>
-            <a:off x="731520" y="2148840"/>
-            <a:ext cx="5669280" cy="2963862"/>
+            <a:off x="1005840" y="1463040"/>
+            <a:ext cx="10149840" cy="4480560"/>
           </a:xfrm>
           <a:prstGeom prst="rect">
             <a:avLst/>
@@ -13197,14 +12757,14 @@
       </p:pic>
       <p:sp>
         <p:nvSpPr>
-          <p:cNvPr id="6" name="TextBox 5"/>
+          <p:cNvPr id="5" name="TextBox 4"/>
           <p:cNvSpPr txBox="1"/>
           <p:nvPr/>
         </p:nvSpPr>
         <p:spPr>
           <a:xfrm>
-            <a:off x="6583680" y="2148840"/>
-            <a:ext cx="4846320" cy="4114800"/>
+            <a:off x="731520" y="6309360"/>
+            <a:ext cx="10728655" cy="411480"/>
           </a:xfrm>
           <a:prstGeom prst="rect">
             <a:avLst/>
@@ -13217,117 +12777,6 @@
           </a:bodyPr>
           <a:lstStyle/>
           <a:p>
-            <a:pPr>
-              <a:defRPr sz="1400" b="1">
-                <a:solidFill>
-                  <a:srgbClr val="3FD0E6"/>
-                </a:solidFill>
-              </a:defRPr>
-            </a:pPr>
-            <a:r>
-              <a:t>Expansão dos APLs &amp; Nexus Hub em 2026:</a:t>
-            </a:r>
-          </a:p>
-          <a:p>
-            <a:r>
-              <a:rPr b="1" sz="1200">
-                <a:solidFill>
-                  <a:srgbClr val="10B981"/>
-                </a:solidFill>
-              </a:rPr>
-              <a:t>
-▸ Cluster Aeroespacial &amp; Defesa: </a:t>
-            </a:r>
-            <a:r>
-              <a:rPr sz="1100">
-                <a:solidFill>
-                  <a:srgbClr val="94A3B8"/>
-                </a:solidFill>
-              </a:rPr>
-              <a:t>Presença internacional em Dubai e Paris; conexões com +10 países e +120h de capacitação.</a:t>
-            </a:r>
-          </a:p>
-          <a:p>
-            <a:r>
-              <a:rPr b="1" sz="1200">
-                <a:solidFill>
-                  <a:srgbClr val="10B981"/>
-                </a:solidFill>
-              </a:rPr>
-              <a:t>
-▸ TIC Vale (137 Empresas): </a:t>
-            </a:r>
-            <a:r>
-              <a:rPr sz="1100">
-                <a:solidFill>
-                  <a:srgbClr val="94A3B8"/>
-                </a:solidFill>
-              </a:rPr>
-              <a:t>Arranjo produtivo em Indústria 4.0, Inteligência Artificial, Big Data e Smart Cities.</a:t>
-            </a:r>
-          </a:p>
-          <a:p>
-            <a:r>
-              <a:rPr b="1" sz="1200">
-                <a:solidFill>
-                  <a:srgbClr val="10B981"/>
-                </a:solidFill>
-              </a:rPr>
-              <a:t>
-▸ Agropolo (+21,6%) &amp; Saúde/Mobilidade: </a:t>
-            </a:r>
-            <a:r>
-              <a:rPr sz="1100">
-                <a:solidFill>
-                  <a:srgbClr val="94A3B8"/>
-                </a:solidFill>
-              </a:rPr>
-              <a:t>90 empresas no Agropolo com foco em ESG; cadeia de saúde com +100 rodadas de negócios.</a:t>
-            </a:r>
-          </a:p>
-          <a:p>
-            <a:r>
-              <a:rPr b="1" sz="1200">
-                <a:solidFill>
-                  <a:srgbClr val="10B981"/>
-                </a:solidFill>
-              </a:rPr>
-              <a:t>
-▸ Nexus Hub (192 Startups): </a:t>
-            </a:r>
-            <a:r>
-              <a:rPr sz="1100">
-                <a:solidFill>
-                  <a:srgbClr val="94A3B8"/>
-                </a:solidFill>
-              </a:rPr>
-              <a:t>Comunidade com 23 entidades estratégicas e 87 mentores seniores no Nexus Circle.</a:t>
-            </a:r>
-          </a:p>
-        </p:txBody>
-      </p:sp>
-      <p:sp>
-        <p:nvSpPr>
-          <p:cNvPr id="7" name="TextBox 6"/>
-          <p:cNvSpPr txBox="1"/>
-          <p:nvPr/>
-        </p:nvSpPr>
-        <p:spPr>
-          <a:xfrm>
-            <a:off x="731520" y="6309360"/>
-            <a:ext cx="10728655" cy="411480"/>
-          </a:xfrm>
-          <a:prstGeom prst="rect">
-            <a:avLst/>
-          </a:prstGeom>
-          <a:noFill/>
-        </p:spPr>
-        <p:txBody>
-          <a:bodyPr wrap="square">
-            <a:spAutoFit/>
-          </a:bodyPr>
-          <a:lstStyle/>
-          <a:p>
             <a:r>
               <a:rPr sz="850" b="1">
                 <a:solidFill>
@@ -13344,7 +12793,7 @@
                 </a:solidFill>
                 <a:latin typeface="JetBrains Mono"/>
               </a:rPr>
-              <a:t>📚 Fonte / Ref:  Cheriegate, J. (2026). Parque Tecnológico fortalece São José como polo nacional de inovação. Gazeta de SP; APTSJC (2025).</a:t>
+              <a:t>📚 Fonte / Ref:  Matéria do jornal Gazeta de São Paulo e entrevista com Jeferson Cheriegate, Presidente do PIT SJC (29.05.2026); Relatório Anual PIT 2025.</a:t>
             </a:r>
           </a:p>
         </p:txBody>
@@ -13440,16 +12889,7 @@
                 </a:solidFill>
                 <a:latin typeface="Outfit"/>
               </a:rPr>
-              <a:t>Síntese Comparativa: </a:t>
-            </a:r>
-            <a:r>
-              <a:rPr sz="2200" b="1">
-                <a:solidFill>
-                  <a:srgbClr val="3FD0E6"/>
-                </a:solidFill>
-                <a:latin typeface="Outfit"/>
-              </a:rPr>
-              <a:t>San Diego (EUA) vs São José dos Campos (Brasil)</a:t>
+              <a:t>Comparativo </a:t>
             </a:r>
           </a:p>
         </p:txBody>
@@ -14016,7 +13456,7 @@
                 </a:solidFill>
                 <a:latin typeface="JetBrains Mono"/>
               </a:rPr>
-              <a:t>📚 Fonte / Ref:  Majava &amp; Rinkinen (2026); Rubem (2018); APTSJC (2025); Matriz Comparativa Oficial Seminário 5 GETI 2026.</a:t>
+              <a:t>📚 Fonte / Ref:  Matriz Comparativa Oficial Seminário 5 GETI 2026; Jukka Majava &amp;amp; Satu Rinkinen (2026); Thiago Chiquetto Rubem (2018); APTSJC (2025).</a:t>
             </a:r>
           </a:p>
         </p:txBody>

</xml_diff>

<commit_message>
feat: enlarge typography across Lilian slides and enlarge Slide 24 figures and written indicators card
</commit_message>
<xml_diff>
--- a/Seminario_5_Ecossistemas_Inovacao_Master.pptx
+++ b/Seminario_5_Ecossistemas_Inovacao_Master.pptx
@@ -11018,7 +11018,7 @@
               </a:defRPr>
             </a:pPr>
             <a:r>
-              <a:t>🌍 BLOCO 5 • O CASO DE SAN DIEGO (1/9)</a:t>
+              <a:t>SEMINÁRIO 5 • ECOSSISTEMAS DE INOVAÇÃO</a:t>
             </a:r>
           </a:p>
         </p:txBody>
@@ -11059,7 +11059,7 @@
       </p:sp>
       <p:pic>
         <p:nvPicPr>
-          <p:cNvPr id="4" name="Picture 3" descr="slide_1_img_2.png"/>
+          <p:cNvPr id="4" name="Picture 3" descr="slide_1_img_3.png"/>
           <p:cNvPicPr>
             <a:picLocks noChangeAspect="1"/>
           </p:cNvPicPr>
@@ -11074,16 +11074,93 @@
         <p:spPr>
           <a:xfrm>
             <a:off x="731520" y="1463040"/>
-            <a:ext cx="6035040" cy="4389120"/>
+            <a:ext cx="3291840" cy="2490281"/>
           </a:xfrm>
           <a:prstGeom prst="rect">
             <a:avLst/>
           </a:prstGeom>
         </p:spPr>
       </p:pic>
+      <p:sp>
+        <p:nvSpPr>
+          <p:cNvPr id="5" name="TextBox 4"/>
+          <p:cNvSpPr txBox="1"/>
+          <p:nvPr/>
+        </p:nvSpPr>
+        <p:spPr>
+          <a:xfrm>
+            <a:off x="731520" y="4114800"/>
+            <a:ext cx="3291840" cy="1828800"/>
+          </a:xfrm>
+          <a:prstGeom prst="rect">
+            <a:avLst/>
+          </a:prstGeom>
+          <a:noFill/>
+        </p:spPr>
+        <p:txBody>
+          <a:bodyPr wrap="square">
+            <a:spAutoFit/>
+          </a:bodyPr>
+          <a:lstStyle/>
+          <a:p>
+            <a:r>
+              <a:rPr sz="1100">
+                <a:solidFill>
+                  <a:srgbClr val="94A3B8"/>
+                </a:solidFill>
+              </a:rPr>
+              <a:t>• Patentes PCT (2020-2024): </a:t>
+            </a:r>
+            <a:r>
+              <a:rPr sz="1200" b="1">
+                <a:solidFill>
+                  <a:srgbClr val="3FD0E6"/>
+                </a:solidFill>
+              </a:rPr>
+              <a:t>26.713</a:t>
+            </a:r>
+          </a:p>
+          <a:p>
+            <a:r>
+              <a:rPr sz="1100">
+                <a:solidFill>
+                  <a:srgbClr val="94A3B8"/>
+                </a:solidFill>
+              </a:rPr>
+              <a:t>• Artigos Científicos: </a:t>
+            </a:r>
+            <a:r>
+              <a:rPr sz="1200" b="1">
+                <a:solidFill>
+                  <a:srgbClr val="3FD0E6"/>
+                </a:solidFill>
+              </a:rPr>
+              <a:t>19.862</a:t>
+            </a:r>
+          </a:p>
+          <a:p>
+            <a:r>
+              <a:rPr sz="1100">
+                <a:solidFill>
+                  <a:srgbClr val="94A3B8"/>
+                </a:solidFill>
+              </a:rPr>
+              <a:t>• Deals de Venture Capital: </a:t>
+            </a:r>
+            <a:r>
+              <a:rPr sz="1200" b="1">
+                <a:solidFill>
+                  <a:srgbClr val="3FD0E6"/>
+                </a:solidFill>
+              </a:rPr>
+              <a:t>1.705</a:t>
+            </a:r>
+          </a:p>
+        </p:txBody>
+      </p:sp>
       <p:pic>
         <p:nvPicPr>
-          <p:cNvPr id="5" name="Picture 4" descr="slide_1_img_3.png"/>
+          <p:cNvPr id="6" name="Picture 5" descr="slide_1_img_2.png"/>
           <p:cNvPicPr>
             <a:picLocks noChangeAspect="1"/>
           </p:cNvPicPr>
@@ -11097,8 +11174,8 @@
         </p:blipFill>
         <p:spPr>
           <a:xfrm>
-            <a:off x="822960" y="3474720"/>
-            <a:ext cx="2286000" cy="1729362"/>
+            <a:off x="4206240" y="1463040"/>
+            <a:ext cx="4023360" cy="4389120"/>
           </a:xfrm>
           <a:prstGeom prst="rect">
             <a:avLst/>
@@ -11107,7 +11184,7 @@
       </p:pic>
       <p:pic>
         <p:nvPicPr>
-          <p:cNvPr id="6" name="Picture 5" descr="slide_1_img_4.png"/>
+          <p:cNvPr id="7" name="Picture 6" descr="slide_1_img_4.png"/>
           <p:cNvPicPr>
             <a:picLocks noChangeAspect="1"/>
           </p:cNvPicPr>
@@ -11121,8 +11198,8 @@
         </p:blipFill>
         <p:spPr>
           <a:xfrm>
-            <a:off x="6949440" y="1463040"/>
-            <a:ext cx="4480560" cy="4389120"/>
+            <a:off x="8412480" y="1463040"/>
+            <a:ext cx="3017520" cy="4389120"/>
           </a:xfrm>
           <a:prstGeom prst="rect">
             <a:avLst/>
@@ -11131,7 +11208,7 @@
       </p:pic>
       <p:sp>
         <p:nvSpPr>
-          <p:cNvPr id="7" name="TextBox 6"/>
+          <p:cNvPr id="8" name="TextBox 7"/>
           <p:cNvSpPr txBox="1"/>
           <p:nvPr/>
         </p:nvSpPr>
@@ -11167,7 +11244,7 @@
                 </a:solidFill>
                 <a:latin typeface="JetBrains Mono"/>
               </a:rPr>
-              <a:t>📚 Fonte / Ref:  Global Innovation Index 2025 (WIPO); Jukka Majava &amp; Satu Rinkinen (2026). Twenty years, twenty studies: what can we learn from San Diego’s innovation ecosystem?</a:t>
+              <a:t>📚 Fonte / Ref:  Global Innovation Index 2025 (WIPO); Jukka Majava &amp;amp; Satu Rinkinen (2026). Twenty years, twenty studies: what can we learn from San Diego’s innovation ecosystem?</a:t>
             </a:r>
           </a:p>
         </p:txBody>
@@ -11229,7 +11306,7 @@
               </a:defRPr>
             </a:pPr>
             <a:r>
-              <a:t>🧬 BLOCO 5 • CONCEITO &amp; FUNDAMENTOS (2/9)</a:t>
+              <a:t>SEMINÁRIO 5 • ECOSSISTEMAS DE INOVAÇÃO</a:t>
             </a:r>
           </a:p>
         </p:txBody>
@@ -11276,8 +11353,8 @@
         </p:nvSpPr>
         <p:spPr>
           <a:xfrm>
-            <a:off x="731520" y="1371600"/>
-            <a:ext cx="10698480" cy="1097280"/>
+            <a:off x="731520" y="1280160"/>
+            <a:ext cx="10698480" cy="1188720"/>
           </a:xfrm>
           <a:prstGeom prst="rect">
             <a:avLst/>
@@ -11291,7 +11368,7 @@
           <a:lstStyle/>
           <a:p>
             <a:pPr>
-              <a:defRPr sz="1300" i="1">
+              <a:defRPr sz="1500" b="1" i="1">
                 <a:solidFill>
                   <a:srgbClr val="FFFFFF"/>
                 </a:solidFill>
@@ -11303,7 +11380,7 @@
           </a:p>
           <a:p>
             <a:pPr>
-              <a:defRPr sz="1000">
+              <a:defRPr sz="1100">
                 <a:solidFill>
                   <a:srgbClr val="3FD0E6"/>
                 </a:solidFill>
@@ -11338,7 +11415,7 @@
           <a:lstStyle/>
           <a:p>
             <a:pPr>
-              <a:defRPr sz="1200" b="1">
+              <a:defRPr sz="1300" b="1">
                 <a:solidFill>
                   <a:srgbClr val="FFFFFF"/>
                 </a:solidFill>
@@ -11351,7 +11428,7 @@
           </a:p>
           <a:p>
             <a:pPr>
-              <a:defRPr sz="1200" b="1">
+              <a:defRPr sz="1300" b="1">
                 <a:solidFill>
                   <a:srgbClr val="FFFFFF"/>
                 </a:solidFill>
@@ -11364,7 +11441,7 @@
           </a:p>
           <a:p>
             <a:pPr>
-              <a:defRPr sz="1200" b="1">
+              <a:defRPr sz="1300" b="1">
                 <a:solidFill>
                   <a:srgbClr val="FFFFFF"/>
                 </a:solidFill>
@@ -11400,7 +11477,7 @@
           <a:lstStyle/>
           <a:p>
             <a:pPr>
-              <a:defRPr sz="1200" b="1">
+              <a:defRPr sz="1300" b="1">
                 <a:solidFill>
                   <a:srgbClr val="FFFFFF"/>
                 </a:solidFill>
@@ -11413,20 +11490,20 @@
           </a:p>
           <a:p>
             <a:pPr>
-              <a:defRPr sz="1200" b="1">
+              <a:defRPr sz="1300" b="1">
                 <a:solidFill>
                   <a:srgbClr val="FFFFFF"/>
                 </a:solidFill>
               </a:defRPr>
             </a:pPr>
             <a:r>
-              <a:t>▸ 5º. Ponto: INSTITUIÇÃO MEDIADORA PARA PROPORCIONAR RELACIONAMENTOS ENTRE ATORES</a:t>
+              <a:t>▸ 5º. Ponto: INSTITUIÇÃO MEDIADORA PARA PROPORCIONAR RELACIONAMENTOS</a:t>
             </a:r>
             <a:br/>
           </a:p>
           <a:p>
             <a:pPr>
-              <a:defRPr sz="1200" b="1">
+              <a:defRPr sz="1300" b="1">
                 <a:solidFill>
                   <a:srgbClr val="FFFFFF"/>
                 </a:solidFill>
@@ -11539,7 +11616,7 @@
               </a:defRPr>
             </a:pPr>
             <a:r>
-              <a:t>🌉 BLOCO 5 • O ORQUESTRADOR REGIONAL (3/9)</a:t>
+              <a:t>SEMINÁRIO 5 • ECOSSISTEMAS DE INOVAÇÃO</a:t>
             </a:r>
           </a:p>
         </p:txBody>
@@ -11573,16 +11650,7 @@
                 </a:solidFill>
                 <a:latin typeface="Outfit"/>
               </a:rPr>
-              <a:t>ECOSSISTEMAS DE INOVAÇÃO • </a:t>
-            </a:r>
-            <a:r>
-              <a:rPr sz="2200" b="1">
-                <a:solidFill>
-                  <a:srgbClr val="3FD0E6"/>
-                </a:solidFill>
-                <a:latin typeface="Outfit"/>
-              </a:rPr>
-              <a:t>O Caso de San Diego</a:t>
+              <a:t>ECOSSISTEMAS DE INOVAÇÃO • O Caso de San Diego </a:t>
             </a:r>
           </a:p>
         </p:txBody>
@@ -11711,7 +11779,7 @@
               </a:defRPr>
             </a:pPr>
             <a:r>
-              <a:t>🎯 BLOCO 5 • DIAGNÓSTICO METODOLÓGICO (4/9)</a:t>
+              <a:t>SEMINÁRIO 5 • ECOSSISTEMAS DE INOVAÇÃO</a:t>
             </a:r>
           </a:p>
         </p:txBody>
@@ -11745,16 +11813,7 @@
                 </a:solidFill>
                 <a:latin typeface="Outfit"/>
               </a:rPr>
-              <a:t>ECOSSISTEMAS DE INOVAÇÃO • </a:t>
-            </a:r>
-            <a:r>
-              <a:rPr sz="2200" b="1">
-                <a:solidFill>
-                  <a:srgbClr val="3FD0E6"/>
-                </a:solidFill>
-                <a:latin typeface="Outfit"/>
-              </a:rPr>
-              <a:t>O Caso de San Diego</a:t>
+              <a:t>ECOSSISTEMAS DE INOVAÇÃO • O Caso de San Diego </a:t>
             </a:r>
           </a:p>
         </p:txBody>
@@ -11883,7 +11942,7 @@
               </a:defRPr>
             </a:pPr>
             <a:r>
-              <a:t>🇧🇷 BLOCO 5 • SÃO JOSÉ DOS CAMPOS: RAÍZES HISTÓRICAS (5/9)</a:t>
+              <a:t>SEMINÁRIO 5 • ECOSSISTEMAS DE INOVAÇÃO</a:t>
             </a:r>
           </a:p>
         </p:txBody>
@@ -11917,16 +11976,7 @@
                 </a:solidFill>
                 <a:latin typeface="Outfit"/>
               </a:rPr>
-              <a:t>ECOSSISTEMAS DE INOVAÇÃO • </a:t>
-            </a:r>
-            <a:r>
-              <a:rPr sz="2200" b="1">
-                <a:solidFill>
-                  <a:srgbClr val="3FD0E6"/>
-                </a:solidFill>
-                <a:latin typeface="Outfit"/>
-              </a:rPr>
-              <a:t>O Caso de São José dos Campos</a:t>
+              <a:t>ECOSSISTEMAS DE INOVAÇÃO • O Caso de São José dos Campos </a:t>
             </a:r>
           </a:p>
         </p:txBody>
@@ -12055,7 +12105,7 @@
               </a:defRPr>
             </a:pPr>
             <a:r>
-              <a:t>🔄 BLOCO 5 • EVOLUÇÃO ESTRUTURAL (6/9)</a:t>
+              <a:t>SEMINÁRIO 5 • ECOSSISTEMAS DE INOVAÇÃO</a:t>
             </a:r>
           </a:p>
         </p:txBody>
@@ -12089,16 +12139,7 @@
                 </a:solidFill>
                 <a:latin typeface="Outfit"/>
               </a:rPr>
-              <a:t>ECOSSISTEMAS DE INOVAÇÃO • </a:t>
-            </a:r>
-            <a:r>
-              <a:rPr sz="2200" b="1">
-                <a:solidFill>
-                  <a:srgbClr val="3FD0E6"/>
-                </a:solidFill>
-                <a:latin typeface="Outfit"/>
-              </a:rPr>
-              <a:t>O Caso de São José dos Campos</a:t>
+              <a:t>ECOSSISTEMAS DE INOVAÇÃO • O Caso de São José dos Campos </a:t>
             </a:r>
           </a:p>
         </p:txBody>
@@ -12529,7 +12570,7 @@
               </a:defRPr>
             </a:pPr>
             <a:r>
-              <a:t>🏛️ BLOCO 5 • ANATOMIA DO PIT SJC (7/9)</a:t>
+              <a:t>SEMINÁRIO 5 • ECOSSISTEMAS DE INOVAÇÃO</a:t>
             </a:r>
           </a:p>
         </p:txBody>
@@ -12692,7 +12733,7 @@
               </a:defRPr>
             </a:pPr>
             <a:r>
-              <a:t>🤝 BLOCO 5 • CONEXÕES &amp; MERCADO (8/9)</a:t>
+              <a:t>SEMINÁRIO 5 • ECOSSISTEMAS DE INOVAÇÃO</a:t>
             </a:r>
           </a:p>
         </p:txBody>
@@ -12855,7 +12896,7 @@
               </a:defRPr>
             </a:pPr>
             <a:r>
-              <a:t>⚖️ BLOCO 5 • MATRIZ DE BENCHMARKING (9/9)</a:t>
+              <a:t>SEMINÁRIO 5 • ECOSSISTEMAS DE INOVAÇÃO</a:t>
             </a:r>
           </a:p>
         </p:txBody>
@@ -12924,7 +12965,7 @@
                     <a:lstStyle/>
                     <a:p>
                       <a:pPr>
-                        <a:defRPr b="1" sz="1200">
+                        <a:defRPr b="1" sz="1300">
                           <a:solidFill>
                             <a:srgbClr val="3FD0E6"/>
                           </a:solidFill>
@@ -12947,7 +12988,7 @@
                     <a:lstStyle/>
                     <a:p>
                       <a:pPr>
-                        <a:defRPr b="1" sz="1200">
+                        <a:defRPr b="1" sz="1300">
                           <a:solidFill>
                             <a:srgbClr val="3FD0E6"/>
                           </a:solidFill>
@@ -12970,7 +13011,7 @@
                     <a:lstStyle/>
                     <a:p>
                       <a:pPr>
-                        <a:defRPr b="1" sz="1200">
+                        <a:defRPr b="1" sz="1300">
                           <a:solidFill>
                             <a:srgbClr val="3FD0E6"/>
                           </a:solidFill>
@@ -12995,7 +13036,7 @@
                     <a:lstStyle/>
                     <a:p>
                       <a:pPr>
-                        <a:defRPr b="1" sz="1000">
+                        <a:defRPr b="1" sz="1150">
                           <a:solidFill>
                             <a:srgbClr val="FFFFFF"/>
                           </a:solidFill>
@@ -13018,7 +13059,7 @@
                     <a:lstStyle/>
                     <a:p>
                       <a:pPr>
-                        <a:defRPr sz="950">
+                        <a:defRPr sz="1100">
                           <a:solidFill>
                             <a:srgbClr val="94A3B8"/>
                           </a:solidFill>
@@ -13041,7 +13082,7 @@
                     <a:lstStyle/>
                     <a:p>
                       <a:pPr>
-                        <a:defRPr sz="950">
+                        <a:defRPr sz="1100">
                           <a:solidFill>
                             <a:srgbClr val="FFFFFF"/>
                           </a:solidFill>
@@ -13066,7 +13107,7 @@
                     <a:lstStyle/>
                     <a:p>
                       <a:pPr>
-                        <a:defRPr b="1" sz="1000">
+                        <a:defRPr b="1" sz="1150">
                           <a:solidFill>
                             <a:srgbClr val="FFFFFF"/>
                           </a:solidFill>
@@ -13089,7 +13130,7 @@
                     <a:lstStyle/>
                     <a:p>
                       <a:pPr>
-                        <a:defRPr sz="950">
+                        <a:defRPr sz="1100">
                           <a:solidFill>
                             <a:srgbClr val="94A3B8"/>
                           </a:solidFill>
@@ -13112,7 +13153,7 @@
                     <a:lstStyle/>
                     <a:p>
                       <a:pPr>
-                        <a:defRPr sz="950">
+                        <a:defRPr sz="1100">
                           <a:solidFill>
                             <a:srgbClr val="FFFFFF"/>
                           </a:solidFill>
@@ -13137,7 +13178,7 @@
                     <a:lstStyle/>
                     <a:p>
                       <a:pPr>
-                        <a:defRPr b="1" sz="1000">
+                        <a:defRPr b="1" sz="1150">
                           <a:solidFill>
                             <a:srgbClr val="FFFFFF"/>
                           </a:solidFill>
@@ -13160,7 +13201,7 @@
                     <a:lstStyle/>
                     <a:p>
                       <a:pPr>
-                        <a:defRPr sz="950">
+                        <a:defRPr sz="1100">
                           <a:solidFill>
                             <a:srgbClr val="94A3B8"/>
                           </a:solidFill>
@@ -13183,7 +13224,7 @@
                     <a:lstStyle/>
                     <a:p>
                       <a:pPr>
-                        <a:defRPr sz="950">
+                        <a:defRPr sz="1100">
                           <a:solidFill>
                             <a:srgbClr val="FFFFFF"/>
                           </a:solidFill>
@@ -13208,7 +13249,7 @@
                     <a:lstStyle/>
                     <a:p>
                       <a:pPr>
-                        <a:defRPr b="1" sz="1000">
+                        <a:defRPr b="1" sz="1150">
                           <a:solidFill>
                             <a:srgbClr val="FFFFFF"/>
                           </a:solidFill>
@@ -13231,7 +13272,7 @@
                     <a:lstStyle/>
                     <a:p>
                       <a:pPr>
-                        <a:defRPr sz="950">
+                        <a:defRPr sz="1100">
                           <a:solidFill>
                             <a:srgbClr val="94A3B8"/>
                           </a:solidFill>
@@ -13254,7 +13295,7 @@
                     <a:lstStyle/>
                     <a:p>
                       <a:pPr>
-                        <a:defRPr sz="950">
+                        <a:defRPr sz="1100">
                           <a:solidFill>
                             <a:srgbClr val="FFFFFF"/>
                           </a:solidFill>
@@ -13279,7 +13320,7 @@
                     <a:lstStyle/>
                     <a:p>
                       <a:pPr>
-                        <a:defRPr b="1" sz="1000">
+                        <a:defRPr b="1" sz="1150">
                           <a:solidFill>
                             <a:srgbClr val="FFFFFF"/>
                           </a:solidFill>
@@ -13302,7 +13343,7 @@
                     <a:lstStyle/>
                     <a:p>
                       <a:pPr>
-                        <a:defRPr sz="950">
+                        <a:defRPr sz="1100">
                           <a:solidFill>
                             <a:srgbClr val="94A3B8"/>
                           </a:solidFill>
@@ -13325,7 +13366,7 @@
                     <a:lstStyle/>
                     <a:p>
                       <a:pPr>
-                        <a:defRPr sz="950">
+                        <a:defRPr sz="1100">
                           <a:solidFill>
                             <a:srgbClr val="FFFFFF"/>
                           </a:solidFill>
@@ -13350,7 +13391,7 @@
                     <a:lstStyle/>
                     <a:p>
                       <a:pPr>
-                        <a:defRPr b="1" sz="1000">
+                        <a:defRPr b="1" sz="1150">
                           <a:solidFill>
                             <a:srgbClr val="FFFFFF"/>
                           </a:solidFill>
@@ -13373,7 +13414,7 @@
                     <a:lstStyle/>
                     <a:p>
                       <a:pPr>
-                        <a:defRPr sz="950">
+                        <a:defRPr sz="1100">
                           <a:solidFill>
                             <a:srgbClr val="94A3B8"/>
                           </a:solidFill>
@@ -13396,7 +13437,7 @@
                     <a:lstStyle/>
                     <a:p>
                       <a:pPr>
-                        <a:defRPr sz="950">
+                        <a:defRPr sz="1100">
                           <a:solidFill>
                             <a:srgbClr val="FFFFFF"/>
                           </a:solidFill>

</xml_diff>

<commit_message>
fix: update Bloco 5 presenter for Quinta-feira from Fabio Lippi to Marciele Toledo
</commit_message>
<xml_diff>
--- a/Seminario_5_Ecossistemas_Inovacao_Master.pptx
+++ b/Seminario_5_Ecossistemas_Inovacao_Master.pptx
@@ -11235,7 +11235,7 @@
                 </a:solidFill>
                 <a:latin typeface="JetBrains Mono"/>
               </a:rPr>
-              <a:t>🎤 Lilian Veiga (4ª) / Fábio Lippi (5ª)   |   </a:t>
+              <a:t>🎤 Lilian Veiga (4ª) / Marciele Toledo (5ª)   |   </a:t>
             </a:r>
             <a:r>
               <a:rPr sz="850">
@@ -11545,7 +11545,7 @@
                 </a:solidFill>
                 <a:latin typeface="JetBrains Mono"/>
               </a:rPr>
-              <a:t>🎤 Lilian Veiga (4ª) / Fábio Lippi (5ª)   |   </a:t>
+              <a:t>🎤 Lilian Veiga (4ª) / Marciele Toledo (5ª)   |   </a:t>
             </a:r>
             <a:r>
               <a:rPr sz="850">
@@ -11708,7 +11708,7 @@
                 </a:solidFill>
                 <a:latin typeface="JetBrains Mono"/>
               </a:rPr>
-              <a:t>🎤 Lilian Veiga (4ª) / Fábio Lippi (5ª)   |   </a:t>
+              <a:t>🎤 Lilian Veiga (4ª) / Marciele Toledo (5ª)   |   </a:t>
             </a:r>
             <a:r>
               <a:rPr sz="850">
@@ -11871,7 +11871,7 @@
                 </a:solidFill>
                 <a:latin typeface="JetBrains Mono"/>
               </a:rPr>
-              <a:t>🎤 Lilian Veiga (4ª) / Fábio Lippi (5ª)   |   </a:t>
+              <a:t>🎤 Lilian Veiga (4ª) / Marciele Toledo (5ª)   |   </a:t>
             </a:r>
             <a:r>
               <a:rPr sz="850">
@@ -12034,7 +12034,7 @@
                 </a:solidFill>
                 <a:latin typeface="JetBrains Mono"/>
               </a:rPr>
-              <a:t>🎤 Lilian Veiga (4ª) / Fábio Lippi (5ª)   |   </a:t>
+              <a:t>🎤 Lilian Veiga (4ª) / Marciele Toledo (5ª)   |   </a:t>
             </a:r>
             <a:r>
               <a:rPr sz="850">
@@ -12197,7 +12197,7 @@
                 </a:solidFill>
                 <a:latin typeface="JetBrains Mono"/>
               </a:rPr>
-              <a:t>🎤 Lilian Veiga (4ª) / Fábio Lippi (5ª)   |   </a:t>
+              <a:t>🎤 Lilian Veiga (4ª) / Marciele Toledo (5ª)   |   </a:t>
             </a:r>
             <a:r>
               <a:rPr sz="850">
@@ -12662,7 +12662,7 @@
                 </a:solidFill>
                 <a:latin typeface="JetBrains Mono"/>
               </a:rPr>
-              <a:t>🎤 Lilian Veiga (4ª) / Fábio Lippi (5ª)   |   </a:t>
+              <a:t>🎤 Lilian Veiga (4ª) / Marciele Toledo (5ª)   |   </a:t>
             </a:r>
             <a:r>
               <a:rPr sz="850">
@@ -12825,7 +12825,7 @@
                 </a:solidFill>
                 <a:latin typeface="JetBrains Mono"/>
               </a:rPr>
-              <a:t>🎤 Lilian Veiga (4ª) / Fábio Lippi (5ª)   |   </a:t>
+              <a:t>🎤 Lilian Veiga (4ª) / Marciele Toledo (5ª)   |   </a:t>
             </a:r>
             <a:r>
               <a:rPr sz="850">
@@ -13488,7 +13488,7 @@
                 </a:solidFill>
                 <a:latin typeface="JetBrains Mono"/>
               </a:rPr>
-              <a:t>🎤 Lilian Veiga (4ª) / Fábio Lippi (5ª)   |   </a:t>
+              <a:t>🎤 Lilian Veiga (4ª) / Marciele Toledo (5ª)   |   </a:t>
             </a:r>
             <a:r>
               <a:rPr sz="850">
@@ -13790,7 +13790,7 @@
                 </a:solidFill>
                 <a:latin typeface="JetBrains Mono"/>
               </a:rPr>
-              <a:t>🎤 Lilian Veiga (4ª) / Fábio Lippi (5ª)   |   </a:t>
+              <a:t>🎤 Lilian Veiga (4ª) / Marciele Toledo (5ª)   |   </a:t>
             </a:r>
             <a:r>
               <a:rPr sz="850">

</xml_diff>

<commit_message>
feat: scale up body fonts presentation-wide and set Joel as Thursday presenter for Bloco 3
</commit_message>
<xml_diff>
--- a/Seminario_5_Ecossistemas_Inovacao_Master.pptx
+++ b/Seminario_5_Ecossistemas_Inovacao_Master.pptx
@@ -7170,7 +7170,7 @@
           <a:lstStyle/>
           <a:p>
             <a:pPr>
-              <a:defRPr sz="1300">
+              <a:defRPr sz="1450">
                 <a:solidFill>
                   <a:srgbClr val="FFFFFF"/>
                 </a:solidFill>
@@ -7182,7 +7182,7 @@
           </a:p>
           <a:p>
             <a:pPr>
-              <a:defRPr sz="1300">
+              <a:defRPr sz="1450">
                 <a:solidFill>
                   <a:srgbClr val="94A3B8"/>
                 </a:solidFill>
@@ -7194,7 +7194,7 @@
           </a:p>
           <a:p>
             <a:pPr>
-              <a:defRPr sz="1300">
+              <a:defRPr sz="1450">
                 <a:solidFill>
                   <a:srgbClr val="FFFFFF"/>
                 </a:solidFill>
@@ -7206,7 +7206,7 @@
           </a:p>
           <a:p>
             <a:pPr>
-              <a:defRPr sz="1300">
+              <a:defRPr sz="1450">
                 <a:solidFill>
                   <a:srgbClr val="94A3B8"/>
                 </a:solidFill>
@@ -7218,7 +7218,7 @@
           </a:p>
           <a:p>
             <a:pPr>
-              <a:defRPr sz="1300">
+              <a:defRPr sz="1450">
                 <a:solidFill>
                   <a:srgbClr val="FFFFFF"/>
                 </a:solidFill>
@@ -7230,7 +7230,7 @@
           </a:p>
           <a:p>
             <a:pPr>
-              <a:defRPr sz="1300">
+              <a:defRPr sz="1450">
                 <a:solidFill>
                   <a:srgbClr val="94A3B8"/>
                 </a:solidFill>
@@ -7242,7 +7242,7 @@
           </a:p>
           <a:p>
             <a:pPr>
-              <a:defRPr sz="1300">
+              <a:defRPr sz="1450">
                 <a:solidFill>
                   <a:srgbClr val="FFFFFF"/>
                 </a:solidFill>
@@ -7254,7 +7254,7 @@
           </a:p>
           <a:p>
             <a:pPr>
-              <a:defRPr sz="1300">
+              <a:defRPr sz="1450">
                 <a:solidFill>
                   <a:srgbClr val="94A3B8"/>
                 </a:solidFill>
@@ -7289,7 +7289,7 @@
           <a:lstStyle/>
           <a:p>
             <a:r>
-              <a:rPr sz="850" b="1">
+              <a:rPr sz="950" b="1">
                 <a:solidFill>
                   <a:srgbClr val="3FD0E6"/>
                 </a:solidFill>
@@ -7298,7 +7298,7 @@
               <a:t>🎤 Josué Jofre (4ª) / Fernando Barreto (5ª)   |   </a:t>
             </a:r>
             <a:r>
-              <a:rPr sz="850">
+              <a:rPr sz="900">
                 <a:solidFill>
                   <a:srgbClr val="94A3B8"/>
                 </a:solidFill>
@@ -7472,7 +7472,7 @@
           <a:lstStyle/>
           <a:p>
             <a:pPr>
-              <a:defRPr sz="1300">
+              <a:defRPr sz="1450">
                 <a:solidFill>
                   <a:srgbClr val="FFFFFF"/>
                 </a:solidFill>
@@ -7484,7 +7484,7 @@
           </a:p>
           <a:p>
             <a:pPr>
-              <a:defRPr sz="1300">
+              <a:defRPr sz="1450">
                 <a:solidFill>
                   <a:srgbClr val="94A3B8"/>
                 </a:solidFill>
@@ -7496,7 +7496,7 @@
           </a:p>
           <a:p>
             <a:pPr>
-              <a:defRPr sz="1300">
+              <a:defRPr sz="1450">
                 <a:solidFill>
                   <a:srgbClr val="FFFFFF"/>
                 </a:solidFill>
@@ -7508,7 +7508,7 @@
           </a:p>
           <a:p>
             <a:pPr>
-              <a:defRPr sz="1300">
+              <a:defRPr sz="1450">
                 <a:solidFill>
                   <a:srgbClr val="94A3B8"/>
                 </a:solidFill>
@@ -7520,7 +7520,7 @@
           </a:p>
           <a:p>
             <a:pPr>
-              <a:defRPr sz="1300">
+              <a:defRPr sz="1450">
                 <a:solidFill>
                   <a:srgbClr val="FFFFFF"/>
                 </a:solidFill>
@@ -7532,7 +7532,7 @@
           </a:p>
           <a:p>
             <a:pPr>
-              <a:defRPr sz="1300">
+              <a:defRPr sz="1450">
                 <a:solidFill>
                   <a:srgbClr val="94A3B8"/>
                 </a:solidFill>
@@ -7544,7 +7544,7 @@
           </a:p>
           <a:p>
             <a:pPr>
-              <a:defRPr sz="1300">
+              <a:defRPr sz="1450">
                 <a:solidFill>
                   <a:srgbClr val="FFFFFF"/>
                 </a:solidFill>
@@ -7556,7 +7556,7 @@
           </a:p>
           <a:p>
             <a:pPr>
-              <a:defRPr sz="1300">
+              <a:defRPr sz="1450">
                 <a:solidFill>
                   <a:srgbClr val="94A3B8"/>
                 </a:solidFill>
@@ -7591,7 +7591,7 @@
           <a:lstStyle/>
           <a:p>
             <a:r>
-              <a:rPr sz="850" b="1">
+              <a:rPr sz="950" b="1">
                 <a:solidFill>
                   <a:srgbClr val="3FD0E6"/>
                 </a:solidFill>
@@ -7600,7 +7600,7 @@
               <a:t>🎤 Veridiany Braga (4ª) / Fábio Lippi (5ª)   |   </a:t>
             </a:r>
             <a:r>
-              <a:rPr sz="850">
+              <a:rPr sz="900">
                 <a:solidFill>
                   <a:srgbClr val="94A3B8"/>
                 </a:solidFill>
@@ -7774,7 +7774,7 @@
           <a:lstStyle/>
           <a:p>
             <a:pPr>
-              <a:defRPr sz="1300">
+              <a:defRPr sz="1450">
                 <a:solidFill>
                   <a:srgbClr val="FFFFFF"/>
                 </a:solidFill>
@@ -7786,7 +7786,7 @@
           </a:p>
           <a:p>
             <a:pPr>
-              <a:defRPr sz="1300">
+              <a:defRPr sz="1450">
                 <a:solidFill>
                   <a:srgbClr val="94A3B8"/>
                 </a:solidFill>
@@ -7798,7 +7798,7 @@
           </a:p>
           <a:p>
             <a:pPr>
-              <a:defRPr sz="1300">
+              <a:defRPr sz="1450">
                 <a:solidFill>
                   <a:srgbClr val="FFFFFF"/>
                 </a:solidFill>
@@ -7810,7 +7810,7 @@
           </a:p>
           <a:p>
             <a:pPr>
-              <a:defRPr sz="1300">
+              <a:defRPr sz="1450">
                 <a:solidFill>
                   <a:srgbClr val="94A3B8"/>
                 </a:solidFill>
@@ -7822,7 +7822,7 @@
           </a:p>
           <a:p>
             <a:pPr>
-              <a:defRPr sz="1300">
+              <a:defRPr sz="1450">
                 <a:solidFill>
                   <a:srgbClr val="FFFFFF"/>
                 </a:solidFill>
@@ -7834,7 +7834,7 @@
           </a:p>
           <a:p>
             <a:pPr>
-              <a:defRPr sz="1300">
+              <a:defRPr sz="1450">
                 <a:solidFill>
                   <a:srgbClr val="94A3B8"/>
                 </a:solidFill>
@@ -7846,7 +7846,7 @@
           </a:p>
           <a:p>
             <a:pPr>
-              <a:defRPr sz="1300">
+              <a:defRPr sz="1450">
                 <a:solidFill>
                   <a:srgbClr val="FFFFFF"/>
                 </a:solidFill>
@@ -7858,7 +7858,7 @@
           </a:p>
           <a:p>
             <a:pPr>
-              <a:defRPr sz="1300">
+              <a:defRPr sz="1450">
                 <a:solidFill>
                   <a:srgbClr val="94A3B8"/>
                 </a:solidFill>
@@ -7893,7 +7893,7 @@
           <a:lstStyle/>
           <a:p>
             <a:r>
-              <a:rPr sz="850" b="1">
+              <a:rPr sz="950" b="1">
                 <a:solidFill>
                   <a:srgbClr val="3FD0E6"/>
                 </a:solidFill>
@@ -7902,7 +7902,7 @@
               <a:t>🎤 Veridiany Braga (4ª) / Fábio Lippi (5ª)   |   </a:t>
             </a:r>
             <a:r>
-              <a:rPr sz="850">
+              <a:rPr sz="900">
                 <a:solidFill>
                   <a:srgbClr val="94A3B8"/>
                 </a:solidFill>
@@ -8056,16 +8056,16 @@
           <a:lstStyle/>
           <a:p>
             <a:r>
-              <a:rPr sz="850" b="1">
+              <a:rPr sz="950" b="1">
                 <a:solidFill>
                   <a:srgbClr val="3FD0E6"/>
                 </a:solidFill>
                 <a:latin typeface="JetBrains Mono"/>
               </a:rPr>
-              <a:t>🎤 Jéssica David (4ª) / Fernando Barreto (5ª)   |   </a:t>
-            </a:r>
-            <a:r>
-              <a:rPr sz="850">
+              <a:t>🎤 Jéssica David (4ª) / Joel (5ª)   |   </a:t>
+            </a:r>
+            <a:r>
+              <a:rPr sz="900">
                 <a:solidFill>
                   <a:srgbClr val="94A3B8"/>
                 </a:solidFill>
@@ -8219,16 +8219,16 @@
           <a:lstStyle/>
           <a:p>
             <a:r>
-              <a:rPr sz="850" b="1">
+              <a:rPr sz="950" b="1">
                 <a:solidFill>
                   <a:srgbClr val="3FD0E6"/>
                 </a:solidFill>
                 <a:latin typeface="JetBrains Mono"/>
               </a:rPr>
-              <a:t>🎤 Jéssica David (4ª) / Fernando Barreto (5ª)   |   </a:t>
-            </a:r>
-            <a:r>
-              <a:rPr sz="850">
+              <a:t>🎤 Jéssica David (4ª) / Joel (5ª)   |   </a:t>
+            </a:r>
+            <a:r>
+              <a:rPr sz="900">
                 <a:solidFill>
                   <a:srgbClr val="94A3B8"/>
                 </a:solidFill>
@@ -8358,7 +8358,7 @@
           <a:lstStyle/>
           <a:p>
             <a:pPr>
-              <a:defRPr sz="1300">
+              <a:defRPr sz="1450">
                 <a:solidFill>
                   <a:srgbClr val="FFFFFF"/>
                 </a:solidFill>
@@ -8370,7 +8370,7 @@
           </a:p>
           <a:p>
             <a:pPr>
-              <a:defRPr sz="1300">
+              <a:defRPr sz="1450">
                 <a:solidFill>
                   <a:srgbClr val="94A3B8"/>
                 </a:solidFill>
@@ -8382,7 +8382,7 @@
           </a:p>
           <a:p>
             <a:pPr>
-              <a:defRPr sz="1300">
+              <a:defRPr sz="1450">
                 <a:solidFill>
                   <a:srgbClr val="FFFFFF"/>
                 </a:solidFill>
@@ -8394,7 +8394,7 @@
           </a:p>
           <a:p>
             <a:pPr>
-              <a:defRPr sz="1300">
+              <a:defRPr sz="1450">
                 <a:solidFill>
                   <a:srgbClr val="94A3B8"/>
                 </a:solidFill>
@@ -8406,7 +8406,7 @@
           </a:p>
           <a:p>
             <a:pPr>
-              <a:defRPr sz="1300">
+              <a:defRPr sz="1450">
                 <a:solidFill>
                   <a:srgbClr val="FFFFFF"/>
                 </a:solidFill>
@@ -8418,7 +8418,7 @@
           </a:p>
           <a:p>
             <a:pPr>
-              <a:defRPr sz="1300">
+              <a:defRPr sz="1450">
                 <a:solidFill>
                   <a:srgbClr val="94A3B8"/>
                 </a:solidFill>
@@ -8430,7 +8430,7 @@
           </a:p>
           <a:p>
             <a:pPr>
-              <a:defRPr sz="1300">
+              <a:defRPr sz="1450">
                 <a:solidFill>
                   <a:srgbClr val="FFFFFF"/>
                 </a:solidFill>
@@ -8442,7 +8442,7 @@
           </a:p>
           <a:p>
             <a:pPr>
-              <a:defRPr sz="1300">
+              <a:defRPr sz="1450">
                 <a:solidFill>
                   <a:srgbClr val="94A3B8"/>
                 </a:solidFill>
@@ -8477,16 +8477,16 @@
           <a:lstStyle/>
           <a:p>
             <a:r>
-              <a:rPr sz="850" b="1">
+              <a:rPr sz="950" b="1">
                 <a:solidFill>
                   <a:srgbClr val="3FD0E6"/>
                 </a:solidFill>
                 <a:latin typeface="JetBrains Mono"/>
               </a:rPr>
-              <a:t>🎤 Jéssica David (4ª) / Fernando Barreto (5ª)   |   </a:t>
-            </a:r>
-            <a:r>
-              <a:rPr sz="850">
+              <a:t>🎤 Jéssica David (4ª) / Joel (5ª)   |   </a:t>
+            </a:r>
+            <a:r>
+              <a:rPr sz="900">
                 <a:solidFill>
                   <a:srgbClr val="94A3B8"/>
                 </a:solidFill>
@@ -8640,16 +8640,16 @@
           <a:lstStyle/>
           <a:p>
             <a:r>
-              <a:rPr sz="850" b="1">
+              <a:rPr sz="950" b="1">
                 <a:solidFill>
                   <a:srgbClr val="3FD0E6"/>
                 </a:solidFill>
                 <a:latin typeface="JetBrains Mono"/>
               </a:rPr>
-              <a:t>🎤 Jéssica David (4ª) / Fernando Barreto (5ª)   |   </a:t>
-            </a:r>
-            <a:r>
-              <a:rPr sz="850">
+              <a:t>🎤 Jéssica David (4ª) / Joel (5ª)   |   </a:t>
+            </a:r>
+            <a:r>
+              <a:rPr sz="900">
                 <a:solidFill>
                   <a:srgbClr val="94A3B8"/>
                 </a:solidFill>
@@ -8803,16 +8803,16 @@
           <a:lstStyle/>
           <a:p>
             <a:r>
-              <a:rPr sz="850" b="1">
+              <a:rPr sz="950" b="1">
                 <a:solidFill>
                   <a:srgbClr val="3FD0E6"/>
                 </a:solidFill>
                 <a:latin typeface="JetBrains Mono"/>
               </a:rPr>
-              <a:t>🎤 Jéssica David (4ª) / Fernando Barreto (5ª)   |   </a:t>
-            </a:r>
-            <a:r>
-              <a:rPr sz="850">
+              <a:t>🎤 Jéssica David (4ª) / Joel (5ª)   |   </a:t>
+            </a:r>
+            <a:r>
+              <a:rPr sz="900">
                 <a:solidFill>
                   <a:srgbClr val="94A3B8"/>
                 </a:solidFill>
@@ -8966,16 +8966,16 @@
           <a:lstStyle/>
           <a:p>
             <a:r>
-              <a:rPr sz="850" b="1">
+              <a:rPr sz="950" b="1">
                 <a:solidFill>
                   <a:srgbClr val="3FD0E6"/>
                 </a:solidFill>
                 <a:latin typeface="JetBrains Mono"/>
               </a:rPr>
-              <a:t>🎤 Jéssica David (4ª) / Fernando Barreto (5ª)   |   </a:t>
-            </a:r>
-            <a:r>
-              <a:rPr sz="850">
+              <a:t>🎤 Jéssica David (4ª) / Joel (5ª)   |   </a:t>
+            </a:r>
+            <a:r>
+              <a:rPr sz="900">
                 <a:solidFill>
                   <a:srgbClr val="94A3B8"/>
                 </a:solidFill>
@@ -9129,16 +9129,16 @@
           <a:lstStyle/>
           <a:p>
             <a:r>
-              <a:rPr sz="850" b="1">
+              <a:rPr sz="950" b="1">
                 <a:solidFill>
                   <a:srgbClr val="3FD0E6"/>
                 </a:solidFill>
                 <a:latin typeface="JetBrains Mono"/>
               </a:rPr>
-              <a:t>🎤 Jéssica David (4ª) / Fernando Barreto (5ª)   |   </a:t>
-            </a:r>
-            <a:r>
-              <a:rPr sz="850">
+              <a:t>🎤 Jéssica David (4ª) / Joel (5ª)   |   </a:t>
+            </a:r>
+            <a:r>
+              <a:rPr sz="900">
                 <a:solidFill>
                   <a:srgbClr val="94A3B8"/>
                 </a:solidFill>
@@ -9312,7 +9312,7 @@
           <a:lstStyle/>
           <a:p>
             <a:pPr>
-              <a:defRPr sz="1300">
+              <a:defRPr sz="1450">
                 <a:solidFill>
                   <a:srgbClr val="FFFFFF"/>
                 </a:solidFill>
@@ -9324,7 +9324,7 @@
           </a:p>
           <a:p>
             <a:pPr>
-              <a:defRPr sz="1300">
+              <a:defRPr sz="1450">
                 <a:solidFill>
                   <a:srgbClr val="94A3B8"/>
                 </a:solidFill>
@@ -9336,7 +9336,7 @@
           </a:p>
           <a:p>
             <a:pPr>
-              <a:defRPr sz="1300">
+              <a:defRPr sz="1450">
                 <a:solidFill>
                   <a:srgbClr val="FFFFFF"/>
                 </a:solidFill>
@@ -9348,7 +9348,7 @@
           </a:p>
           <a:p>
             <a:pPr>
-              <a:defRPr sz="1300">
+              <a:defRPr sz="1450">
                 <a:solidFill>
                   <a:srgbClr val="94A3B8"/>
                 </a:solidFill>
@@ -9360,7 +9360,7 @@
           </a:p>
           <a:p>
             <a:pPr>
-              <a:defRPr sz="1300">
+              <a:defRPr sz="1450">
                 <a:solidFill>
                   <a:srgbClr val="FFFFFF"/>
                 </a:solidFill>
@@ -9372,7 +9372,7 @@
           </a:p>
           <a:p>
             <a:pPr>
-              <a:defRPr sz="1300">
+              <a:defRPr sz="1450">
                 <a:solidFill>
                   <a:srgbClr val="94A3B8"/>
                 </a:solidFill>
@@ -9384,7 +9384,7 @@
           </a:p>
           <a:p>
             <a:pPr>
-              <a:defRPr sz="1300">
+              <a:defRPr sz="1450">
                 <a:solidFill>
                   <a:srgbClr val="FFFFFF"/>
                 </a:solidFill>
@@ -9396,7 +9396,7 @@
           </a:p>
           <a:p>
             <a:pPr>
-              <a:defRPr sz="1300">
+              <a:defRPr sz="1450">
                 <a:solidFill>
                   <a:srgbClr val="94A3B8"/>
                 </a:solidFill>
@@ -9431,16 +9431,16 @@
           <a:lstStyle/>
           <a:p>
             <a:r>
-              <a:rPr sz="850" b="1">
+              <a:rPr sz="950" b="1">
                 <a:solidFill>
                   <a:srgbClr val="3FD0E6"/>
                 </a:solidFill>
                 <a:latin typeface="JetBrains Mono"/>
               </a:rPr>
-              <a:t>🎤 Jéssica David (4ª) / Fernando Barreto (5ª)   |   </a:t>
-            </a:r>
-            <a:r>
-              <a:rPr sz="850">
+              <a:t>🎤 Jéssica David (4ª) / Joel (5ª)   |   </a:t>
+            </a:r>
+            <a:r>
+              <a:rPr sz="900">
                 <a:solidFill>
                   <a:srgbClr val="94A3B8"/>
                 </a:solidFill>
@@ -9614,7 +9614,7 @@
           <a:lstStyle/>
           <a:p>
             <a:pPr>
-              <a:defRPr sz="1300">
+              <a:defRPr sz="1450">
                 <a:solidFill>
                   <a:srgbClr val="FFFFFF"/>
                 </a:solidFill>
@@ -9626,7 +9626,7 @@
           </a:p>
           <a:p>
             <a:pPr>
-              <a:defRPr sz="1300">
+              <a:defRPr sz="1450">
                 <a:solidFill>
                   <a:srgbClr val="94A3B8"/>
                 </a:solidFill>
@@ -9638,7 +9638,7 @@
           </a:p>
           <a:p>
             <a:pPr>
-              <a:defRPr sz="1300">
+              <a:defRPr sz="1450">
                 <a:solidFill>
                   <a:srgbClr val="FFFFFF"/>
                 </a:solidFill>
@@ -9650,7 +9650,7 @@
           </a:p>
           <a:p>
             <a:pPr>
-              <a:defRPr sz="1300">
+              <a:defRPr sz="1450">
                 <a:solidFill>
                   <a:srgbClr val="94A3B8"/>
                 </a:solidFill>
@@ -9662,7 +9662,7 @@
           </a:p>
           <a:p>
             <a:pPr>
-              <a:defRPr sz="1300">
+              <a:defRPr sz="1450">
                 <a:solidFill>
                   <a:srgbClr val="FFFFFF"/>
                 </a:solidFill>
@@ -9674,7 +9674,7 @@
           </a:p>
           <a:p>
             <a:pPr>
-              <a:defRPr sz="1300">
+              <a:defRPr sz="1450">
                 <a:solidFill>
                   <a:srgbClr val="94A3B8"/>
                 </a:solidFill>
@@ -9686,7 +9686,7 @@
           </a:p>
           <a:p>
             <a:pPr>
-              <a:defRPr sz="1300">
+              <a:defRPr sz="1450">
                 <a:solidFill>
                   <a:srgbClr val="FFFFFF"/>
                 </a:solidFill>
@@ -9698,7 +9698,7 @@
           </a:p>
           <a:p>
             <a:pPr>
-              <a:defRPr sz="1300">
+              <a:defRPr sz="1450">
                 <a:solidFill>
                   <a:srgbClr val="94A3B8"/>
                 </a:solidFill>
@@ -9733,7 +9733,7 @@
           <a:lstStyle/>
           <a:p>
             <a:r>
-              <a:rPr sz="850" b="1">
+              <a:rPr sz="950" b="1">
                 <a:solidFill>
                   <a:srgbClr val="3FD0E6"/>
                 </a:solidFill>
@@ -9742,7 +9742,7 @@
               <a:t>🎤 Nathalia Neves (4ª) / Fernando Barreto (5ª)   |   </a:t>
             </a:r>
             <a:r>
-              <a:rPr sz="850">
+              <a:rPr sz="900">
                 <a:solidFill>
                   <a:srgbClr val="94A3B8"/>
                 </a:solidFill>
@@ -9916,7 +9916,7 @@
           <a:lstStyle/>
           <a:p>
             <a:pPr>
-              <a:defRPr sz="1300">
+              <a:defRPr sz="1450">
                 <a:solidFill>
                   <a:srgbClr val="FFFFFF"/>
                 </a:solidFill>
@@ -9928,7 +9928,7 @@
           </a:p>
           <a:p>
             <a:pPr>
-              <a:defRPr sz="1300">
+              <a:defRPr sz="1450">
                 <a:solidFill>
                   <a:srgbClr val="94A3B8"/>
                 </a:solidFill>
@@ -9940,7 +9940,7 @@
           </a:p>
           <a:p>
             <a:pPr>
-              <a:defRPr sz="1300">
+              <a:defRPr sz="1450">
                 <a:solidFill>
                   <a:srgbClr val="FFFFFF"/>
                 </a:solidFill>
@@ -9952,7 +9952,7 @@
           </a:p>
           <a:p>
             <a:pPr>
-              <a:defRPr sz="1300">
+              <a:defRPr sz="1450">
                 <a:solidFill>
                   <a:srgbClr val="94A3B8"/>
                 </a:solidFill>
@@ -9964,7 +9964,7 @@
           </a:p>
           <a:p>
             <a:pPr>
-              <a:defRPr sz="1300">
+              <a:defRPr sz="1450">
                 <a:solidFill>
                   <a:srgbClr val="FFFFFF"/>
                 </a:solidFill>
@@ -9976,7 +9976,7 @@
           </a:p>
           <a:p>
             <a:pPr>
-              <a:defRPr sz="1300">
+              <a:defRPr sz="1450">
                 <a:solidFill>
                   <a:srgbClr val="94A3B8"/>
                 </a:solidFill>
@@ -9988,7 +9988,7 @@
           </a:p>
           <a:p>
             <a:pPr>
-              <a:defRPr sz="1300">
+              <a:defRPr sz="1450">
                 <a:solidFill>
                   <a:srgbClr val="FFFFFF"/>
                 </a:solidFill>
@@ -10000,7 +10000,7 @@
           </a:p>
           <a:p>
             <a:pPr>
-              <a:defRPr sz="1300">
+              <a:defRPr sz="1450">
                 <a:solidFill>
                   <a:srgbClr val="94A3B8"/>
                 </a:solidFill>
@@ -10035,7 +10035,7 @@
           <a:lstStyle/>
           <a:p>
             <a:r>
-              <a:rPr sz="850" b="1">
+              <a:rPr sz="950" b="1">
                 <a:solidFill>
                   <a:srgbClr val="3FD0E6"/>
                 </a:solidFill>
@@ -10044,7 +10044,7 @@
               <a:t>🎤 Josué Jofre (4ª) / Marciele Toledo (5ª)   |   </a:t>
             </a:r>
             <a:r>
-              <a:rPr sz="850">
+              <a:rPr sz="900">
                 <a:solidFill>
                   <a:srgbClr val="94A3B8"/>
                 </a:solidFill>
@@ -10218,7 +10218,7 @@
           <a:lstStyle/>
           <a:p>
             <a:pPr>
-              <a:defRPr sz="1300">
+              <a:defRPr sz="1450">
                 <a:solidFill>
                   <a:srgbClr val="FFFFFF"/>
                 </a:solidFill>
@@ -10230,7 +10230,7 @@
           </a:p>
           <a:p>
             <a:pPr>
-              <a:defRPr sz="1300">
+              <a:defRPr sz="1450">
                 <a:solidFill>
                   <a:srgbClr val="94A3B8"/>
                 </a:solidFill>
@@ -10242,7 +10242,7 @@
           </a:p>
           <a:p>
             <a:pPr>
-              <a:defRPr sz="1300">
+              <a:defRPr sz="1450">
                 <a:solidFill>
                   <a:srgbClr val="FFFFFF"/>
                 </a:solidFill>
@@ -10254,7 +10254,7 @@
           </a:p>
           <a:p>
             <a:pPr>
-              <a:defRPr sz="1300">
+              <a:defRPr sz="1450">
                 <a:solidFill>
                   <a:srgbClr val="94A3B8"/>
                 </a:solidFill>
@@ -10266,7 +10266,7 @@
           </a:p>
           <a:p>
             <a:pPr>
-              <a:defRPr sz="1300">
+              <a:defRPr sz="1450">
                 <a:solidFill>
                   <a:srgbClr val="FFFFFF"/>
                 </a:solidFill>
@@ -10278,7 +10278,7 @@
           </a:p>
           <a:p>
             <a:pPr>
-              <a:defRPr sz="1300">
+              <a:defRPr sz="1450">
                 <a:solidFill>
                   <a:srgbClr val="94A3B8"/>
                 </a:solidFill>
@@ -10290,7 +10290,7 @@
           </a:p>
           <a:p>
             <a:pPr>
-              <a:defRPr sz="1300">
+              <a:defRPr sz="1450">
                 <a:solidFill>
                   <a:srgbClr val="FFFFFF"/>
                 </a:solidFill>
@@ -10302,7 +10302,7 @@
           </a:p>
           <a:p>
             <a:pPr>
-              <a:defRPr sz="1300">
+              <a:defRPr sz="1450">
                 <a:solidFill>
                   <a:srgbClr val="94A3B8"/>
                 </a:solidFill>
@@ -10337,7 +10337,7 @@
           <a:lstStyle/>
           <a:p>
             <a:r>
-              <a:rPr sz="850" b="1">
+              <a:rPr sz="950" b="1">
                 <a:solidFill>
                   <a:srgbClr val="3FD0E6"/>
                 </a:solidFill>
@@ -10346,7 +10346,7 @@
               <a:t>🎤 Josué Jofre (4ª) / Marciele Toledo (5ª)   |   </a:t>
             </a:r>
             <a:r>
-              <a:rPr sz="850">
+              <a:rPr sz="900">
                 <a:solidFill>
                   <a:srgbClr val="94A3B8"/>
                 </a:solidFill>
@@ -10520,7 +10520,7 @@
           <a:lstStyle/>
           <a:p>
             <a:pPr>
-              <a:defRPr sz="1300">
+              <a:defRPr sz="1450">
                 <a:solidFill>
                   <a:srgbClr val="FFFFFF"/>
                 </a:solidFill>
@@ -10532,7 +10532,7 @@
           </a:p>
           <a:p>
             <a:pPr>
-              <a:defRPr sz="1300">
+              <a:defRPr sz="1450">
                 <a:solidFill>
                   <a:srgbClr val="94A3B8"/>
                 </a:solidFill>
@@ -10544,7 +10544,7 @@
           </a:p>
           <a:p>
             <a:pPr>
-              <a:defRPr sz="1300">
+              <a:defRPr sz="1450">
                 <a:solidFill>
                   <a:srgbClr val="FFFFFF"/>
                 </a:solidFill>
@@ -10556,7 +10556,7 @@
           </a:p>
           <a:p>
             <a:pPr>
-              <a:defRPr sz="1300">
+              <a:defRPr sz="1450">
                 <a:solidFill>
                   <a:srgbClr val="94A3B8"/>
                 </a:solidFill>
@@ -10568,7 +10568,7 @@
           </a:p>
           <a:p>
             <a:pPr>
-              <a:defRPr sz="1300">
+              <a:defRPr sz="1450">
                 <a:solidFill>
                   <a:srgbClr val="FFFFFF"/>
                 </a:solidFill>
@@ -10580,7 +10580,7 @@
           </a:p>
           <a:p>
             <a:pPr>
-              <a:defRPr sz="1300">
+              <a:defRPr sz="1450">
                 <a:solidFill>
                   <a:srgbClr val="94A3B8"/>
                 </a:solidFill>
@@ -10592,7 +10592,7 @@
           </a:p>
           <a:p>
             <a:pPr>
-              <a:defRPr sz="1300">
+              <a:defRPr sz="1450">
                 <a:solidFill>
                   <a:srgbClr val="FFFFFF"/>
                 </a:solidFill>
@@ -10604,7 +10604,7 @@
           </a:p>
           <a:p>
             <a:pPr>
-              <a:defRPr sz="1300">
+              <a:defRPr sz="1450">
                 <a:solidFill>
                   <a:srgbClr val="94A3B8"/>
                 </a:solidFill>
@@ -10639,7 +10639,7 @@
           <a:lstStyle/>
           <a:p>
             <a:r>
-              <a:rPr sz="850" b="1">
+              <a:rPr sz="950" b="1">
                 <a:solidFill>
                   <a:srgbClr val="3FD0E6"/>
                 </a:solidFill>
@@ -10648,7 +10648,7 @@
               <a:t>🎤 Josué Jofre (4ª) / Marciele Toledo (5ª)   |   </a:t>
             </a:r>
             <a:r>
-              <a:rPr sz="850">
+              <a:rPr sz="900">
                 <a:solidFill>
                   <a:srgbClr val="94A3B8"/>
                 </a:solidFill>
@@ -10822,7 +10822,7 @@
           <a:lstStyle/>
           <a:p>
             <a:pPr>
-              <a:defRPr sz="1300">
+              <a:defRPr sz="1450">
                 <a:solidFill>
                   <a:srgbClr val="FFFFFF"/>
                 </a:solidFill>
@@ -10834,7 +10834,7 @@
           </a:p>
           <a:p>
             <a:pPr>
-              <a:defRPr sz="1300">
+              <a:defRPr sz="1450">
                 <a:solidFill>
                   <a:srgbClr val="94A3B8"/>
                 </a:solidFill>
@@ -10846,7 +10846,7 @@
           </a:p>
           <a:p>
             <a:pPr>
-              <a:defRPr sz="1300">
+              <a:defRPr sz="1450">
                 <a:solidFill>
                   <a:srgbClr val="FFFFFF"/>
                 </a:solidFill>
@@ -10858,7 +10858,7 @@
           </a:p>
           <a:p>
             <a:pPr>
-              <a:defRPr sz="1300">
+              <a:defRPr sz="1450">
                 <a:solidFill>
                   <a:srgbClr val="94A3B8"/>
                 </a:solidFill>
@@ -10870,7 +10870,7 @@
           </a:p>
           <a:p>
             <a:pPr>
-              <a:defRPr sz="1300">
+              <a:defRPr sz="1450">
                 <a:solidFill>
                   <a:srgbClr val="FFFFFF"/>
                 </a:solidFill>
@@ -10882,7 +10882,7 @@
           </a:p>
           <a:p>
             <a:pPr>
-              <a:defRPr sz="1300">
+              <a:defRPr sz="1450">
                 <a:solidFill>
                   <a:srgbClr val="94A3B8"/>
                 </a:solidFill>
@@ -10894,7 +10894,7 @@
           </a:p>
           <a:p>
             <a:pPr>
-              <a:defRPr sz="1300">
+              <a:defRPr sz="1450">
                 <a:solidFill>
                   <a:srgbClr val="FFFFFF"/>
                 </a:solidFill>
@@ -10906,7 +10906,7 @@
           </a:p>
           <a:p>
             <a:pPr>
-              <a:defRPr sz="1300">
+              <a:defRPr sz="1450">
                 <a:solidFill>
                   <a:srgbClr val="94A3B8"/>
                 </a:solidFill>
@@ -10941,7 +10941,7 @@
           <a:lstStyle/>
           <a:p>
             <a:r>
-              <a:rPr sz="850" b="1">
+              <a:rPr sz="950" b="1">
                 <a:solidFill>
                   <a:srgbClr val="3FD0E6"/>
                 </a:solidFill>
@@ -10950,7 +10950,7 @@
               <a:t>🎤 Josué Jofre (4ª) / Marciele Toledo (5ª)   |   </a:t>
             </a:r>
             <a:r>
-              <a:rPr sz="850">
+              <a:rPr sz="900">
                 <a:solidFill>
                   <a:srgbClr val="94A3B8"/>
                 </a:solidFill>
@@ -11229,7 +11229,7 @@
           <a:lstStyle/>
           <a:p>
             <a:r>
-              <a:rPr sz="850" b="1">
+              <a:rPr sz="950" b="1">
                 <a:solidFill>
                   <a:srgbClr val="3FD0E6"/>
                 </a:solidFill>
@@ -11238,7 +11238,7 @@
               <a:t>🎤 Lilian Veiga (4ª) / Marciele Toledo (5ª)   |   </a:t>
             </a:r>
             <a:r>
-              <a:rPr sz="850">
+              <a:rPr sz="900">
                 <a:solidFill>
                   <a:srgbClr val="94A3B8"/>
                 </a:solidFill>
@@ -11539,7 +11539,7 @@
           <a:lstStyle/>
           <a:p>
             <a:r>
-              <a:rPr sz="850" b="1">
+              <a:rPr sz="950" b="1">
                 <a:solidFill>
                   <a:srgbClr val="3FD0E6"/>
                 </a:solidFill>
@@ -11548,7 +11548,7 @@
               <a:t>🎤 Lilian Veiga (4ª) / Marciele Toledo (5ª)   |   </a:t>
             </a:r>
             <a:r>
-              <a:rPr sz="850">
+              <a:rPr sz="900">
                 <a:solidFill>
                   <a:srgbClr val="94A3B8"/>
                 </a:solidFill>
@@ -11702,7 +11702,7 @@
           <a:lstStyle/>
           <a:p>
             <a:r>
-              <a:rPr sz="850" b="1">
+              <a:rPr sz="950" b="1">
                 <a:solidFill>
                   <a:srgbClr val="3FD0E6"/>
                 </a:solidFill>
@@ -11711,7 +11711,7 @@
               <a:t>🎤 Lilian Veiga (4ª) / Marciele Toledo (5ª)   |   </a:t>
             </a:r>
             <a:r>
-              <a:rPr sz="850">
+              <a:rPr sz="900">
                 <a:solidFill>
                   <a:srgbClr val="94A3B8"/>
                 </a:solidFill>
@@ -11865,7 +11865,7 @@
           <a:lstStyle/>
           <a:p>
             <a:r>
-              <a:rPr sz="850" b="1">
+              <a:rPr sz="950" b="1">
                 <a:solidFill>
                   <a:srgbClr val="3FD0E6"/>
                 </a:solidFill>
@@ -11874,7 +11874,7 @@
               <a:t>🎤 Lilian Veiga (4ª) / Marciele Toledo (5ª)   |   </a:t>
             </a:r>
             <a:r>
-              <a:rPr sz="850">
+              <a:rPr sz="900">
                 <a:solidFill>
                   <a:srgbClr val="94A3B8"/>
                 </a:solidFill>
@@ -12028,7 +12028,7 @@
           <a:lstStyle/>
           <a:p>
             <a:r>
-              <a:rPr sz="850" b="1">
+              <a:rPr sz="950" b="1">
                 <a:solidFill>
                   <a:srgbClr val="3FD0E6"/>
                 </a:solidFill>
@@ -12037,7 +12037,7 @@
               <a:t>🎤 Lilian Veiga (4ª) / Marciele Toledo (5ª)   |   </a:t>
             </a:r>
             <a:r>
-              <a:rPr sz="850">
+              <a:rPr sz="900">
                 <a:solidFill>
                   <a:srgbClr val="94A3B8"/>
                 </a:solidFill>
@@ -12191,7 +12191,7 @@
           <a:lstStyle/>
           <a:p>
             <a:r>
-              <a:rPr sz="850" b="1">
+              <a:rPr sz="950" b="1">
                 <a:solidFill>
                   <a:srgbClr val="3FD0E6"/>
                 </a:solidFill>
@@ -12200,7 +12200,7 @@
               <a:t>🎤 Lilian Veiga (4ª) / Marciele Toledo (5ª)   |   </a:t>
             </a:r>
             <a:r>
-              <a:rPr sz="850">
+              <a:rPr sz="900">
                 <a:solidFill>
                   <a:srgbClr val="94A3B8"/>
                 </a:solidFill>
@@ -12374,7 +12374,7 @@
           <a:lstStyle/>
           <a:p>
             <a:pPr>
-              <a:defRPr sz="1300">
+              <a:defRPr sz="1450">
                 <a:solidFill>
                   <a:srgbClr val="FFFFFF"/>
                 </a:solidFill>
@@ -12386,7 +12386,7 @@
           </a:p>
           <a:p>
             <a:pPr>
-              <a:defRPr sz="1300">
+              <a:defRPr sz="1450">
                 <a:solidFill>
                   <a:srgbClr val="94A3B8"/>
                 </a:solidFill>
@@ -12398,7 +12398,7 @@
           </a:p>
           <a:p>
             <a:pPr>
-              <a:defRPr sz="1300">
+              <a:defRPr sz="1450">
                 <a:solidFill>
                   <a:srgbClr val="FFFFFF"/>
                 </a:solidFill>
@@ -12410,7 +12410,7 @@
           </a:p>
           <a:p>
             <a:pPr>
-              <a:defRPr sz="1300">
+              <a:defRPr sz="1450">
                 <a:solidFill>
                   <a:srgbClr val="94A3B8"/>
                 </a:solidFill>
@@ -12422,7 +12422,7 @@
           </a:p>
           <a:p>
             <a:pPr>
-              <a:defRPr sz="1300">
+              <a:defRPr sz="1450">
                 <a:solidFill>
                   <a:srgbClr val="FFFFFF"/>
                 </a:solidFill>
@@ -12434,7 +12434,7 @@
           </a:p>
           <a:p>
             <a:pPr>
-              <a:defRPr sz="1300">
+              <a:defRPr sz="1450">
                 <a:solidFill>
                   <a:srgbClr val="94A3B8"/>
                 </a:solidFill>
@@ -12446,7 +12446,7 @@
           </a:p>
           <a:p>
             <a:pPr>
-              <a:defRPr sz="1300">
+              <a:defRPr sz="1450">
                 <a:solidFill>
                   <a:srgbClr val="FFFFFF"/>
                 </a:solidFill>
@@ -12458,7 +12458,7 @@
           </a:p>
           <a:p>
             <a:pPr>
-              <a:defRPr sz="1300">
+              <a:defRPr sz="1450">
                 <a:solidFill>
                   <a:srgbClr val="94A3B8"/>
                 </a:solidFill>
@@ -12493,7 +12493,7 @@
           <a:lstStyle/>
           <a:p>
             <a:r>
-              <a:rPr sz="850" b="1">
+              <a:rPr sz="950" b="1">
                 <a:solidFill>
                   <a:srgbClr val="3FD0E6"/>
                 </a:solidFill>
@@ -12502,7 +12502,7 @@
               <a:t>🎤 Josué Jofre (4ª) / Marciele Toledo (5ª)   |   </a:t>
             </a:r>
             <a:r>
-              <a:rPr sz="850">
+              <a:rPr sz="900">
                 <a:solidFill>
                   <a:srgbClr val="94A3B8"/>
                 </a:solidFill>
@@ -12656,7 +12656,7 @@
           <a:lstStyle/>
           <a:p>
             <a:r>
-              <a:rPr sz="850" b="1">
+              <a:rPr sz="950" b="1">
                 <a:solidFill>
                   <a:srgbClr val="3FD0E6"/>
                 </a:solidFill>
@@ -12665,7 +12665,7 @@
               <a:t>🎤 Lilian Veiga (4ª) / Marciele Toledo (5ª)   |   </a:t>
             </a:r>
             <a:r>
-              <a:rPr sz="850">
+              <a:rPr sz="900">
                 <a:solidFill>
                   <a:srgbClr val="94A3B8"/>
                 </a:solidFill>
@@ -12819,7 +12819,7 @@
           <a:lstStyle/>
           <a:p>
             <a:r>
-              <a:rPr sz="850" b="1">
+              <a:rPr sz="950" b="1">
                 <a:solidFill>
                   <a:srgbClr val="3FD0E6"/>
                 </a:solidFill>
@@ -12828,7 +12828,7 @@
               <a:t>🎤 Lilian Veiga (4ª) / Marciele Toledo (5ª)   |   </a:t>
             </a:r>
             <a:r>
-              <a:rPr sz="850">
+              <a:rPr sz="900">
                 <a:solidFill>
                   <a:srgbClr val="94A3B8"/>
                 </a:solidFill>
@@ -13482,7 +13482,7 @@
           <a:lstStyle/>
           <a:p>
             <a:r>
-              <a:rPr sz="850" b="1">
+              <a:rPr sz="950" b="1">
                 <a:solidFill>
                   <a:srgbClr val="3FD0E6"/>
                 </a:solidFill>
@@ -13491,7 +13491,7 @@
               <a:t>🎤 Lilian Veiga (4ª) / Marciele Toledo (5ª)   |   </a:t>
             </a:r>
             <a:r>
-              <a:rPr sz="850">
+              <a:rPr sz="900">
                 <a:solidFill>
                   <a:srgbClr val="94A3B8"/>
                 </a:solidFill>
@@ -13665,7 +13665,7 @@
           <a:lstStyle/>
           <a:p>
             <a:pPr>
-              <a:defRPr sz="1300">
+              <a:defRPr sz="1450">
                 <a:solidFill>
                   <a:srgbClr val="FFFFFF"/>
                 </a:solidFill>
@@ -13677,7 +13677,7 @@
           </a:p>
           <a:p>
             <a:pPr>
-              <a:defRPr sz="1300">
+              <a:defRPr sz="1450">
                 <a:solidFill>
                   <a:srgbClr val="94A3B8"/>
                 </a:solidFill>
@@ -13689,7 +13689,7 @@
           </a:p>
           <a:p>
             <a:pPr>
-              <a:defRPr sz="1300">
+              <a:defRPr sz="1450">
                 <a:solidFill>
                   <a:srgbClr val="FFFFFF"/>
                 </a:solidFill>
@@ -13701,7 +13701,7 @@
           </a:p>
           <a:p>
             <a:pPr>
-              <a:defRPr sz="1300">
+              <a:defRPr sz="1450">
                 <a:solidFill>
                   <a:srgbClr val="94A3B8"/>
                 </a:solidFill>
@@ -13713,7 +13713,7 @@
           </a:p>
           <a:p>
             <a:pPr>
-              <a:defRPr sz="1300">
+              <a:defRPr sz="1450">
                 <a:solidFill>
                   <a:srgbClr val="FFFFFF"/>
                 </a:solidFill>
@@ -13725,7 +13725,7 @@
           </a:p>
           <a:p>
             <a:pPr>
-              <a:defRPr sz="1300">
+              <a:defRPr sz="1450">
                 <a:solidFill>
                   <a:srgbClr val="94A3B8"/>
                 </a:solidFill>
@@ -13737,7 +13737,7 @@
           </a:p>
           <a:p>
             <a:pPr>
-              <a:defRPr sz="1300">
+              <a:defRPr sz="1450">
                 <a:solidFill>
                   <a:srgbClr val="FFFFFF"/>
                 </a:solidFill>
@@ -13749,7 +13749,7 @@
           </a:p>
           <a:p>
             <a:pPr>
-              <a:defRPr sz="1300">
+              <a:defRPr sz="1450">
                 <a:solidFill>
                   <a:srgbClr val="94A3B8"/>
                 </a:solidFill>
@@ -13784,7 +13784,7 @@
           <a:lstStyle/>
           <a:p>
             <a:r>
-              <a:rPr sz="850" b="1">
+              <a:rPr sz="950" b="1">
                 <a:solidFill>
                   <a:srgbClr val="3FD0E6"/>
                 </a:solidFill>
@@ -13793,7 +13793,7 @@
               <a:t>🎤 Lilian Veiga (4ª) / Marciele Toledo (5ª)   |   </a:t>
             </a:r>
             <a:r>
-              <a:rPr sz="850">
+              <a:rPr sz="900">
                 <a:solidFill>
                   <a:srgbClr val="94A3B8"/>
                 </a:solidFill>
@@ -13967,7 +13967,7 @@
           <a:lstStyle/>
           <a:p>
             <a:pPr>
-              <a:defRPr sz="1300">
+              <a:defRPr sz="1450">
                 <a:solidFill>
                   <a:srgbClr val="FFFFFF"/>
                 </a:solidFill>
@@ -13979,7 +13979,7 @@
           </a:p>
           <a:p>
             <a:pPr>
-              <a:defRPr sz="1300">
+              <a:defRPr sz="1450">
                 <a:solidFill>
                   <a:srgbClr val="94A3B8"/>
                 </a:solidFill>
@@ -13991,7 +13991,7 @@
           </a:p>
           <a:p>
             <a:pPr>
-              <a:defRPr sz="1300">
+              <a:defRPr sz="1450">
                 <a:solidFill>
                   <a:srgbClr val="FFFFFF"/>
                 </a:solidFill>
@@ -14003,7 +14003,7 @@
           </a:p>
           <a:p>
             <a:pPr>
-              <a:defRPr sz="1300">
+              <a:defRPr sz="1450">
                 <a:solidFill>
                   <a:srgbClr val="94A3B8"/>
                 </a:solidFill>
@@ -14015,7 +14015,7 @@
           </a:p>
           <a:p>
             <a:pPr>
-              <a:defRPr sz="1300">
+              <a:defRPr sz="1450">
                 <a:solidFill>
                   <a:srgbClr val="FFFFFF"/>
                 </a:solidFill>
@@ -14027,7 +14027,7 @@
           </a:p>
           <a:p>
             <a:pPr>
-              <a:defRPr sz="1300">
+              <a:defRPr sz="1450">
                 <a:solidFill>
                   <a:srgbClr val="94A3B8"/>
                 </a:solidFill>
@@ -14039,7 +14039,7 @@
           </a:p>
           <a:p>
             <a:pPr>
-              <a:defRPr sz="1300">
+              <a:defRPr sz="1450">
                 <a:solidFill>
                   <a:srgbClr val="FFFFFF"/>
                 </a:solidFill>
@@ -14051,7 +14051,7 @@
           </a:p>
           <a:p>
             <a:pPr>
-              <a:defRPr sz="1300">
+              <a:defRPr sz="1450">
                 <a:solidFill>
                   <a:srgbClr val="94A3B8"/>
                 </a:solidFill>
@@ -14086,7 +14086,7 @@
           <a:lstStyle/>
           <a:p>
             <a:r>
-              <a:rPr sz="850" b="1">
+              <a:rPr sz="950" b="1">
                 <a:solidFill>
                   <a:srgbClr val="3FD0E6"/>
                 </a:solidFill>
@@ -14095,7 +14095,7 @@
               <a:t>🎤 Josué Jofre (4ª) / Marciele Toledo (5ª)   |   </a:t>
             </a:r>
             <a:r>
-              <a:rPr sz="850">
+              <a:rPr sz="900">
                 <a:solidFill>
                   <a:srgbClr val="94A3B8"/>
                 </a:solidFill>
@@ -14269,7 +14269,7 @@
           <a:lstStyle/>
           <a:p>
             <a:pPr>
-              <a:defRPr sz="1300">
+              <a:defRPr sz="1450">
                 <a:solidFill>
                   <a:srgbClr val="FFFFFF"/>
                 </a:solidFill>
@@ -14281,7 +14281,7 @@
           </a:p>
           <a:p>
             <a:pPr>
-              <a:defRPr sz="1300">
+              <a:defRPr sz="1450">
                 <a:solidFill>
                   <a:srgbClr val="94A3B8"/>
                 </a:solidFill>
@@ -14293,7 +14293,7 @@
           </a:p>
           <a:p>
             <a:pPr>
-              <a:defRPr sz="1300">
+              <a:defRPr sz="1450">
                 <a:solidFill>
                   <a:srgbClr val="FFFFFF"/>
                 </a:solidFill>
@@ -14305,7 +14305,7 @@
           </a:p>
           <a:p>
             <a:pPr>
-              <a:defRPr sz="1300">
+              <a:defRPr sz="1450">
                 <a:solidFill>
                   <a:srgbClr val="94A3B8"/>
                 </a:solidFill>
@@ -14317,7 +14317,7 @@
           </a:p>
           <a:p>
             <a:pPr>
-              <a:defRPr sz="1300">
+              <a:defRPr sz="1450">
                 <a:solidFill>
                   <a:srgbClr val="FFFFFF"/>
                 </a:solidFill>
@@ -14329,7 +14329,7 @@
           </a:p>
           <a:p>
             <a:pPr>
-              <a:defRPr sz="1300">
+              <a:defRPr sz="1450">
                 <a:solidFill>
                   <a:srgbClr val="94A3B8"/>
                 </a:solidFill>
@@ -14341,7 +14341,7 @@
           </a:p>
           <a:p>
             <a:pPr>
-              <a:defRPr sz="1300">
+              <a:defRPr sz="1450">
                 <a:solidFill>
                   <a:srgbClr val="FFFFFF"/>
                 </a:solidFill>
@@ -14353,7 +14353,7 @@
           </a:p>
           <a:p>
             <a:pPr>
-              <a:defRPr sz="1300">
+              <a:defRPr sz="1450">
                 <a:solidFill>
                   <a:srgbClr val="94A3B8"/>
                 </a:solidFill>
@@ -14388,7 +14388,7 @@
           <a:lstStyle/>
           <a:p>
             <a:r>
-              <a:rPr sz="850" b="1">
+              <a:rPr sz="950" b="1">
                 <a:solidFill>
                   <a:srgbClr val="3FD0E6"/>
                 </a:solidFill>
@@ -14397,7 +14397,7 @@
               <a:t>🎤 Renato Paschoal (4ª e 5ª)   |   </a:t>
             </a:r>
             <a:r>
-              <a:rPr sz="850">
+              <a:rPr sz="900">
                 <a:solidFill>
                   <a:srgbClr val="94A3B8"/>
                 </a:solidFill>
@@ -14571,7 +14571,7 @@
           <a:lstStyle/>
           <a:p>
             <a:pPr>
-              <a:defRPr sz="1300">
+              <a:defRPr sz="1450">
                 <a:solidFill>
                   <a:srgbClr val="FFFFFF"/>
                 </a:solidFill>
@@ -14583,7 +14583,7 @@
           </a:p>
           <a:p>
             <a:pPr>
-              <a:defRPr sz="1300">
+              <a:defRPr sz="1450">
                 <a:solidFill>
                   <a:srgbClr val="94A3B8"/>
                 </a:solidFill>
@@ -14595,7 +14595,7 @@
           </a:p>
           <a:p>
             <a:pPr>
-              <a:defRPr sz="1300">
+              <a:defRPr sz="1450">
                 <a:solidFill>
                   <a:srgbClr val="FFFFFF"/>
                 </a:solidFill>
@@ -14607,7 +14607,7 @@
           </a:p>
           <a:p>
             <a:pPr>
-              <a:defRPr sz="1300">
+              <a:defRPr sz="1450">
                 <a:solidFill>
                   <a:srgbClr val="94A3B8"/>
                 </a:solidFill>
@@ -14619,7 +14619,7 @@
           </a:p>
           <a:p>
             <a:pPr>
-              <a:defRPr sz="1300">
+              <a:defRPr sz="1450">
                 <a:solidFill>
                   <a:srgbClr val="FFFFFF"/>
                 </a:solidFill>
@@ -14631,7 +14631,7 @@
           </a:p>
           <a:p>
             <a:pPr>
-              <a:defRPr sz="1300">
+              <a:defRPr sz="1450">
                 <a:solidFill>
                   <a:srgbClr val="94A3B8"/>
                 </a:solidFill>
@@ -14643,7 +14643,7 @@
           </a:p>
           <a:p>
             <a:pPr>
-              <a:defRPr sz="1300">
+              <a:defRPr sz="1450">
                 <a:solidFill>
                   <a:srgbClr val="FFFFFF"/>
                 </a:solidFill>
@@ -14655,7 +14655,7 @@
           </a:p>
           <a:p>
             <a:pPr>
-              <a:defRPr sz="1300">
+              <a:defRPr sz="1450">
                 <a:solidFill>
                   <a:srgbClr val="94A3B8"/>
                 </a:solidFill>
@@ -14690,7 +14690,7 @@
           <a:lstStyle/>
           <a:p>
             <a:r>
-              <a:rPr sz="850" b="1">
+              <a:rPr sz="950" b="1">
                 <a:solidFill>
                   <a:srgbClr val="3FD0E6"/>
                 </a:solidFill>
@@ -14699,7 +14699,7 @@
               <a:t>🎤 Renato Paschoal (4ª e 5ª)   |   </a:t>
             </a:r>
             <a:r>
-              <a:rPr sz="850">
+              <a:rPr sz="900">
                 <a:solidFill>
                   <a:srgbClr val="94A3B8"/>
                 </a:solidFill>
@@ -14873,7 +14873,7 @@
           <a:lstStyle/>
           <a:p>
             <a:pPr>
-              <a:defRPr sz="1300">
+              <a:defRPr sz="1450">
                 <a:solidFill>
                   <a:srgbClr val="FFFFFF"/>
                 </a:solidFill>
@@ -14885,7 +14885,7 @@
           </a:p>
           <a:p>
             <a:pPr>
-              <a:defRPr sz="1300">
+              <a:defRPr sz="1450">
                 <a:solidFill>
                   <a:srgbClr val="94A3B8"/>
                 </a:solidFill>
@@ -14897,7 +14897,7 @@
           </a:p>
           <a:p>
             <a:pPr>
-              <a:defRPr sz="1300">
+              <a:defRPr sz="1450">
                 <a:solidFill>
                   <a:srgbClr val="FFFFFF"/>
                 </a:solidFill>
@@ -14909,7 +14909,7 @@
           </a:p>
           <a:p>
             <a:pPr>
-              <a:defRPr sz="1300">
+              <a:defRPr sz="1450">
                 <a:solidFill>
                   <a:srgbClr val="94A3B8"/>
                 </a:solidFill>
@@ -14921,7 +14921,7 @@
           </a:p>
           <a:p>
             <a:pPr>
-              <a:defRPr sz="1300">
+              <a:defRPr sz="1450">
                 <a:solidFill>
                   <a:srgbClr val="FFFFFF"/>
                 </a:solidFill>
@@ -14933,7 +14933,7 @@
           </a:p>
           <a:p>
             <a:pPr>
-              <a:defRPr sz="1300">
+              <a:defRPr sz="1450">
                 <a:solidFill>
                   <a:srgbClr val="94A3B8"/>
                 </a:solidFill>
@@ -14945,7 +14945,7 @@
           </a:p>
           <a:p>
             <a:pPr>
-              <a:defRPr sz="1300">
+              <a:defRPr sz="1450">
                 <a:solidFill>
                   <a:srgbClr val="FFFFFF"/>
                 </a:solidFill>
@@ -14957,7 +14957,7 @@
           </a:p>
           <a:p>
             <a:pPr>
-              <a:defRPr sz="1300">
+              <a:defRPr sz="1450">
                 <a:solidFill>
                   <a:srgbClr val="94A3B8"/>
                 </a:solidFill>
@@ -14992,7 +14992,7 @@
           <a:lstStyle/>
           <a:p>
             <a:r>
-              <a:rPr sz="850" b="1">
+              <a:rPr sz="950" b="1">
                 <a:solidFill>
                   <a:srgbClr val="3FD0E6"/>
                 </a:solidFill>
@@ -15001,7 +15001,7 @@
               <a:t>🎤 Renato Paschoal (4ª e 5ª)   |   </a:t>
             </a:r>
             <a:r>
-              <a:rPr sz="850">
+              <a:rPr sz="900">
                 <a:solidFill>
                   <a:srgbClr val="94A3B8"/>
                 </a:solidFill>
@@ -15175,7 +15175,7 @@
           <a:lstStyle/>
           <a:p>
             <a:pPr>
-              <a:defRPr sz="1300">
+              <a:defRPr sz="1450">
                 <a:solidFill>
                   <a:srgbClr val="FFFFFF"/>
                 </a:solidFill>
@@ -15187,7 +15187,7 @@
           </a:p>
           <a:p>
             <a:pPr>
-              <a:defRPr sz="1300">
+              <a:defRPr sz="1450">
                 <a:solidFill>
                   <a:srgbClr val="94A3B8"/>
                 </a:solidFill>
@@ -15199,7 +15199,7 @@
           </a:p>
           <a:p>
             <a:pPr>
-              <a:defRPr sz="1300">
+              <a:defRPr sz="1450">
                 <a:solidFill>
                   <a:srgbClr val="FFFFFF"/>
                 </a:solidFill>
@@ -15211,7 +15211,7 @@
           </a:p>
           <a:p>
             <a:pPr>
-              <a:defRPr sz="1300">
+              <a:defRPr sz="1450">
                 <a:solidFill>
                   <a:srgbClr val="94A3B8"/>
                 </a:solidFill>
@@ -15223,7 +15223,7 @@
           </a:p>
           <a:p>
             <a:pPr>
-              <a:defRPr sz="1300">
+              <a:defRPr sz="1450">
                 <a:solidFill>
                   <a:srgbClr val="FFFFFF"/>
                 </a:solidFill>
@@ -15235,7 +15235,7 @@
           </a:p>
           <a:p>
             <a:pPr>
-              <a:defRPr sz="1300">
+              <a:defRPr sz="1450">
                 <a:solidFill>
                   <a:srgbClr val="94A3B8"/>
                 </a:solidFill>
@@ -15247,7 +15247,7 @@
           </a:p>
           <a:p>
             <a:pPr>
-              <a:defRPr sz="1300">
+              <a:defRPr sz="1450">
                 <a:solidFill>
                   <a:srgbClr val="FFFFFF"/>
                 </a:solidFill>
@@ -15259,7 +15259,7 @@
           </a:p>
           <a:p>
             <a:pPr>
-              <a:defRPr sz="1300">
+              <a:defRPr sz="1450">
                 <a:solidFill>
                   <a:srgbClr val="94A3B8"/>
                 </a:solidFill>
@@ -15294,7 +15294,7 @@
           <a:lstStyle/>
           <a:p>
             <a:r>
-              <a:rPr sz="850" b="1">
+              <a:rPr sz="950" b="1">
                 <a:solidFill>
                   <a:srgbClr val="3FD0E6"/>
                 </a:solidFill>
@@ -15303,7 +15303,7 @@
               <a:t>🎤 Renato Paschoal (4ª e 5ª)   |   </a:t>
             </a:r>
             <a:r>
-              <a:rPr sz="850">
+              <a:rPr sz="900">
                 <a:solidFill>
                   <a:srgbClr val="94A3B8"/>
                 </a:solidFill>
@@ -15477,7 +15477,7 @@
           <a:lstStyle/>
           <a:p>
             <a:pPr>
-              <a:defRPr sz="1300">
+              <a:defRPr sz="1450">
                 <a:solidFill>
                   <a:srgbClr val="FFFFFF"/>
                 </a:solidFill>
@@ -15489,7 +15489,7 @@
           </a:p>
           <a:p>
             <a:pPr>
-              <a:defRPr sz="1300">
+              <a:defRPr sz="1450">
                 <a:solidFill>
                   <a:srgbClr val="94A3B8"/>
                 </a:solidFill>
@@ -15501,7 +15501,7 @@
           </a:p>
           <a:p>
             <a:pPr>
-              <a:defRPr sz="1300">
+              <a:defRPr sz="1450">
                 <a:solidFill>
                   <a:srgbClr val="FFFFFF"/>
                 </a:solidFill>
@@ -15513,7 +15513,7 @@
           </a:p>
           <a:p>
             <a:pPr>
-              <a:defRPr sz="1300">
+              <a:defRPr sz="1450">
                 <a:solidFill>
                   <a:srgbClr val="94A3B8"/>
                 </a:solidFill>
@@ -15525,7 +15525,7 @@
           </a:p>
           <a:p>
             <a:pPr>
-              <a:defRPr sz="1300">
+              <a:defRPr sz="1450">
                 <a:solidFill>
                   <a:srgbClr val="FFFFFF"/>
                 </a:solidFill>
@@ -15537,7 +15537,7 @@
           </a:p>
           <a:p>
             <a:pPr>
-              <a:defRPr sz="1300">
+              <a:defRPr sz="1450">
                 <a:solidFill>
                   <a:srgbClr val="94A3B8"/>
                 </a:solidFill>
@@ -15549,7 +15549,7 @@
           </a:p>
           <a:p>
             <a:pPr>
-              <a:defRPr sz="1300">
+              <a:defRPr sz="1450">
                 <a:solidFill>
                   <a:srgbClr val="FFFFFF"/>
                 </a:solidFill>
@@ -15561,7 +15561,7 @@
           </a:p>
           <a:p>
             <a:pPr>
-              <a:defRPr sz="1300">
+              <a:defRPr sz="1450">
                 <a:solidFill>
                   <a:srgbClr val="94A3B8"/>
                 </a:solidFill>
@@ -15596,7 +15596,7 @@
           <a:lstStyle/>
           <a:p>
             <a:r>
-              <a:rPr sz="850" b="1">
+              <a:rPr sz="950" b="1">
                 <a:solidFill>
                   <a:srgbClr val="3FD0E6"/>
                 </a:solidFill>
@@ -15605,7 +15605,7 @@
               <a:t>🎤 Renato Paschoal (4ª e 5ª)   |   </a:t>
             </a:r>
             <a:r>
-              <a:rPr sz="850">
+              <a:rPr sz="900">
                 <a:solidFill>
                   <a:srgbClr val="94A3B8"/>
                 </a:solidFill>
@@ -15779,7 +15779,7 @@
           <a:lstStyle/>
           <a:p>
             <a:pPr>
-              <a:defRPr sz="1300">
+              <a:defRPr sz="1450">
                 <a:solidFill>
                   <a:srgbClr val="FFFFFF"/>
                 </a:solidFill>
@@ -15791,7 +15791,7 @@
           </a:p>
           <a:p>
             <a:pPr>
-              <a:defRPr sz="1300">
+              <a:defRPr sz="1450">
                 <a:solidFill>
                   <a:srgbClr val="94A3B8"/>
                 </a:solidFill>
@@ -15803,7 +15803,7 @@
           </a:p>
           <a:p>
             <a:pPr>
-              <a:defRPr sz="1300">
+              <a:defRPr sz="1450">
                 <a:solidFill>
                   <a:srgbClr val="FFFFFF"/>
                 </a:solidFill>
@@ -15815,7 +15815,7 @@
           </a:p>
           <a:p>
             <a:pPr>
-              <a:defRPr sz="1300">
+              <a:defRPr sz="1450">
                 <a:solidFill>
                   <a:srgbClr val="94A3B8"/>
                 </a:solidFill>
@@ -15827,7 +15827,7 @@
           </a:p>
           <a:p>
             <a:pPr>
-              <a:defRPr sz="1300">
+              <a:defRPr sz="1450">
                 <a:solidFill>
                   <a:srgbClr val="FFFFFF"/>
                 </a:solidFill>
@@ -15839,7 +15839,7 @@
           </a:p>
           <a:p>
             <a:pPr>
-              <a:defRPr sz="1300">
+              <a:defRPr sz="1450">
                 <a:solidFill>
                   <a:srgbClr val="94A3B8"/>
                 </a:solidFill>
@@ -15851,7 +15851,7 @@
           </a:p>
           <a:p>
             <a:pPr>
-              <a:defRPr sz="1300">
+              <a:defRPr sz="1450">
                 <a:solidFill>
                   <a:srgbClr val="FFFFFF"/>
                 </a:solidFill>
@@ -15863,7 +15863,7 @@
           </a:p>
           <a:p>
             <a:pPr>
-              <a:defRPr sz="1300">
+              <a:defRPr sz="1450">
                 <a:solidFill>
                   <a:srgbClr val="94A3B8"/>
                 </a:solidFill>
@@ -15898,7 +15898,7 @@
           <a:lstStyle/>
           <a:p>
             <a:r>
-              <a:rPr sz="850" b="1">
+              <a:rPr sz="950" b="1">
                 <a:solidFill>
                   <a:srgbClr val="3FD0E6"/>
                 </a:solidFill>
@@ -15907,7 +15907,7 @@
               <a:t>🎤 Nathalia Neves (4ª) / Fernando Barreto (5ª)   |   </a:t>
             </a:r>
             <a:r>
-              <a:rPr sz="850">
+              <a:rPr sz="900">
                 <a:solidFill>
                   <a:srgbClr val="94A3B8"/>
                 </a:solidFill>
@@ -16081,7 +16081,7 @@
           <a:lstStyle/>
           <a:p>
             <a:pPr>
-              <a:defRPr sz="1300">
+              <a:defRPr sz="1450">
                 <a:solidFill>
                   <a:srgbClr val="FFFFFF"/>
                 </a:solidFill>
@@ -16093,7 +16093,7 @@
           </a:p>
           <a:p>
             <a:pPr>
-              <a:defRPr sz="1300">
+              <a:defRPr sz="1450">
                 <a:solidFill>
                   <a:srgbClr val="94A3B8"/>
                 </a:solidFill>
@@ -16105,7 +16105,7 @@
           </a:p>
           <a:p>
             <a:pPr>
-              <a:defRPr sz="1300">
+              <a:defRPr sz="1450">
                 <a:solidFill>
                   <a:srgbClr val="FFFFFF"/>
                 </a:solidFill>
@@ -16117,7 +16117,7 @@
           </a:p>
           <a:p>
             <a:pPr>
-              <a:defRPr sz="1300">
+              <a:defRPr sz="1450">
                 <a:solidFill>
                   <a:srgbClr val="94A3B8"/>
                 </a:solidFill>
@@ -16129,7 +16129,7 @@
           </a:p>
           <a:p>
             <a:pPr>
-              <a:defRPr sz="1300">
+              <a:defRPr sz="1450">
                 <a:solidFill>
                   <a:srgbClr val="FFFFFF"/>
                 </a:solidFill>
@@ -16141,7 +16141,7 @@
           </a:p>
           <a:p>
             <a:pPr>
-              <a:defRPr sz="1300">
+              <a:defRPr sz="1450">
                 <a:solidFill>
                   <a:srgbClr val="94A3B8"/>
                 </a:solidFill>
@@ -16153,7 +16153,7 @@
           </a:p>
           <a:p>
             <a:pPr>
-              <a:defRPr sz="1300">
+              <a:defRPr sz="1450">
                 <a:solidFill>
                   <a:srgbClr val="FFFFFF"/>
                 </a:solidFill>
@@ -16165,7 +16165,7 @@
           </a:p>
           <a:p>
             <a:pPr>
-              <a:defRPr sz="1300">
+              <a:defRPr sz="1450">
                 <a:solidFill>
                   <a:srgbClr val="94A3B8"/>
                 </a:solidFill>
@@ -16200,7 +16200,7 @@
           <a:lstStyle/>
           <a:p>
             <a:r>
-              <a:rPr sz="850" b="1">
+              <a:rPr sz="950" b="1">
                 <a:solidFill>
                   <a:srgbClr val="3FD0E6"/>
                 </a:solidFill>
@@ -16209,7 +16209,7 @@
               <a:t>🎤 Jéssica David (4ª) / Fernando Barreto (5ª)   |   </a:t>
             </a:r>
             <a:r>
-              <a:rPr sz="850">
+              <a:rPr sz="900">
                 <a:solidFill>
                   <a:srgbClr val="94A3B8"/>
                 </a:solidFill>
@@ -16383,7 +16383,7 @@
           <a:lstStyle/>
           <a:p>
             <a:pPr>
-              <a:defRPr sz="1300">
+              <a:defRPr sz="1450">
                 <a:solidFill>
                   <a:srgbClr val="FFFFFF"/>
                 </a:solidFill>
@@ -16395,7 +16395,7 @@
           </a:p>
           <a:p>
             <a:pPr>
-              <a:defRPr sz="1300">
+              <a:defRPr sz="1450">
                 <a:solidFill>
                   <a:srgbClr val="94A3B8"/>
                 </a:solidFill>
@@ -16407,7 +16407,7 @@
           </a:p>
           <a:p>
             <a:pPr>
-              <a:defRPr sz="1300">
+              <a:defRPr sz="1450">
                 <a:solidFill>
                   <a:srgbClr val="FFFFFF"/>
                 </a:solidFill>
@@ -16419,7 +16419,7 @@
           </a:p>
           <a:p>
             <a:pPr>
-              <a:defRPr sz="1300">
+              <a:defRPr sz="1450">
                 <a:solidFill>
                   <a:srgbClr val="94A3B8"/>
                 </a:solidFill>
@@ -16431,7 +16431,7 @@
           </a:p>
           <a:p>
             <a:pPr>
-              <a:defRPr sz="1300">
+              <a:defRPr sz="1450">
                 <a:solidFill>
                   <a:srgbClr val="FFFFFF"/>
                 </a:solidFill>
@@ -16443,7 +16443,7 @@
           </a:p>
           <a:p>
             <a:pPr>
-              <a:defRPr sz="1300">
+              <a:defRPr sz="1450">
                 <a:solidFill>
                   <a:srgbClr val="94A3B8"/>
                 </a:solidFill>
@@ -16455,7 +16455,7 @@
           </a:p>
           <a:p>
             <a:pPr>
-              <a:defRPr sz="1300">
+              <a:defRPr sz="1450">
                 <a:solidFill>
                   <a:srgbClr val="FFFFFF"/>
                 </a:solidFill>
@@ -16467,7 +16467,7 @@
           </a:p>
           <a:p>
             <a:pPr>
-              <a:defRPr sz="1300">
+              <a:defRPr sz="1450">
                 <a:solidFill>
                   <a:srgbClr val="94A3B8"/>
                 </a:solidFill>
@@ -16502,7 +16502,7 @@
           <a:lstStyle/>
           <a:p>
             <a:r>
-              <a:rPr sz="850" b="1">
+              <a:rPr sz="950" b="1">
                 <a:solidFill>
                   <a:srgbClr val="3FD0E6"/>
                 </a:solidFill>
@@ -16511,7 +16511,7 @@
               <a:t>🎤 Jéssica David (4ª) / Fernando Barreto (5ª)   |   </a:t>
             </a:r>
             <a:r>
-              <a:rPr sz="850">
+              <a:rPr sz="900">
                 <a:solidFill>
                   <a:srgbClr val="94A3B8"/>
                 </a:solidFill>
@@ -16685,7 +16685,7 @@
           <a:lstStyle/>
           <a:p>
             <a:pPr>
-              <a:defRPr sz="1300">
+              <a:defRPr sz="1450">
                 <a:solidFill>
                   <a:srgbClr val="FFFFFF"/>
                 </a:solidFill>
@@ -16697,7 +16697,7 @@
           </a:p>
           <a:p>
             <a:pPr>
-              <a:defRPr sz="1300">
+              <a:defRPr sz="1450">
                 <a:solidFill>
                   <a:srgbClr val="94A3B8"/>
                 </a:solidFill>
@@ -16709,7 +16709,7 @@
           </a:p>
           <a:p>
             <a:pPr>
-              <a:defRPr sz="1300">
+              <a:defRPr sz="1450">
                 <a:solidFill>
                   <a:srgbClr val="FFFFFF"/>
                 </a:solidFill>
@@ -16721,7 +16721,7 @@
           </a:p>
           <a:p>
             <a:pPr>
-              <a:defRPr sz="1300">
+              <a:defRPr sz="1450">
                 <a:solidFill>
                   <a:srgbClr val="94A3B8"/>
                 </a:solidFill>
@@ -16733,7 +16733,7 @@
           </a:p>
           <a:p>
             <a:pPr>
-              <a:defRPr sz="1300">
+              <a:defRPr sz="1450">
                 <a:solidFill>
                   <a:srgbClr val="FFFFFF"/>
                 </a:solidFill>
@@ -16745,7 +16745,7 @@
           </a:p>
           <a:p>
             <a:pPr>
-              <a:defRPr sz="1300">
+              <a:defRPr sz="1450">
                 <a:solidFill>
                   <a:srgbClr val="94A3B8"/>
                 </a:solidFill>
@@ -16757,7 +16757,7 @@
           </a:p>
           <a:p>
             <a:pPr>
-              <a:defRPr sz="1300">
+              <a:defRPr sz="1450">
                 <a:solidFill>
                   <a:srgbClr val="FFFFFF"/>
                 </a:solidFill>
@@ -16769,7 +16769,7 @@
           </a:p>
           <a:p>
             <a:pPr>
-              <a:defRPr sz="1300">
+              <a:defRPr sz="1450">
                 <a:solidFill>
                   <a:srgbClr val="94A3B8"/>
                 </a:solidFill>
@@ -16804,7 +16804,7 @@
           <a:lstStyle/>
           <a:p>
             <a:r>
-              <a:rPr sz="850" b="1">
+              <a:rPr sz="950" b="1">
                 <a:solidFill>
                   <a:srgbClr val="3FD0E6"/>
                 </a:solidFill>
@@ -16813,7 +16813,7 @@
               <a:t>🎤 Renato Paschoal (4ª) / Fernando Barreto (5ª)   |   </a:t>
             </a:r>
             <a:r>
-              <a:rPr sz="850">
+              <a:rPr sz="900">
                 <a:solidFill>
                   <a:srgbClr val="94A3B8"/>
                 </a:solidFill>
@@ -16987,7 +16987,7 @@
           <a:lstStyle/>
           <a:p>
             <a:pPr>
-              <a:defRPr sz="1300">
+              <a:defRPr sz="1450">
                 <a:solidFill>
                   <a:srgbClr val="FFFFFF"/>
                 </a:solidFill>
@@ -16999,7 +16999,7 @@
           </a:p>
           <a:p>
             <a:pPr>
-              <a:defRPr sz="1300">
+              <a:defRPr sz="1450">
                 <a:solidFill>
                   <a:srgbClr val="94A3B8"/>
                 </a:solidFill>
@@ -17011,7 +17011,7 @@
           </a:p>
           <a:p>
             <a:pPr>
-              <a:defRPr sz="1300">
+              <a:defRPr sz="1450">
                 <a:solidFill>
                   <a:srgbClr val="FFFFFF"/>
                 </a:solidFill>
@@ -17023,7 +17023,7 @@
           </a:p>
           <a:p>
             <a:pPr>
-              <a:defRPr sz="1300">
+              <a:defRPr sz="1450">
                 <a:solidFill>
                   <a:srgbClr val="94A3B8"/>
                 </a:solidFill>
@@ -17035,7 +17035,7 @@
           </a:p>
           <a:p>
             <a:pPr>
-              <a:defRPr sz="1300">
+              <a:defRPr sz="1450">
                 <a:solidFill>
                   <a:srgbClr val="FFFFFF"/>
                 </a:solidFill>
@@ -17047,7 +17047,7 @@
           </a:p>
           <a:p>
             <a:pPr>
-              <a:defRPr sz="1300">
+              <a:defRPr sz="1450">
                 <a:solidFill>
                   <a:srgbClr val="94A3B8"/>
                 </a:solidFill>
@@ -17059,7 +17059,7 @@
           </a:p>
           <a:p>
             <a:pPr>
-              <a:defRPr sz="1300">
+              <a:defRPr sz="1450">
                 <a:solidFill>
                   <a:srgbClr val="FFFFFF"/>
                 </a:solidFill>
@@ -17071,7 +17071,7 @@
           </a:p>
           <a:p>
             <a:pPr>
-              <a:defRPr sz="1300">
+              <a:defRPr sz="1450">
                 <a:solidFill>
                   <a:srgbClr val="94A3B8"/>
                 </a:solidFill>
@@ -17106,7 +17106,7 @@
           <a:lstStyle/>
           <a:p>
             <a:r>
-              <a:rPr sz="850" b="1">
+              <a:rPr sz="950" b="1">
                 <a:solidFill>
                   <a:srgbClr val="3FD0E6"/>
                 </a:solidFill>
@@ -17115,7 +17115,7 @@
               <a:t>🎤 Grupo Inteiro (4ª e 5ª)   |   </a:t>
             </a:r>
             <a:r>
-              <a:rPr sz="850">
+              <a:rPr sz="900">
                 <a:solidFill>
                   <a:srgbClr val="94A3B8"/>
                 </a:solidFill>
@@ -17289,7 +17289,7 @@
           <a:lstStyle/>
           <a:p>
             <a:pPr>
-              <a:defRPr sz="1300">
+              <a:defRPr sz="1450">
                 <a:solidFill>
                   <a:srgbClr val="FFFFFF"/>
                 </a:solidFill>
@@ -17301,7 +17301,7 @@
           </a:p>
           <a:p>
             <a:pPr>
-              <a:defRPr sz="1300">
+              <a:defRPr sz="1450">
                 <a:solidFill>
                   <a:srgbClr val="94A3B8"/>
                 </a:solidFill>
@@ -17313,7 +17313,7 @@
           </a:p>
           <a:p>
             <a:pPr>
-              <a:defRPr sz="1300">
+              <a:defRPr sz="1450">
                 <a:solidFill>
                   <a:srgbClr val="FFFFFF"/>
                 </a:solidFill>
@@ -17325,7 +17325,7 @@
           </a:p>
           <a:p>
             <a:pPr>
-              <a:defRPr sz="1300">
+              <a:defRPr sz="1450">
                 <a:solidFill>
                   <a:srgbClr val="94A3B8"/>
                 </a:solidFill>
@@ -17337,7 +17337,7 @@
           </a:p>
           <a:p>
             <a:pPr>
-              <a:defRPr sz="1300">
+              <a:defRPr sz="1450">
                 <a:solidFill>
                   <a:srgbClr val="FFFFFF"/>
                 </a:solidFill>
@@ -17349,7 +17349,7 @@
           </a:p>
           <a:p>
             <a:pPr>
-              <a:defRPr sz="1300">
+              <a:defRPr sz="1450">
                 <a:solidFill>
                   <a:srgbClr val="94A3B8"/>
                 </a:solidFill>
@@ -17361,7 +17361,7 @@
           </a:p>
           <a:p>
             <a:pPr>
-              <a:defRPr sz="1300">
+              <a:defRPr sz="1450">
                 <a:solidFill>
                   <a:srgbClr val="FFFFFF"/>
                 </a:solidFill>
@@ -17373,7 +17373,7 @@
           </a:p>
           <a:p>
             <a:pPr>
-              <a:defRPr sz="1300">
+              <a:defRPr sz="1450">
                 <a:solidFill>
                   <a:srgbClr val="94A3B8"/>
                 </a:solidFill>
@@ -17408,7 +17408,7 @@
           <a:lstStyle/>
           <a:p>
             <a:r>
-              <a:rPr sz="850" b="1">
+              <a:rPr sz="950" b="1">
                 <a:solidFill>
                   <a:srgbClr val="3FD0E6"/>
                 </a:solidFill>
@@ -17417,7 +17417,7 @@
               <a:t>🎤 Nathalia Neves (4ª) / Fernando Barreto (5ª)   |   </a:t>
             </a:r>
             <a:r>
-              <a:rPr sz="850">
+              <a:rPr sz="900">
                 <a:solidFill>
                   <a:srgbClr val="94A3B8"/>
                 </a:solidFill>
@@ -17591,7 +17591,7 @@
           <a:lstStyle/>
           <a:p>
             <a:pPr>
-              <a:defRPr sz="1300">
+              <a:defRPr sz="1450">
                 <a:solidFill>
                   <a:srgbClr val="FFFFFF"/>
                 </a:solidFill>
@@ -17603,7 +17603,7 @@
           </a:p>
           <a:p>
             <a:pPr>
-              <a:defRPr sz="1300">
+              <a:defRPr sz="1450">
                 <a:solidFill>
                   <a:srgbClr val="94A3B8"/>
                 </a:solidFill>
@@ -17615,7 +17615,7 @@
           </a:p>
           <a:p>
             <a:pPr>
-              <a:defRPr sz="1300">
+              <a:defRPr sz="1450">
                 <a:solidFill>
                   <a:srgbClr val="FFFFFF"/>
                 </a:solidFill>
@@ -17627,7 +17627,7 @@
           </a:p>
           <a:p>
             <a:pPr>
-              <a:defRPr sz="1300">
+              <a:defRPr sz="1450">
                 <a:solidFill>
                   <a:srgbClr val="94A3B8"/>
                 </a:solidFill>
@@ -17639,7 +17639,7 @@
           </a:p>
           <a:p>
             <a:pPr>
-              <a:defRPr sz="1300">
+              <a:defRPr sz="1450">
                 <a:solidFill>
                   <a:srgbClr val="FFFFFF"/>
                 </a:solidFill>
@@ -17651,7 +17651,7 @@
           </a:p>
           <a:p>
             <a:pPr>
-              <a:defRPr sz="1300">
+              <a:defRPr sz="1450">
                 <a:solidFill>
                   <a:srgbClr val="94A3B8"/>
                 </a:solidFill>
@@ -17663,7 +17663,7 @@
           </a:p>
           <a:p>
             <a:pPr>
-              <a:defRPr sz="1300">
+              <a:defRPr sz="1450">
                 <a:solidFill>
                   <a:srgbClr val="FFFFFF"/>
                 </a:solidFill>
@@ -17675,7 +17675,7 @@
           </a:p>
           <a:p>
             <a:pPr>
-              <a:defRPr sz="1300">
+              <a:defRPr sz="1450">
                 <a:solidFill>
                   <a:srgbClr val="94A3B8"/>
                 </a:solidFill>
@@ -17710,7 +17710,7 @@
           <a:lstStyle/>
           <a:p>
             <a:r>
-              <a:rPr sz="850" b="1">
+              <a:rPr sz="950" b="1">
                 <a:solidFill>
                   <a:srgbClr val="3FD0E6"/>
                 </a:solidFill>
@@ -17719,7 +17719,7 @@
               <a:t>🎤 Nathalia Neves (4ª) / Fernando Barreto (5ª)   |   </a:t>
             </a:r>
             <a:r>
-              <a:rPr sz="850">
+              <a:rPr sz="900">
                 <a:solidFill>
                   <a:srgbClr val="94A3B8"/>
                 </a:solidFill>
@@ -17893,7 +17893,7 @@
           <a:lstStyle/>
           <a:p>
             <a:pPr>
-              <a:defRPr sz="1300">
+              <a:defRPr sz="1450">
                 <a:solidFill>
                   <a:srgbClr val="FFFFFF"/>
                 </a:solidFill>
@@ -17905,7 +17905,7 @@
           </a:p>
           <a:p>
             <a:pPr>
-              <a:defRPr sz="1300">
+              <a:defRPr sz="1450">
                 <a:solidFill>
                   <a:srgbClr val="94A3B8"/>
                 </a:solidFill>
@@ -17917,7 +17917,7 @@
           </a:p>
           <a:p>
             <a:pPr>
-              <a:defRPr sz="1300">
+              <a:defRPr sz="1450">
                 <a:solidFill>
                   <a:srgbClr val="FFFFFF"/>
                 </a:solidFill>
@@ -17929,7 +17929,7 @@
           </a:p>
           <a:p>
             <a:pPr>
-              <a:defRPr sz="1300">
+              <a:defRPr sz="1450">
                 <a:solidFill>
                   <a:srgbClr val="94A3B8"/>
                 </a:solidFill>
@@ -17941,7 +17941,7 @@
           </a:p>
           <a:p>
             <a:pPr>
-              <a:defRPr sz="1300">
+              <a:defRPr sz="1450">
                 <a:solidFill>
                   <a:srgbClr val="FFFFFF"/>
                 </a:solidFill>
@@ -17953,7 +17953,7 @@
           </a:p>
           <a:p>
             <a:pPr>
-              <a:defRPr sz="1300">
+              <a:defRPr sz="1450">
                 <a:solidFill>
                   <a:srgbClr val="94A3B8"/>
                 </a:solidFill>
@@ -17965,7 +17965,7 @@
           </a:p>
           <a:p>
             <a:pPr>
-              <a:defRPr sz="1300">
+              <a:defRPr sz="1450">
                 <a:solidFill>
                   <a:srgbClr val="FFFFFF"/>
                 </a:solidFill>
@@ -17977,7 +17977,7 @@
           </a:p>
           <a:p>
             <a:pPr>
-              <a:defRPr sz="1300">
+              <a:defRPr sz="1450">
                 <a:solidFill>
                   <a:srgbClr val="94A3B8"/>
                 </a:solidFill>
@@ -18012,7 +18012,7 @@
           <a:lstStyle/>
           <a:p>
             <a:r>
-              <a:rPr sz="850" b="1">
+              <a:rPr sz="950" b="1">
                 <a:solidFill>
                   <a:srgbClr val="3FD0E6"/>
                 </a:solidFill>
@@ -18021,7 +18021,7 @@
               <a:t>🎤 Nathalia Neves (4ª) / Fernando Barreto (5ª)   |   </a:t>
             </a:r>
             <a:r>
-              <a:rPr sz="850">
+              <a:rPr sz="900">
                 <a:solidFill>
                   <a:srgbClr val="94A3B8"/>
                 </a:solidFill>
@@ -18195,7 +18195,7 @@
           <a:lstStyle/>
           <a:p>
             <a:pPr>
-              <a:defRPr sz="1300">
+              <a:defRPr sz="1450">
                 <a:solidFill>
                   <a:srgbClr val="FFFFFF"/>
                 </a:solidFill>
@@ -18207,7 +18207,7 @@
           </a:p>
           <a:p>
             <a:pPr>
-              <a:defRPr sz="1300">
+              <a:defRPr sz="1450">
                 <a:solidFill>
                   <a:srgbClr val="94A3B8"/>
                 </a:solidFill>
@@ -18219,7 +18219,7 @@
           </a:p>
           <a:p>
             <a:pPr>
-              <a:defRPr sz="1300">
+              <a:defRPr sz="1450">
                 <a:solidFill>
                   <a:srgbClr val="FFFFFF"/>
                 </a:solidFill>
@@ -18231,7 +18231,7 @@
           </a:p>
           <a:p>
             <a:pPr>
-              <a:defRPr sz="1300">
+              <a:defRPr sz="1450">
                 <a:solidFill>
                   <a:srgbClr val="94A3B8"/>
                 </a:solidFill>
@@ -18243,7 +18243,7 @@
           </a:p>
           <a:p>
             <a:pPr>
-              <a:defRPr sz="1300">
+              <a:defRPr sz="1450">
                 <a:solidFill>
                   <a:srgbClr val="FFFFFF"/>
                 </a:solidFill>
@@ -18255,7 +18255,7 @@
           </a:p>
           <a:p>
             <a:pPr>
-              <a:defRPr sz="1300">
+              <a:defRPr sz="1450">
                 <a:solidFill>
                   <a:srgbClr val="94A3B8"/>
                 </a:solidFill>
@@ -18267,7 +18267,7 @@
           </a:p>
           <a:p>
             <a:pPr>
-              <a:defRPr sz="1300">
+              <a:defRPr sz="1450">
                 <a:solidFill>
                   <a:srgbClr val="FFFFFF"/>
                 </a:solidFill>
@@ -18279,7 +18279,7 @@
           </a:p>
           <a:p>
             <a:pPr>
-              <a:defRPr sz="1300">
+              <a:defRPr sz="1450">
                 <a:solidFill>
                   <a:srgbClr val="94A3B8"/>
                 </a:solidFill>
@@ -18314,7 +18314,7 @@
           <a:lstStyle/>
           <a:p>
             <a:r>
-              <a:rPr sz="850" b="1">
+              <a:rPr sz="950" b="1">
                 <a:solidFill>
                   <a:srgbClr val="3FD0E6"/>
                 </a:solidFill>
@@ -18323,7 +18323,7 @@
               <a:t>🎤 Veridiany Braga (4ª) / Fábio Lippi (5ª)   |   </a:t>
             </a:r>
             <a:r>
-              <a:rPr sz="850">
+              <a:rPr sz="900">
                 <a:solidFill>
                   <a:srgbClr val="94A3B8"/>
                 </a:solidFill>
@@ -18497,7 +18497,7 @@
           <a:lstStyle/>
           <a:p>
             <a:pPr>
-              <a:defRPr sz="1300">
+              <a:defRPr sz="1450">
                 <a:solidFill>
                   <a:srgbClr val="FFFFFF"/>
                 </a:solidFill>
@@ -18509,7 +18509,7 @@
           </a:p>
           <a:p>
             <a:pPr>
-              <a:defRPr sz="1300">
+              <a:defRPr sz="1450">
                 <a:solidFill>
                   <a:srgbClr val="94A3B8"/>
                 </a:solidFill>
@@ -18521,7 +18521,7 @@
           </a:p>
           <a:p>
             <a:pPr>
-              <a:defRPr sz="1300">
+              <a:defRPr sz="1450">
                 <a:solidFill>
                   <a:srgbClr val="FFFFFF"/>
                 </a:solidFill>
@@ -18533,7 +18533,7 @@
           </a:p>
           <a:p>
             <a:pPr>
-              <a:defRPr sz="1300">
+              <a:defRPr sz="1450">
                 <a:solidFill>
                   <a:srgbClr val="94A3B8"/>
                 </a:solidFill>
@@ -18545,7 +18545,7 @@
           </a:p>
           <a:p>
             <a:pPr>
-              <a:defRPr sz="1300">
+              <a:defRPr sz="1450">
                 <a:solidFill>
                   <a:srgbClr val="FFFFFF"/>
                 </a:solidFill>
@@ -18557,7 +18557,7 @@
           </a:p>
           <a:p>
             <a:pPr>
-              <a:defRPr sz="1300">
+              <a:defRPr sz="1450">
                 <a:solidFill>
                   <a:srgbClr val="94A3B8"/>
                 </a:solidFill>
@@ -18569,7 +18569,7 @@
           </a:p>
           <a:p>
             <a:pPr>
-              <a:defRPr sz="1300">
+              <a:defRPr sz="1450">
                 <a:solidFill>
                   <a:srgbClr val="FFFFFF"/>
                 </a:solidFill>
@@ -18581,7 +18581,7 @@
           </a:p>
           <a:p>
             <a:pPr>
-              <a:defRPr sz="1300">
+              <a:defRPr sz="1450">
                 <a:solidFill>
                   <a:srgbClr val="94A3B8"/>
                 </a:solidFill>
@@ -18616,7 +18616,7 @@
           <a:lstStyle/>
           <a:p>
             <a:r>
-              <a:rPr sz="850" b="1">
+              <a:rPr sz="950" b="1">
                 <a:solidFill>
                   <a:srgbClr val="3FD0E6"/>
                 </a:solidFill>
@@ -18625,7 +18625,7 @@
               <a:t>🎤 Veridiany Braga (4ª) / Fábio Lippi (5ª)   |   </a:t>
             </a:r>
             <a:r>
-              <a:rPr sz="850">
+              <a:rPr sz="900">
                 <a:solidFill>
                   <a:srgbClr val="94A3B8"/>
                 </a:solidFill>

</xml_diff>

<commit_message>
fix: align Thursday presenters rigorously (Abertura-B1: Fernando, B2: Fabio, B3-B4: Joel, B5-Sintese: Marciele, Encerramento: Grupo)
</commit_message>
<xml_diff>
--- a/Seminario_5_Ecossistemas_Inovacao_Master.pptx
+++ b/Seminario_5_Ecossistemas_Inovacao_Master.pptx
@@ -7295,7 +7295,7 @@
                 </a:solidFill>
                 <a:latin typeface="JetBrains Mono"/>
               </a:rPr>
-              <a:t>🎤 Josué Jofre (4ª) / Fernando Barreto (5ª)   |   </a:t>
+              <a:t>🎤 Josué Jofre (4ª) / Fernando (5ª)   |   </a:t>
             </a:r>
             <a:r>
               <a:rPr sz="900">
@@ -7597,7 +7597,7 @@
                 </a:solidFill>
                 <a:latin typeface="JetBrains Mono"/>
               </a:rPr>
-              <a:t>🎤 Veridiany Braga (4ª) / Fábio Lippi (5ª)   |   </a:t>
+              <a:t>🎤 Veridiany Braga (4ª) / Fábio (5ª)   |   </a:t>
             </a:r>
             <a:r>
               <a:rPr sz="900">
@@ -7899,7 +7899,7 @@
                 </a:solidFill>
                 <a:latin typeface="JetBrains Mono"/>
               </a:rPr>
-              <a:t>🎤 Veridiany Braga (4ª) / Fábio Lippi (5ª)   |   </a:t>
+              <a:t>🎤 Veridiany Braga (4ª) / Fábio (5ª)   |   </a:t>
             </a:r>
             <a:r>
               <a:rPr sz="900">
@@ -9739,7 +9739,7 @@
                 </a:solidFill>
                 <a:latin typeface="JetBrains Mono"/>
               </a:rPr>
-              <a:t>🎤 Nathalia Neves (4ª) / Fernando Barreto (5ª)   |   </a:t>
+              <a:t>🎤 Nathalia Neves (4ª) / Fernando (5ª)   |   </a:t>
             </a:r>
             <a:r>
               <a:rPr sz="900">
@@ -10041,7 +10041,7 @@
                 </a:solidFill>
                 <a:latin typeface="JetBrains Mono"/>
               </a:rPr>
-              <a:t>🎤 Josué Jofre (4ª) / Marciele Toledo (5ª)   |   </a:t>
+              <a:t>🎤 Josué Jofre (4ª) / Joel (5ª)   |   </a:t>
             </a:r>
             <a:r>
               <a:rPr sz="900">
@@ -10343,7 +10343,7 @@
                 </a:solidFill>
                 <a:latin typeface="JetBrains Mono"/>
               </a:rPr>
-              <a:t>🎤 Josué Jofre (4ª) / Marciele Toledo (5ª)   |   </a:t>
+              <a:t>🎤 Josué Jofre (4ª) / Joel (5ª)   |   </a:t>
             </a:r>
             <a:r>
               <a:rPr sz="900">
@@ -10645,7 +10645,7 @@
                 </a:solidFill>
                 <a:latin typeface="JetBrains Mono"/>
               </a:rPr>
-              <a:t>🎤 Josué Jofre (4ª) / Marciele Toledo (5ª)   |   </a:t>
+              <a:t>🎤 Josué Jofre (4ª) / Joel (5ª)   |   </a:t>
             </a:r>
             <a:r>
               <a:rPr sz="900">
@@ -10947,7 +10947,7 @@
                 </a:solidFill>
                 <a:latin typeface="JetBrains Mono"/>
               </a:rPr>
-              <a:t>🎤 Josué Jofre (4ª) / Marciele Toledo (5ª)   |   </a:t>
+              <a:t>🎤 Josué Jofre (4ª) / Joel (5ª)   |   </a:t>
             </a:r>
             <a:r>
               <a:rPr sz="900">
@@ -11235,7 +11235,7 @@
                 </a:solidFill>
                 <a:latin typeface="JetBrains Mono"/>
               </a:rPr>
-              <a:t>🎤 Lilian Veiga (4ª) / Marciele Toledo (5ª)   |   </a:t>
+              <a:t>🎤 Lilian Veiga (4ª) / Marciele (5ª)   |   </a:t>
             </a:r>
             <a:r>
               <a:rPr sz="900">
@@ -11545,7 +11545,7 @@
                 </a:solidFill>
                 <a:latin typeface="JetBrains Mono"/>
               </a:rPr>
-              <a:t>🎤 Lilian Veiga (4ª) / Marciele Toledo (5ª)   |   </a:t>
+              <a:t>🎤 Lilian Veiga (4ª) / Marciele (5ª)   |   </a:t>
             </a:r>
             <a:r>
               <a:rPr sz="900">
@@ -11708,7 +11708,7 @@
                 </a:solidFill>
                 <a:latin typeface="JetBrains Mono"/>
               </a:rPr>
-              <a:t>🎤 Lilian Veiga (4ª) / Marciele Toledo (5ª)   |   </a:t>
+              <a:t>🎤 Lilian Veiga (4ª) / Marciele (5ª)   |   </a:t>
             </a:r>
             <a:r>
               <a:rPr sz="900">
@@ -11871,7 +11871,7 @@
                 </a:solidFill>
                 <a:latin typeface="JetBrains Mono"/>
               </a:rPr>
-              <a:t>🎤 Lilian Veiga (4ª) / Marciele Toledo (5ª)   |   </a:t>
+              <a:t>🎤 Lilian Veiga (4ª) / Marciele (5ª)   |   </a:t>
             </a:r>
             <a:r>
               <a:rPr sz="900">
@@ -12034,7 +12034,7 @@
                 </a:solidFill>
                 <a:latin typeface="JetBrains Mono"/>
               </a:rPr>
-              <a:t>🎤 Lilian Veiga (4ª) / Marciele Toledo (5ª)   |   </a:t>
+              <a:t>🎤 Lilian Veiga (4ª) / Marciele (5ª)   |   </a:t>
             </a:r>
             <a:r>
               <a:rPr sz="900">
@@ -12197,7 +12197,7 @@
                 </a:solidFill>
                 <a:latin typeface="JetBrains Mono"/>
               </a:rPr>
-              <a:t>🎤 Lilian Veiga (4ª) / Marciele Toledo (5ª)   |   </a:t>
+              <a:t>🎤 Lilian Veiga (4ª) / Marciele (5ª)   |   </a:t>
             </a:r>
             <a:r>
               <a:rPr sz="900">
@@ -12499,7 +12499,7 @@
                 </a:solidFill>
                 <a:latin typeface="JetBrains Mono"/>
               </a:rPr>
-              <a:t>🎤 Josué Jofre (4ª) / Marciele Toledo (5ª)   |   </a:t>
+              <a:t>🎤 Josué Jofre (4ª) / Fernando (5ª)   |   </a:t>
             </a:r>
             <a:r>
               <a:rPr sz="900">
@@ -12662,7 +12662,7 @@
                 </a:solidFill>
                 <a:latin typeface="JetBrains Mono"/>
               </a:rPr>
-              <a:t>🎤 Lilian Veiga (4ª) / Marciele Toledo (5ª)   |   </a:t>
+              <a:t>🎤 Lilian Veiga (4ª) / Marciele (5ª)   |   </a:t>
             </a:r>
             <a:r>
               <a:rPr sz="900">
@@ -12825,7 +12825,7 @@
                 </a:solidFill>
                 <a:latin typeface="JetBrains Mono"/>
               </a:rPr>
-              <a:t>🎤 Lilian Veiga (4ª) / Marciele Toledo (5ª)   |   </a:t>
+              <a:t>🎤 Lilian Veiga (4ª) / Marciele (5ª)   |   </a:t>
             </a:r>
             <a:r>
               <a:rPr sz="900">
@@ -13488,7 +13488,7 @@
                 </a:solidFill>
                 <a:latin typeface="JetBrains Mono"/>
               </a:rPr>
-              <a:t>🎤 Lilian Veiga (4ª) / Marciele Toledo (5ª)   |   </a:t>
+              <a:t>🎤 Lilian Veiga (4ª) / Marciele (5ª)   |   </a:t>
             </a:r>
             <a:r>
               <a:rPr sz="900">
@@ -13790,7 +13790,7 @@
                 </a:solidFill>
                 <a:latin typeface="JetBrains Mono"/>
               </a:rPr>
-              <a:t>🎤 Lilian Veiga (4ª) / Marciele Toledo (5ª)   |   </a:t>
+              <a:t>🎤 Lilian Veiga (4ª) / Marciele (5ª)   |   </a:t>
             </a:r>
             <a:r>
               <a:rPr sz="900">
@@ -14092,7 +14092,7 @@
                 </a:solidFill>
                 <a:latin typeface="JetBrains Mono"/>
               </a:rPr>
-              <a:t>🎤 Josué Jofre (4ª) / Marciele Toledo (5ª)   |   </a:t>
+              <a:t>🎤 Josué Jofre (4ª) / Marciele (5ª)   |   </a:t>
             </a:r>
             <a:r>
               <a:rPr sz="900">
@@ -14394,7 +14394,7 @@
                 </a:solidFill>
                 <a:latin typeface="JetBrains Mono"/>
               </a:rPr>
-              <a:t>🎤 Renato Paschoal (4ª e 5ª)   |   </a:t>
+              <a:t>🎤 Renato Paschoal (4ª) / Marciele (5ª)   |   </a:t>
             </a:r>
             <a:r>
               <a:rPr sz="900">
@@ -14696,7 +14696,7 @@
                 </a:solidFill>
                 <a:latin typeface="JetBrains Mono"/>
               </a:rPr>
-              <a:t>🎤 Renato Paschoal (4ª e 5ª)   |   </a:t>
+              <a:t>🎤 Renato Paschoal (4ª) / Marciele (5ª)   |   </a:t>
             </a:r>
             <a:r>
               <a:rPr sz="900">
@@ -14998,7 +14998,7 @@
                 </a:solidFill>
                 <a:latin typeface="JetBrains Mono"/>
               </a:rPr>
-              <a:t>🎤 Renato Paschoal (4ª e 5ª)   |   </a:t>
+              <a:t>🎤 Renato Paschoal (4ª) / Marciele (5ª)   |   </a:t>
             </a:r>
             <a:r>
               <a:rPr sz="900">
@@ -15300,7 +15300,7 @@
                 </a:solidFill>
                 <a:latin typeface="JetBrains Mono"/>
               </a:rPr>
-              <a:t>🎤 Renato Paschoal (4ª e 5ª)   |   </a:t>
+              <a:t>🎤 Renato Paschoal (4ª) / Marciele (5ª)   |   </a:t>
             </a:r>
             <a:r>
               <a:rPr sz="900">
@@ -15602,7 +15602,7 @@
                 </a:solidFill>
                 <a:latin typeface="JetBrains Mono"/>
               </a:rPr>
-              <a:t>🎤 Renato Paschoal (4ª e 5ª)   |   </a:t>
+              <a:t>🎤 Renato Paschoal (4ª) / Marciele (5ª)   |   </a:t>
             </a:r>
             <a:r>
               <a:rPr sz="900">
@@ -15904,7 +15904,7 @@
                 </a:solidFill>
                 <a:latin typeface="JetBrains Mono"/>
               </a:rPr>
-              <a:t>🎤 Nathalia Neves (4ª) / Fernando Barreto (5ª)   |   </a:t>
+              <a:t>🎤 Nathalia Neves (4ª) / Fernando (5ª)   |   </a:t>
             </a:r>
             <a:r>
               <a:rPr sz="900">
@@ -16206,7 +16206,7 @@
                 </a:solidFill>
                 <a:latin typeface="JetBrains Mono"/>
               </a:rPr>
-              <a:t>🎤 Jéssica David (4ª) / Fernando Barreto (5ª)   |   </a:t>
+              <a:t>🎤 Jéssica David (4ª) / Marciele (5ª)   |   </a:t>
             </a:r>
             <a:r>
               <a:rPr sz="900">
@@ -16508,7 +16508,7 @@
                 </a:solidFill>
                 <a:latin typeface="JetBrains Mono"/>
               </a:rPr>
-              <a:t>🎤 Jéssica David (4ª) / Fernando Barreto (5ª)   |   </a:t>
+              <a:t>🎤 Jéssica David (4ª) / Marciele (5ª)   |   </a:t>
             </a:r>
             <a:r>
               <a:rPr sz="900">
@@ -16810,7 +16810,7 @@
                 </a:solidFill>
                 <a:latin typeface="JetBrains Mono"/>
               </a:rPr>
-              <a:t>🎤 Renato Paschoal (4ª) / Fernando Barreto (5ª)   |   </a:t>
+              <a:t>🎤 Renato Paschoal (4ª) / Marciele (5ª)   |   </a:t>
             </a:r>
             <a:r>
               <a:rPr sz="900">
@@ -17414,7 +17414,7 @@
                 </a:solidFill>
                 <a:latin typeface="JetBrains Mono"/>
               </a:rPr>
-              <a:t>🎤 Nathalia Neves (4ª) / Fernando Barreto (5ª)   |   </a:t>
+              <a:t>🎤 Nathalia Neves (4ª) / Fernando (5ª)   |   </a:t>
             </a:r>
             <a:r>
               <a:rPr sz="900">
@@ -17716,7 +17716,7 @@
                 </a:solidFill>
                 <a:latin typeface="JetBrains Mono"/>
               </a:rPr>
-              <a:t>🎤 Nathalia Neves (4ª) / Fernando Barreto (5ª)   |   </a:t>
+              <a:t>🎤 Nathalia Neves (4ª) / Fernando (5ª)   |   </a:t>
             </a:r>
             <a:r>
               <a:rPr sz="900">
@@ -18018,7 +18018,7 @@
                 </a:solidFill>
                 <a:latin typeface="JetBrains Mono"/>
               </a:rPr>
-              <a:t>🎤 Nathalia Neves (4ª) / Fernando Barreto (5ª)   |   </a:t>
+              <a:t>🎤 Nathalia Neves (4ª) / Fernando (5ª)   |   </a:t>
             </a:r>
             <a:r>
               <a:rPr sz="900">
@@ -18320,7 +18320,7 @@
                 </a:solidFill>
                 <a:latin typeface="JetBrains Mono"/>
               </a:rPr>
-              <a:t>🎤 Veridiany Braga (4ª) / Fábio Lippi (5ª)   |   </a:t>
+              <a:t>🎤 Veridiany Braga (4ª) / Fábio (5ª)   |   </a:t>
             </a:r>
             <a:r>
               <a:rPr sz="900">
@@ -18622,7 +18622,7 @@
                 </a:solidFill>
                 <a:latin typeface="JetBrains Mono"/>
               </a:rPr>
-              <a:t>🎤 Veridiany Braga (4ª) / Fábio Lippi (5ª)   |   </a:t>
+              <a:t>🎤 Veridiany Braga (4ª) / Fábio (5ª)   |   </a:t>
             </a:r>
             <a:r>
               <a:rPr sz="900">

</xml_diff>